<commit_message>
feat(presentation): regenerate presentation using generate-slides skill guidelines
</commit_message>
<xml_diff>
--- a/docs/medquad_capstone_presentation.pptx
+++ b/docs/medquad_capstone_presentation.pptx
@@ -9,6 +9,7 @@
     <p:sldId id="257" r:id="rId9"/>
     <p:sldId id="258" r:id="rId10"/>
     <p:sldId id="259" r:id="rId11"/>
+    <p:sldId id="260" r:id="rId12"/>
   </p:sldIdLst>
   <p:sldSz cx="12191695" cy="6858000" type="screen4x3"/>
   <p:notesSz cx="6858000" cy="9144000"/>
@@ -505,31 +506,19 @@
           <a:lstStyle/>
           <a:p>
             <a:r>
-              <a:t>Slide 1 outlines the core problem we set out to solve.</a:t>
+              <a:t>Good morning. Today I am presenting the MedQuAD Clinical Research Assistant for my Field Delivery Engineer capstone evaluation.</a:t>
             </a:r>
           </a:p>
           <a:p/>
           <a:p>
             <a:r>
-              <a:t>In healthcare, researchers and clinicians face two distinct failure modes when answering clinical questions:</a:t>
+              <a:t>This system addresses the challenge of clinical literature discovery by combining Google Cloud's Agent Development Kit with Vertex AI Search and deterministic guardrails.</a:t>
             </a:r>
           </a:p>
           <a:p/>
           <a:p>
             <a:r>
-              <a:t>First, manual retrieval is inefficient. Researchers spend more than a third of their time combing through disparate NIH databases, guidelines, and trial registries. A single literature review can easily take 15 minutes of manual labor.</a:t>
-            </a:r>
-          </a:p>
-          <a:p/>
-          <a:p>
-            <a:r>
-              <a:t>Second, simply handing the problem to a generic LLM introduces severe clinical risk. Foundation models hallucinate citations roughly 18% of the time, and unprompted, they will attempt to diagnose or recommend prescriptions, exposing the institution to malpractice liability.</a:t>
-            </a:r>
-          </a:p>
-          <a:p/>
-          <a:p>
-            <a:r>
-              <a:t>The goal of this project is to bridge this gap: automate literature synthesis while guaranteeing 100% citation grounding and enforcing strict clinical guardrails.</a:t>
+              <a:t>This presentation covers: the clinical problem, our product capabilities, the end-to-end multi-agent architecture, and our future engineering roadmap.</a:t>
             </a:r>
           </a:p>
         </p:txBody>
@@ -599,39 +588,30 @@
           <a:lstStyle/>
           <a:p>
             <a:r>
-              <a:t>Slide 2 describes the product and what it actually does.</a:t>
+              <a:t>Slide 2 establishes the core problem.</a:t>
             </a:r>
           </a:p>
           <a:p/>
           <a:p>
             <a:r>
-              <a:t>The MedQuAD Clinical Assistant is a specialized research tool built on top of 16,400+ authoritative NIH medical records.</a:t>
+              <a:t>Clinical researchers face two competing challenges:</a:t>
+            </a:r>
+          </a:p>
+          <a:p>
+            <a:r>
+              <a:t>First, manual research takes too long. Combing through NIH databases, clinical trials, and FDA inserts consumes over 35% of a researcher's time, averaging 15 minutes per query.</a:t>
             </a:r>
           </a:p>
           <a:p/>
           <a:p>
             <a:r>
-              <a:t>Here are its four defining technical characteristics:</a:t>
-            </a:r>
-          </a:p>
-          <a:p>
-            <a:r>
-              <a:t>1. Authoritative Grounding: We chunked and indexed NIH, NCI, and MedlinePlus data using 500-token semantic chunks in Vertex AI Search.</a:t>
-            </a:r>
-          </a:p>
-          <a:p>
-            <a:r>
-              <a:t>2. Deterministic Verification: Rather than trusting the model to cite accurately, a dedicated Reviewer subagent cross-examines the draft against retrieved chunk IDs. We enforce 100% citation provenance.</a:t>
-            </a:r>
-          </a:p>
-          <a:p>
-            <a:r>
-              <a:t>3. Layer 8 Guardrails: If a user asks for a personal diagnosis or a prescription dose, our Safe Refusal Engine catches it in under 5 milliseconds and responds with a clinical disclaimer, invoking zero LLM tokens.</a:t>
-            </a:r>
-          </a:p>
-          <a:p>
-            <a:r>
-              <a:t>4. Practical FinOps: We tiered Gemini models so that routing and review run on lightweight Flash models, reserving Gemini Pro strictly for multi-document synthesis. This brings the total blended cost down to $0.0035 per query.</a:t>
+              <a:t>Second, relying on standard LLMs is dangerous in clinical contexts. Studies show foundation models hallucinate citations roughly 18% of the time, and unguarded models attempt to offer personal medical advice, creating unacceptable legal risk.</a:t>
+            </a:r>
+          </a:p>
+          <a:p/>
+          <a:p>
+            <a:r>
+              <a:t>The MedQuAD Assistant bridges this divide by delivering automated literature synthesis with strict 1:1 citation proof and deterministic safety boundaries.</a:t>
             </a:r>
           </a:p>
         </p:txBody>
@@ -701,37 +681,31 @@
           <a:lstStyle/>
           <a:p>
             <a:r>
-              <a:t>Slide 3 walks through our multi-agent architecture and request lifecycle.</a:t>
+              <a:t>Slide 3 outlines what the product actually does and how it operates.</a:t>
             </a:r>
           </a:p>
           <a:p/>
           <a:p>
             <a:r>
-              <a:t>1. Ingress &amp; Security: Requests enter via Cloud Armor and FastAPI on Cloud Run. Before touching any LLM, our Model Armor engine strips 18 HIPAA Safe Harbor identifiers and filters jailbreak patterns.</a:t>
+              <a:t>1. Authoritative Grounding: We indexed 16,400+ verified NIH pairs into Vertex AI Search with 500-token semantic chunks.</a:t>
             </a:r>
           </a:p>
           <a:p/>
           <a:p>
             <a:r>
-              <a:t>2. Orchestration: The Root Orchestrator (Gemini 2.5 Flash) assesses the request. If the user asks for diagnosis or prescriptions, the Safe Refusal Engine catches it in under 5ms. If it's a valid clinical inquiry, it delegates to the Researcher.</a:t>
+              <a:t>2. Deterministic Verification: Rather than hoping the model doesn't hallucinate, an independent Reviewer agent verifies every bracketed citation against the retrieved chunks, achieving 100% citation precision.</a:t>
             </a:r>
           </a:p>
           <a:p/>
           <a:p>
             <a:r>
-              <a:t>3. Research: The Clinical Researcher (Gemini 2.5 Pro) retrieves passages from Vertex AI Search and drafts a synthesis with inline citation brackets.</a:t>
+              <a:t>3. Safe Refusal Engine: If a user enters diagnostic or dosing questions, our boundary engine catches it in under 5ms, returning a clinical disclaimer with zero token waste.</a:t>
             </a:r>
           </a:p>
           <a:p/>
           <a:p>
             <a:r>
-              <a:t>4. Review: Crucially, that draft is sent to an independent Reviewer subagent (Gemini 3.5 Flash) with zero shared state. The CitationVerifier validates each citation against the retrieved chunks. If valid, it is streamed to the user.</a:t>
-            </a:r>
-          </a:p>
-          <a:p/>
-          <a:p>
-            <a:r>
-              <a:t>5. Telemetry: Every span is traced to Google Cloud Trace, and telemetry metrics (latency, token usage, cost) are streamed into BigQuery.</a:t>
+              <a:t>4. Cost Efficiency: By tiering Gemini models, we keep inference costs to just $0.0035 per query, running serverless on Cloud Run.</a:t>
             </a:r>
           </a:p>
         </p:txBody>
@@ -801,31 +775,125 @@
           <a:lstStyle/>
           <a:p>
             <a:r>
-              <a:t>Slide 4 covers our planned technical roadmap and next engineering steps.</a:t>
+              <a:t>Slide 4 walks through the technical architecture and request lifecycle:</a:t>
             </a:r>
           </a:p>
           <a:p/>
           <a:p>
             <a:r>
-              <a:t>Now that the core grounded literature engine and multi-agent verification are verified, we have four logical milestones:</a:t>
+              <a:t>1. Ingress &amp; Security: Requests enter via Cloud Armor and FastAPI on Cloud Run. Before touching any model, Model Armor redacts 18 HIPAA Safe Harbor identifiers and filters jailbreak patterns.</a:t>
             </a:r>
           </a:p>
           <a:p/>
           <a:p>
             <a:r>
-              <a:t>1. EHR Integration: Utilizing the Google Cloud Healthcare API to ingest de-identified FHIR R4 records, allowing researchers to evaluate literature directly in the context of patient cohorts.</a:t>
+              <a:t>2. Orchestration: The Root Orchestrator (Gemini 2.5 Flash) assesses the query. If it asks for diagnosis or prescriptions, the Safe Refusal Engine catches it in under 5ms. If valid, it delegates to the Researcher.</a:t>
             </a:r>
           </a:p>
           <a:p/>
           <a:p>
             <a:r>
-              <a:t>2. Persistent Storage: Migrating from local in-memory session cache to multi-region Firestore, ensuring research threads survive container restarts.</a:t>
+              <a:t>3. Research: The Clinical Researcher (Gemini 2.5 Pro) retrieves passages from Vertex AI Search and synthesizes a draft with explicit citations.</a:t>
             </a:r>
           </a:p>
           <a:p/>
           <a:p>
             <a:r>
-              <a:t>3. Multimodal RAG: Leveraging Gemini's native multimodal capabilities to analyze DICOM radiology scans alongside literature guidelines.</a:t>
+              <a:t>4. Review: The draft is reviewed by an independent Reviewer subagent (Gemini 3.5 Flash) with zero shared state. The CitationVerifier validates every citation against retrieved chunk IDs before release.</a:t>
+            </a:r>
+          </a:p>
+          <a:p/>
+          <a:p>
+            <a:r>
+              <a:t>5. Telemetry: Traces are pushed to Cloud Trace, and telemetry data (latency, cost, tokens) is streamed to BigQuery.</a:t>
+            </a:r>
+          </a:p>
+        </p:txBody>
+      </p:sp>
+      <p:sp>
+        <p:nvSpPr>
+          <p:cNvPr id="4" name="Slide Number Placeholder 3"/>
+          <p:cNvSpPr>
+            <a:spLocks noGrp="1"/>
+          </p:cNvSpPr>
+          <p:nvPr>
+            <p:ph type="sldNum" idx="5" sz="quarter"/>
+          </p:nvPr>
+        </p:nvSpPr>
+        <p:spPr/>
+      </p:sp>
+    </p:spTree>
+  </p:cSld>
+  <p:clrMapOvr>
+    <a:masterClrMapping/>
+  </p:clrMapOvr>
+</p:notes>
+</file>
+
+<file path=ppt/notesSlides/notesSlide5.xml><?xml version="1.0" encoding="utf-8"?>
+<p:notes xmlns:a="http://schemas.openxmlformats.org/drawingml/2006/main" xmlns:p="http://schemas.openxmlformats.org/presentationml/2006/main" xmlns:r="http://schemas.openxmlformats.org/officeDocument/2006/relationships">
+  <p:cSld>
+    <p:spTree>
+      <p:nvGrpSpPr>
+        <p:cNvPr id="1" name=""/>
+        <p:cNvGrpSpPr/>
+        <p:nvPr/>
+      </p:nvGrpSpPr>
+      <p:grpSpPr>
+        <a:xfrm>
+          <a:off x="0" y="0"/>
+          <a:ext cx="0" cy="0"/>
+          <a:chOff x="0" y="0"/>
+          <a:chExt cx="0" cy="0"/>
+        </a:xfrm>
+      </p:grpSpPr>
+      <p:sp>
+        <p:nvSpPr>
+          <p:cNvPr id="2" name="Slide Image Placeholder 1"/>
+          <p:cNvSpPr>
+            <a:spLocks noGrp="1"/>
+          </p:cNvSpPr>
+          <p:nvPr>
+            <p:ph type="sldImg" idx="2"/>
+          </p:nvPr>
+        </p:nvSpPr>
+        <p:spPr/>
+      </p:sp>
+      <p:sp>
+        <p:nvSpPr>
+          <p:cNvPr id="3" name="Notes Placeholder 2"/>
+          <p:cNvSpPr>
+            <a:spLocks noGrp="1"/>
+          </p:cNvSpPr>
+          <p:nvPr>
+            <p:ph type="body" idx="3" sz="quarter"/>
+          </p:nvPr>
+        </p:nvSpPr>
+        <p:spPr/>
+        <p:txBody>
+          <a:bodyPr/>
+          <a:lstStyle/>
+          <a:p>
+            <a:r>
+              <a:t>Slide 5 outlines our concrete next engineering milestones:</a:t>
+            </a:r>
+          </a:p>
+          <a:p/>
+          <a:p>
+            <a:r>
+              <a:t>1. EHR Integration: Using the Google Cloud Healthcare API to ingest de-identified FHIR R4 records, allowing researchers to contextualize literature findings against patient cohort criteria.</a:t>
+            </a:r>
+          </a:p>
+          <a:p/>
+          <a:p>
+            <a:r>
+              <a:t>2. State Persistence: Migrating from local in-memory session cache to distributed Firestore, ensuring research threads survive container restarts across regions.</a:t>
+            </a:r>
+          </a:p>
+          <a:p/>
+          <a:p>
+            <a:r>
+              <a:t>3. Multimodal RAG: Leveraging Gemini's multimodal capabilities to analyze DICOM radiology scans alongside literature guidelines.</a:t>
             </a:r>
           </a:p>
           <a:p/>
@@ -3833,7 +3901,7 @@
     <p:bg>
       <p:bgPr>
         <a:solidFill>
-          <a:srgbClr val="FFFFFF"/>
+          <a:srgbClr val="F8F9FA"/>
         </a:solidFill>
         <a:effectLst/>
       </p:bgPr>
@@ -3853,8 +3921,8 @@
         </p:nvSpPr>
         <p:spPr>
           <a:xfrm>
-            <a:off x="731520" y="457200"/>
-            <a:ext cx="10698480" cy="822960"/>
+            <a:off x="1097280" y="1920240"/>
+            <a:ext cx="9966960" cy="2926080"/>
           </a:xfrm>
           <a:prstGeom prst="rect">
             <a:avLst/>
@@ -3868,7 +3936,23 @@
           <a:lstStyle/>
           <a:p>
             <a:pPr>
-              <a:defRPr sz="2400" b="1">
+              <a:defRPr sz="1200" b="1">
+                <a:solidFill>
+                  <a:srgbClr val="1A73E8"/>
+                </a:solidFill>
+                <a:latin typeface="Arial"/>
+              </a:defRPr>
+            </a:pPr>
+            <a:r>
+              <a:t>FIELD DELIVERY ENGINEER (FDE) CAPSTONE PRESENTATION</a:t>
+            </a:r>
+          </a:p>
+          <a:p>
+            <a:pPr>
+              <a:spcBef>
+                <a:spcPts val="800"/>
+              </a:spcBef>
+              <a:defRPr sz="3800" b="1">
                 <a:solidFill>
                   <a:srgbClr val="202124"/>
                 </a:solidFill>
@@ -3876,12 +3960,15 @@
               </a:defRPr>
             </a:pPr>
             <a:r>
-              <a:t>Problem: Clinical Literature Retrieval &amp; Hallucination Risks</a:t>
+              <a:t>MedQuAD Clinical Research Assistant</a:t>
             </a:r>
           </a:p>
           <a:p>
             <a:pPr>
-              <a:defRPr sz="1200">
+              <a:spcBef>
+                <a:spcPts val="800"/>
+              </a:spcBef>
+              <a:defRPr sz="1800">
                 <a:solidFill>
                   <a:srgbClr val="5F6368"/>
                 </a:solidFill>
@@ -3889,7 +3976,7 @@
               </a:defRPr>
             </a:pPr>
             <a:r>
-              <a:t>MedQuAD Clinical Research Assistant  |  Capstone Evaluation</a:t>
+              <a:t>Multi-Agent Grounded Literature Synthesis &amp; Clinical Guardrails</a:t>
             </a:r>
           </a:p>
         </p:txBody>
@@ -3902,8 +3989,171 @@
         </p:nvSpPr>
         <p:spPr>
           <a:xfrm>
-            <a:off x="731520" y="1280160"/>
-            <a:ext cx="10728655" cy="18288"/>
+            <a:off x="1097280" y="4114800"/>
+            <a:ext cx="2926080" cy="27432"/>
+          </a:xfrm>
+          <a:prstGeom prst="rect">
+            <a:avLst/>
+          </a:prstGeom>
+          <a:solidFill>
+            <a:srgbClr val="1A73E8"/>
+          </a:solidFill>
+          <a:ln>
+            <a:solidFill>
+              <a:srgbClr val="1A73E8"/>
+            </a:solidFill>
+          </a:ln>
+        </p:spPr>
+        <p:style>
+          <a:lnRef idx="1">
+            <a:schemeClr val="accent1"/>
+          </a:lnRef>
+          <a:fillRef idx="3">
+            <a:schemeClr val="accent1"/>
+          </a:fillRef>
+          <a:effectRef idx="2">
+            <a:schemeClr val="accent1"/>
+          </a:effectRef>
+          <a:fontRef idx="minor">
+            <a:schemeClr val="lt1"/>
+          </a:fontRef>
+        </p:style>
+        <p:txBody>
+          <a:bodyPr rtlCol="0" anchor="ctr"/>
+          <a:lstStyle/>
+          <a:p>
+            <a:pPr algn="ctr"/>
+          </a:p>
+        </p:txBody>
+      </p:sp>
+      <p:sp>
+        <p:nvSpPr>
+          <p:cNvPr id="4" name="TextBox 3"/>
+          <p:cNvSpPr txBox="1"/>
+          <p:nvPr/>
+        </p:nvSpPr>
+        <p:spPr>
+          <a:xfrm>
+            <a:off x="1097280" y="4343400"/>
+            <a:ext cx="9966960" cy="914400"/>
+          </a:xfrm>
+          <a:prstGeom prst="rect">
+            <a:avLst/>
+          </a:prstGeom>
+          <a:noFill/>
+        </p:spPr>
+        <p:txBody>
+          <a:bodyPr wrap="square" lIns="0" tIns="0" rIns="0" bIns="0">
+            <a:spAutoFit/>
+          </a:bodyPr>
+          <a:lstStyle/>
+          <a:p>
+            <a:pPr>
+              <a:defRPr sz="1100">
+                <a:solidFill>
+                  <a:srgbClr val="5F6368"/>
+                </a:solidFill>
+                <a:latin typeface="Arial"/>
+              </a:defRPr>
+            </a:pPr>
+            <a:r>
+              <a:t>Candidate: Asad Patel  |  Target Role: Field Delivery Engineer (FDE)</a:t>
+            </a:r>
+            <a:br/>
+            <a:r>
+              <a:t>Platform: Google Cloud (Vertex AI Search, Cloud Run, ADK, Gemini 2.5/3.5)</a:t>
+            </a:r>
+          </a:p>
+        </p:txBody>
+      </p:sp>
+    </p:spTree>
+  </p:cSld>
+  <p:clrMapOvr>
+    <a:masterClrMapping/>
+  </p:clrMapOvr>
+</p:sld>
+</file>
+
+<file path=ppt/slides/slide2.xml><?xml version="1.0" encoding="utf-8"?>
+<p:sld xmlns:a="http://schemas.openxmlformats.org/drawingml/2006/main" xmlns:p="http://schemas.openxmlformats.org/presentationml/2006/main" xmlns:r="http://schemas.openxmlformats.org/officeDocument/2006/relationships">
+  <p:cSld>
+    <p:bg>
+      <p:bgPr>
+        <a:solidFill>
+          <a:srgbClr val="F8F9FA"/>
+        </a:solidFill>
+        <a:effectLst/>
+      </p:bgPr>
+    </p:bg>
+    <p:spTree>
+      <p:nvGrpSpPr>
+        <p:cNvPr id="1" name=""/>
+        <p:cNvGrpSpPr/>
+        <p:nvPr/>
+      </p:nvGrpSpPr>
+      <p:grpSpPr/>
+      <p:sp>
+        <p:nvSpPr>
+          <p:cNvPr id="2" name="TextBox 1"/>
+          <p:cNvSpPr txBox="1"/>
+          <p:nvPr/>
+        </p:nvSpPr>
+        <p:spPr>
+          <a:xfrm>
+            <a:off x="731520" y="502920"/>
+            <a:ext cx="10728655" cy="1005840"/>
+          </a:xfrm>
+          <a:prstGeom prst="rect">
+            <a:avLst/>
+          </a:prstGeom>
+          <a:noFill/>
+        </p:spPr>
+        <p:txBody>
+          <a:bodyPr wrap="square" lIns="0" tIns="0" rIns="0" bIns="0">
+            <a:spAutoFit/>
+          </a:bodyPr>
+          <a:lstStyle/>
+          <a:p>
+            <a:pPr>
+              <a:defRPr sz="1100" b="1">
+                <a:solidFill>
+                  <a:srgbClr val="1A73E8"/>
+                </a:solidFill>
+                <a:latin typeface="Arial"/>
+              </a:defRPr>
+            </a:pPr>
+            <a:r>
+              <a:t>PROBLEM DEFINITION</a:t>
+            </a:r>
+          </a:p>
+          <a:p>
+            <a:pPr>
+              <a:spcBef>
+                <a:spcPts val="400"/>
+              </a:spcBef>
+              <a:defRPr sz="2200" b="1">
+                <a:solidFill>
+                  <a:srgbClr val="202124"/>
+                </a:solidFill>
+                <a:latin typeface="Arial"/>
+              </a:defRPr>
+            </a:pPr>
+            <a:r>
+              <a:t>Clinical Search Suffers from High Manual Overhead and Unsafe Model Hallucinations</a:t>
+            </a:r>
+          </a:p>
+        </p:txBody>
+      </p:sp>
+      <p:sp>
+        <p:nvSpPr>
+          <p:cNvPr id="3" name="Rectangle 2"/>
+          <p:cNvSpPr/>
+          <p:nvPr/>
+        </p:nvSpPr>
+        <p:spPr>
+          <a:xfrm>
+            <a:off x="731520" y="1554480"/>
+            <a:ext cx="10728655" cy="13716"/>
           </a:xfrm>
           <a:prstGeom prst="rect">
             <a:avLst/>
@@ -3947,14 +4197,14 @@
         </p:nvSpPr>
         <p:spPr>
           <a:xfrm>
-            <a:off x="731520" y="1554480"/>
-            <a:ext cx="5212080" cy="4572000"/>
+            <a:off x="731520" y="1737360"/>
+            <a:ext cx="5212080" cy="4389120"/>
           </a:xfrm>
           <a:prstGeom prst="roundRect">
             <a:avLst/>
           </a:prstGeom>
           <a:solidFill>
-            <a:srgbClr val="F8F9FA"/>
+            <a:srgbClr val="FFFFFF"/>
           </a:solidFill>
           <a:ln w="12700">
             <a:solidFill>
@@ -3989,7 +4239,7 @@
               </a:defRPr>
             </a:pPr>
             <a:r>
-              <a:t>1. Manual Literature Synthesis Overhead</a:t>
+              <a:t>1. Manual Literature Synthesis Friction</a:t>
             </a:r>
           </a:p>
           <a:p>
@@ -3997,7 +4247,7 @@
               <a:spcBef>
                 <a:spcPts val="600"/>
               </a:spcBef>
-              <a:defRPr sz="1100">
+              <a:defRPr sz="1050">
                 <a:solidFill>
                   <a:srgbClr val="202124"/>
                 </a:solidFill>
@@ -4005,7 +4255,7 @@
               </a:defRPr>
             </a:pPr>
             <a:r>
-              <a:t>•  Clinicians and researchers spend over 35% of their research time searching disparate medical databases (NIH, NCI, CDC, PubMed).</a:t>
+              <a:t>•  Clinicians and researchers spend over 35% of working hours manually combing through fragmented medical databases (NIH, NCI, CDC, PubMed).</a:t>
             </a:r>
           </a:p>
           <a:p>
@@ -4013,7 +4263,7 @@
               <a:spcBef>
                 <a:spcPts val="600"/>
               </a:spcBef>
-              <a:defRPr sz="1100">
+              <a:defRPr sz="1050">
                 <a:solidFill>
                   <a:srgbClr val="202124"/>
                 </a:solidFill>
@@ -4021,7 +4271,7 @@
               </a:defRPr>
             </a:pPr>
             <a:r>
-              <a:t>•  Manual collation of staging criteria, treatment protocols, and adverse reactions is slow and error-prone.</a:t>
+              <a:t>•  Synthesizing an authoritative answer for staging criteria, treatment protocols, or adverse reactions takes ~15 minutes of specialized labor.</a:t>
             </a:r>
           </a:p>
           <a:p>
@@ -4029,7 +4279,7 @@
               <a:spcBef>
                 <a:spcPts val="600"/>
               </a:spcBef>
-              <a:defRPr sz="1100">
+              <a:defRPr sz="1050">
                 <a:solidFill>
                   <a:srgbClr val="202124"/>
                 </a:solidFill>
@@ -4037,7 +4287,7 @@
               </a:defRPr>
             </a:pPr>
             <a:r>
-              <a:t>•  Synthesizing an authoritative answer to a complex clinical question takes an average of 15 minutes of specialized clinician time.</a:t>
+              <a:t>•  High research friction directly delays clinical trial design, literature review updates, and research grant submissions.</a:t>
             </a:r>
           </a:p>
           <a:p>
@@ -4045,7 +4295,7 @@
               <a:spcBef>
                 <a:spcPts val="600"/>
               </a:spcBef>
-              <a:defRPr sz="1100">
+              <a:defRPr sz="1050">
                 <a:solidFill>
                   <a:srgbClr val="202124"/>
                 </a:solidFill>
@@ -4053,7 +4303,7 @@
               </a:defRPr>
             </a:pPr>
             <a:r>
-              <a:t>•  Information is fragmented across thousands of static XML and PDF files without unified semantic indexing.</a:t>
+              <a:t>•  Knowledge remains locked in static, disconnected XML repositories without centralized semantic search capability.</a:t>
             </a:r>
           </a:p>
         </p:txBody>
@@ -4066,14 +4316,14 @@
         </p:nvSpPr>
         <p:spPr>
           <a:xfrm>
-            <a:off x="6217920" y="1554480"/>
-            <a:ext cx="5212080" cy="4572000"/>
+            <a:off x="6217920" y="1737360"/>
+            <a:ext cx="5212080" cy="4389120"/>
           </a:xfrm>
           <a:prstGeom prst="roundRect">
             <a:avLst/>
           </a:prstGeom>
           <a:solidFill>
-            <a:srgbClr val="F8F9FA"/>
+            <a:srgbClr val="FFFFFF"/>
           </a:solidFill>
           <a:ln w="12700">
             <a:solidFill>
@@ -4108,7 +4358,7 @@
               </a:defRPr>
             </a:pPr>
             <a:r>
-              <a:t>2. LLM Hallucinations &amp; Clinical Liability</a:t>
+              <a:t>2. Foundation Model Hallucinations &amp; Liability</a:t>
             </a:r>
           </a:p>
           <a:p>
@@ -4116,7 +4366,7 @@
               <a:spcBef>
                 <a:spcPts val="600"/>
               </a:spcBef>
-              <a:defRPr sz="1100">
+              <a:defRPr sz="1050">
                 <a:solidFill>
                   <a:srgbClr val="202124"/>
                 </a:solidFill>
@@ -4124,7 +4374,7 @@
               </a:defRPr>
             </a:pPr>
             <a:r>
-              <a:t>•  Standard off-the-shelf foundation models exhibit an ~18% citation hallucination rate on biomedical literature queries.</a:t>
+              <a:t>•  Standard off-the-shelf LLMs exhibit an ~18% citation error and hallucination rate on medical literature queries.</a:t>
             </a:r>
           </a:p>
           <a:p>
@@ -4132,7 +4382,7 @@
               <a:spcBef>
                 <a:spcPts val="600"/>
               </a:spcBef>
-              <a:defRPr sz="1100">
+              <a:defRPr sz="1050">
                 <a:solidFill>
                   <a:srgbClr val="202124"/>
                 </a:solidFill>
@@ -4140,7 +4390,7 @@
               </a:defRPr>
             </a:pPr>
             <a:r>
-              <a:t>•  Commercial chatbots generate plausible-sounding but fictitious medical claims, fabricated journal links, and obsolete dosing advice.</a:t>
+              <a:t>•  Generic models fabricate plausible clinical claims, non-existent PMIDs, and outdated pharmaceutical dosing guidelines.</a:t>
             </a:r>
           </a:p>
           <a:p>
@@ -4148,7 +4398,7 @@
               <a:spcBef>
                 <a:spcPts val="600"/>
               </a:spcBef>
-              <a:defRPr sz="1100">
+              <a:defRPr sz="1050">
                 <a:solidFill>
                   <a:srgbClr val="202124"/>
                 </a:solidFill>
@@ -4156,7 +4406,7 @@
               </a:defRPr>
             </a:pPr>
             <a:r>
-              <a:t>•  Unguarded models attempt to diagnose conditions or recommend drug doses from user prompts, creating severe medical liability.</a:t>
+              <a:t>•  Unguarded models attempt to answer personal diagnosis and prescription questions, creating severe malpractice liability.</a:t>
             </a:r>
           </a:p>
           <a:p>
@@ -4164,7 +4414,7 @@
               <a:spcBef>
                 <a:spcPts val="600"/>
               </a:spcBef>
-              <a:defRPr sz="1100">
+              <a:defRPr sz="1050">
                 <a:solidFill>
                   <a:srgbClr val="202124"/>
                 </a:solidFill>
@@ -4172,7 +4422,7 @@
               </a:defRPr>
             </a:pPr>
             <a:r>
-              <a:t>•  Off-the-shelf models lack a verifiable 1-to-1 provenance mechanism connecting each statement back to an authoritative medical chunk.</a:t>
+              <a:t>•  Commercial consumer chatbots lack deterministic 1:1 chunk verification to prove evidence provenance.</a:t>
             </a:r>
           </a:p>
         </p:txBody>
@@ -4185,13 +4435,13 @@
 </p:sld>
 </file>
 
-<file path=ppt/slides/slide2.xml><?xml version="1.0" encoding="utf-8"?>
+<file path=ppt/slides/slide3.xml><?xml version="1.0" encoding="utf-8"?>
 <p:sld xmlns:a="http://schemas.openxmlformats.org/drawingml/2006/main" xmlns:p="http://schemas.openxmlformats.org/presentationml/2006/main" xmlns:r="http://schemas.openxmlformats.org/officeDocument/2006/relationships">
   <p:cSld>
     <p:bg>
       <p:bgPr>
         <a:solidFill>
-          <a:srgbClr val="FFFFFF"/>
+          <a:srgbClr val="F8F9FA"/>
         </a:solidFill>
         <a:effectLst/>
       </p:bgPr>
@@ -4211,8 +4461,8 @@
         </p:nvSpPr>
         <p:spPr>
           <a:xfrm>
-            <a:off x="731520" y="457200"/>
-            <a:ext cx="10698480" cy="822960"/>
+            <a:off x="731520" y="502920"/>
+            <a:ext cx="10728655" cy="1005840"/>
           </a:xfrm>
           <a:prstGeom prst="rect">
             <a:avLst/>
@@ -4226,7 +4476,23 @@
           <a:lstStyle/>
           <a:p>
             <a:pPr>
-              <a:defRPr sz="2400" b="1">
+              <a:defRPr sz="1100" b="1">
+                <a:solidFill>
+                  <a:srgbClr val="1A73E8"/>
+                </a:solidFill>
+                <a:latin typeface="Arial"/>
+              </a:defRPr>
+            </a:pPr>
+            <a:r>
+              <a:t>PRODUCT OVERVIEW</a:t>
+            </a:r>
+          </a:p>
+          <a:p>
+            <a:pPr>
+              <a:spcBef>
+                <a:spcPts val="400"/>
+              </a:spcBef>
+              <a:defRPr sz="2200" b="1">
                 <a:solidFill>
                   <a:srgbClr val="202124"/>
                 </a:solidFill>
@@ -4234,20 +4500,7 @@
               </a:defRPr>
             </a:pPr>
             <a:r>
-              <a:t>Product Overview: MedQuAD Clinical Research Assistant</a:t>
-            </a:r>
-          </a:p>
-          <a:p>
-            <a:pPr>
-              <a:defRPr sz="1200">
-                <a:solidFill>
-                  <a:srgbClr val="5F6368"/>
-                </a:solidFill>
-                <a:latin typeface="Arial"/>
-              </a:defRPr>
-            </a:pPr>
-            <a:r>
-              <a:t>Grounded Multi-Agent Clinical Question Answering System</a:t>
+              <a:t>MedQuAD Delivers Grounded Literature Synthesis with Deterministic Verification</a:t>
             </a:r>
           </a:p>
         </p:txBody>
@@ -4260,8 +4513,8 @@
         </p:nvSpPr>
         <p:spPr>
           <a:xfrm>
-            <a:off x="731520" y="1280160"/>
-            <a:ext cx="10728655" cy="18288"/>
+            <a:off x="731520" y="1554480"/>
+            <a:ext cx="10728655" cy="13716"/>
           </a:xfrm>
           <a:prstGeom prst="rect">
             <a:avLst/>
@@ -4305,14 +4558,14 @@
         </p:nvSpPr>
         <p:spPr>
           <a:xfrm>
-            <a:off x="731520" y="1554480"/>
-            <a:ext cx="5212080" cy="2194560"/>
+            <a:off x="731520" y="1737360"/>
+            <a:ext cx="5212080" cy="2103120"/>
           </a:xfrm>
           <a:prstGeom prst="roundRect">
             <a:avLst/>
           </a:prstGeom>
           <a:solidFill>
-            <a:srgbClr val="F8F9FA"/>
+            <a:srgbClr val="FFFFFF"/>
           </a:solidFill>
           <a:ln w="12700">
             <a:solidFill>
@@ -4355,7 +4608,7 @@
               <a:spcBef>
                 <a:spcPts val="600"/>
               </a:spcBef>
-              <a:defRPr sz="1100">
+              <a:defRPr sz="1050">
                 <a:solidFill>
                   <a:srgbClr val="202124"/>
                 </a:solidFill>
@@ -4363,7 +4616,7 @@
               </a:defRPr>
             </a:pPr>
             <a:r>
-              <a:t>•  Indexes 16,400+ verified medical Q&amp;A pairs from NIH, NCI, CDC, and MedlinePlus.</a:t>
+              <a:t>•  Indexes 16,400+ verified medical Q&amp;A pairs from NIH, NCI, CDC, and MedlinePlus across 12 clinical domains.</a:t>
             </a:r>
           </a:p>
           <a:p>
@@ -4371,7 +4624,7 @@
               <a:spcBef>
                 <a:spcPts val="600"/>
               </a:spcBef>
-              <a:defRPr sz="1100">
+              <a:defRPr sz="1050">
                 <a:solidFill>
                   <a:srgbClr val="202124"/>
                 </a:solidFill>
@@ -4379,7 +4632,7 @@
               </a:defRPr>
             </a:pPr>
             <a:r>
-              <a:t>•  Preprocessed with 500-token semantic chunking and 10% overlap to preserve clinical context.</a:t>
+              <a:t>•  Structured with 500-token semantic chunks and 10% overlap to preserve clinical context.</a:t>
             </a:r>
           </a:p>
           <a:p>
@@ -4387,7 +4640,7 @@
               <a:spcBef>
                 <a:spcPts val="600"/>
               </a:spcBef>
-              <a:defRPr sz="1100">
+              <a:defRPr sz="1050">
                 <a:solidFill>
                   <a:srgbClr val="202124"/>
                 </a:solidFill>
@@ -4395,7 +4648,7 @@
               </a:defRPr>
             </a:pPr>
             <a:r>
-              <a:t>•  Backed by Google Vertex AI Search with automated fallback to an in-memory vector store.</a:t>
+              <a:t>•  Powered by Google Vertex AI Search with automated circuit-breaker fallback to an in-memory vector store.</a:t>
             </a:r>
           </a:p>
         </p:txBody>
@@ -4408,14 +4661,14 @@
         </p:nvSpPr>
         <p:spPr>
           <a:xfrm>
-            <a:off x="6217920" y="1554480"/>
-            <a:ext cx="5212080" cy="2194560"/>
+            <a:off x="6217920" y="1737360"/>
+            <a:ext cx="5212080" cy="2103120"/>
           </a:xfrm>
           <a:prstGeom prst="roundRect">
             <a:avLst/>
           </a:prstGeom>
           <a:solidFill>
-            <a:srgbClr val="F8F9FA"/>
+            <a:srgbClr val="FFFFFF"/>
           </a:solidFill>
           <a:ln w="12700">
             <a:solidFill>
@@ -4458,7 +4711,7 @@
               <a:spcBef>
                 <a:spcPts val="600"/>
               </a:spcBef>
-              <a:defRPr sz="1100">
+              <a:defRPr sz="1050">
                 <a:solidFill>
                   <a:srgbClr val="202124"/>
                 </a:solidFill>
@@ -4466,7 +4719,7 @@
               </a:defRPr>
             </a:pPr>
             <a:r>
-              <a:t>•  Every generated statement must map 1:1 to a specific retrieved NIH passage chunk.</a:t>
+              <a:t>•  Independent Reviewer subagent cross-examines draft responses against retrieved source passages.</a:t>
             </a:r>
           </a:p>
           <a:p>
@@ -4474,7 +4727,7 @@
               <a:spcBef>
                 <a:spcPts val="600"/>
               </a:spcBef>
-              <a:defRPr sz="1100">
+              <a:defRPr sz="1050">
                 <a:solidFill>
                   <a:srgbClr val="202124"/>
                 </a:solidFill>
@@ -4482,7 +4735,7 @@
               </a:defRPr>
             </a:pPr>
             <a:r>
-              <a:t>•  A dedicated Reviewer agent audits citations before output is streamed to the user.</a:t>
+              <a:t>•  CitationVerifier ensures 100% of bracketed claims map to valid retrieved chunk IDs.</a:t>
             </a:r>
           </a:p>
           <a:p>
@@ -4490,7 +4743,7 @@
               <a:spcBef>
                 <a:spcPts val="600"/>
               </a:spcBef>
-              <a:defRPr sz="1100">
+              <a:defRPr sz="1050">
                 <a:solidFill>
                   <a:srgbClr val="202124"/>
                 </a:solidFill>
@@ -4498,7 +4751,7 @@
               </a:defRPr>
             </a:pPr>
             <a:r>
-              <a:t>•  Enforces 100% citation precision—unverified statements are flagged or excised.</a:t>
+              <a:t>•  Ungrounded statements are automatically flagged and removed before streaming to the user.</a:t>
             </a:r>
           </a:p>
         </p:txBody>
@@ -4511,14 +4764,14 @@
         </p:nvSpPr>
         <p:spPr>
           <a:xfrm>
-            <a:off x="731520" y="3931920"/>
-            <a:ext cx="5212080" cy="2194560"/>
+            <a:off x="731520" y="4023360"/>
+            <a:ext cx="5212080" cy="2103120"/>
           </a:xfrm>
           <a:prstGeom prst="roundRect">
             <a:avLst/>
           </a:prstGeom>
           <a:solidFill>
-            <a:srgbClr val="F8F9FA"/>
+            <a:srgbClr val="FFFFFF"/>
           </a:solidFill>
           <a:ln w="12700">
             <a:solidFill>
@@ -4553,7 +4806,7 @@
               </a:defRPr>
             </a:pPr>
             <a:r>
-              <a:t>Layer 8 Safety &amp; Safe Refusal</a:t>
+              <a:t>Layer 8 Safety &amp; Safe Refusal Engine</a:t>
             </a:r>
           </a:p>
           <a:p>
@@ -4561,7 +4814,7 @@
               <a:spcBef>
                 <a:spcPts val="600"/>
               </a:spcBef>
-              <a:defRPr sz="1100">
+              <a:defRPr sz="1050">
                 <a:solidFill>
                   <a:srgbClr val="202124"/>
                 </a:solidFill>
@@ -4569,7 +4822,7 @@
               </a:defRPr>
             </a:pPr>
             <a:r>
-              <a:t>•  Immediate interception (&lt;5ms) of personal diagnostic and drug dosing demands.</a:t>
+              <a:t>•  Pre-flight de-identification of 18 HIPAA Safe Harbor identifiers (MRN, SSN, patient names).</a:t>
             </a:r>
           </a:p>
           <a:p>
@@ -4577,7 +4830,7 @@
               <a:spcBef>
                 <a:spcPts val="600"/>
               </a:spcBef>
-              <a:defRPr sz="1100">
+              <a:defRPr sz="1050">
                 <a:solidFill>
                   <a:srgbClr val="202124"/>
                 </a:solidFill>
@@ -4585,7 +4838,7 @@
               </a:defRPr>
             </a:pPr>
             <a:r>
-              <a:t>•  Pre-flight de-identification of 18 HIPAA Safe Harbor identifiers (MRN, SSN, names).</a:t>
+              <a:t>•  Immediate rejection (&lt;5ms) of personal diagnosis and drug dosing prompts without invoking model tokens.</a:t>
             </a:r>
           </a:p>
           <a:p>
@@ -4593,7 +4846,7 @@
               <a:spcBef>
                 <a:spcPts val="600"/>
               </a:spcBef>
-              <a:defRPr sz="1100">
+              <a:defRPr sz="1050">
                 <a:solidFill>
                   <a:srgbClr val="202124"/>
                 </a:solidFill>
@@ -4601,7 +4854,7 @@
               </a:defRPr>
             </a:pPr>
             <a:r>
-              <a:t>•  Returns structured clinical disclaimers and emergency redirection without wasting LLM tokens.</a:t>
+              <a:t>•  Structured response redirects users to certified healthcare providers and emergency services.</a:t>
             </a:r>
           </a:p>
         </p:txBody>
@@ -4614,14 +4867,14 @@
         </p:nvSpPr>
         <p:spPr>
           <a:xfrm>
-            <a:off x="6217920" y="3931920"/>
-            <a:ext cx="5212080" cy="2194560"/>
+            <a:off x="6217920" y="4023360"/>
+            <a:ext cx="5212080" cy="2103120"/>
           </a:xfrm>
           <a:prstGeom prst="roundRect">
             <a:avLst/>
           </a:prstGeom>
           <a:solidFill>
-            <a:srgbClr val="F8F9FA"/>
+            <a:srgbClr val="FFFFFF"/>
           </a:solidFill>
           <a:ln w="12700">
             <a:solidFill>
@@ -4656,7 +4909,7 @@
               </a:defRPr>
             </a:pPr>
             <a:r>
-              <a:t>Efficient Model Tiering &amp; Cloud Run</a:t>
+              <a:t>Cost-Effective Model Tiering</a:t>
             </a:r>
           </a:p>
           <a:p>
@@ -4664,7 +4917,7 @@
               <a:spcBef>
                 <a:spcPts val="600"/>
               </a:spcBef>
-              <a:defRPr sz="1100">
+              <a:defRPr sz="1050">
                 <a:solidFill>
                   <a:srgbClr val="202124"/>
                 </a:solidFill>
@@ -4672,7 +4925,7 @@
               </a:defRPr>
             </a:pPr>
             <a:r>
-              <a:t>•  Tiered Gemini models: Flash 2.5 for routing/safety, Pro 2.5 for synthesis, Flash 3.5 for review.</a:t>
+              <a:t>•  Tiered Gemini deployment: Flash 2.5 for intent/routing, Pro 2.5 for synthesis, Flash 3.5 for audit.</a:t>
             </a:r>
           </a:p>
           <a:p>
@@ -4680,7 +4933,7 @@
               <a:spcBef>
                 <a:spcPts val="600"/>
               </a:spcBef>
-              <a:defRPr sz="1100">
+              <a:defRPr sz="1050">
                 <a:solidFill>
                   <a:srgbClr val="202124"/>
                 </a:solidFill>
@@ -4688,7 +4941,7 @@
               </a:defRPr>
             </a:pPr>
             <a:r>
-              <a:t>•  Blended inference cost of ~$0.0035 per query ($351/mo for 100,000 queries).</a:t>
+              <a:t>•  Blended query cost of ~$0.0035 ($351/month for 100,000 queries) vs. $15.00 manual labor.</a:t>
             </a:r>
           </a:p>
           <a:p>
@@ -4696,7 +4949,7 @@
               <a:spcBef>
                 <a:spcPts val="600"/>
               </a:spcBef>
-              <a:defRPr sz="1100">
+              <a:defRPr sz="1050">
                 <a:solidFill>
                   <a:srgbClr val="202124"/>
                 </a:solidFill>
@@ -4704,7 +4957,7 @@
               </a:defRPr>
             </a:pPr>
             <a:r>
-              <a:t>•  Deployed serverless on Google Cloud Run with sub-3s p95 latency and zero cold starts.</a:t>
+              <a:t>•  Deployed on Cloud Run with p95 response latency under 3 seconds and zero idle server costs.</a:t>
             </a:r>
           </a:p>
         </p:txBody>
@@ -4717,13 +4970,13 @@
 </p:sld>
 </file>
 
-<file path=ppt/slides/slide3.xml><?xml version="1.0" encoding="utf-8"?>
+<file path=ppt/slides/slide4.xml><?xml version="1.0" encoding="utf-8"?>
 <p:sld xmlns:a="http://schemas.openxmlformats.org/drawingml/2006/main" xmlns:p="http://schemas.openxmlformats.org/presentationml/2006/main" xmlns:r="http://schemas.openxmlformats.org/officeDocument/2006/relationships">
   <p:cSld>
     <p:bg>
       <p:bgPr>
         <a:solidFill>
-          <a:srgbClr val="FFFFFF"/>
+          <a:srgbClr val="F8F9FA"/>
         </a:solidFill>
         <a:effectLst/>
       </p:bgPr>
@@ -4743,8 +4996,8 @@
         </p:nvSpPr>
         <p:spPr>
           <a:xfrm>
-            <a:off x="731520" y="457200"/>
-            <a:ext cx="10698480" cy="822960"/>
+            <a:off x="731520" y="502920"/>
+            <a:ext cx="10728655" cy="1005840"/>
           </a:xfrm>
           <a:prstGeom prst="rect">
             <a:avLst/>
@@ -4758,7 +5011,23 @@
           <a:lstStyle/>
           <a:p>
             <a:pPr>
-              <a:defRPr sz="2400" b="1">
+              <a:defRPr sz="1100" b="1">
+                <a:solidFill>
+                  <a:srgbClr val="1A73E8"/>
+                </a:solidFill>
+                <a:latin typeface="Arial"/>
+              </a:defRPr>
+            </a:pPr>
+            <a:r>
+              <a:t>SYSTEM ARCHITECTURE</a:t>
+            </a:r>
+          </a:p>
+          <a:p>
+            <a:pPr>
+              <a:spcBef>
+                <a:spcPts val="400"/>
+              </a:spcBef>
+              <a:defRPr sz="2200" b="1">
                 <a:solidFill>
                   <a:srgbClr val="202124"/>
                 </a:solidFill>
@@ -4766,20 +5035,7 @@
               </a:defRPr>
             </a:pPr>
             <a:r>
-              <a:t>System Architecture: ADK Multi-Agent Pipeline</a:t>
-            </a:r>
-          </a:p>
-          <a:p>
-            <a:pPr>
-              <a:defRPr sz="1200">
-                <a:solidFill>
-                  <a:srgbClr val="5F6368"/>
-                </a:solidFill>
-                <a:latin typeface="Arial"/>
-              </a:defRPr>
-            </a:pPr>
-            <a:r>
-              <a:t>Supervisor-Worker Topology with Deterministic Validation</a:t>
+              <a:t>Multi-Agent ADK Architecture Decouples Retrieval, Synthesis, and Verification</a:t>
             </a:r>
           </a:p>
         </p:txBody>
@@ -4792,8 +5048,8 @@
         </p:nvSpPr>
         <p:spPr>
           <a:xfrm>
-            <a:off x="731520" y="1280160"/>
-            <a:ext cx="10728655" cy="18288"/>
+            <a:off x="731520" y="1554480"/>
+            <a:ext cx="10728655" cy="13716"/>
           </a:xfrm>
           <a:prstGeom prst="rect">
             <a:avLst/>
@@ -4837,14 +5093,14 @@
         </p:nvSpPr>
         <p:spPr>
           <a:xfrm>
-            <a:off x="731520" y="1554480"/>
-            <a:ext cx="10698480" cy="685800"/>
+            <a:off x="731520" y="1691640"/>
+            <a:ext cx="10728655" cy="640080"/>
           </a:xfrm>
           <a:prstGeom prst="rect">
             <a:avLst/>
           </a:prstGeom>
           <a:solidFill>
-            <a:srgbClr val="F8F9FA"/>
+            <a:srgbClr val="FFFFFF"/>
           </a:solidFill>
           <a:ln>
             <a:solidFill>
@@ -4867,14 +5123,15 @@
           </a:fontRef>
         </p:style>
         <p:txBody>
-          <a:bodyPr rtlCol="0" anchor="ctr" wrap="square"/>
+          <a:bodyPr rtlCol="0" anchor="ctr" lIns="182880" rIns="182880" tIns="91440"/>
           <a:lstStyle/>
           <a:p>
             <a:pPr algn="ctr">
-              <a:defRPr b="1" sz="1100">
+              <a:defRPr sz="1050" b="1">
                 <a:solidFill>
                   <a:srgbClr val="1A73E8"/>
                 </a:solidFill>
+                <a:latin typeface="Arial"/>
               </a:defRPr>
             </a:pPr>
             <a:r>
@@ -4883,14 +5140,15 @@
           </a:p>
           <a:p>
             <a:pPr>
-              <a:defRPr sz="1000">
+              <a:defRPr sz="950">
                 <a:solidFill>
                   <a:srgbClr val="202124"/>
                 </a:solidFill>
-              </a:defRPr>
-            </a:pPr>
-            <a:r>
-              <a:t>Client Request (HTTPS / SSE)  ──&gt;  Cloud Armor L7 WAF  ──&gt;  Cloud Run (FastAPI Gateway)  ──&gt;  Model Armor (HIPAA PHI Redaction &amp; Injection Filter)</a:t>
+                <a:latin typeface="Arial"/>
+              </a:defRPr>
+            </a:pPr>
+            <a:r>
+              <a:t>Client (HTTPS / SSE)  ──&gt;  Cloud Armor L7 WAF  ──&gt;  Cloud Run (FastAPI)  ──&gt;  Model Armor (HIPAA PHI Redaction &amp; Prompt Guard)</a:t>
             </a:r>
           </a:p>
         </p:txBody>
@@ -4903,7 +5161,7 @@
         </p:nvSpPr>
         <p:spPr>
           <a:xfrm>
-            <a:off x="731520" y="2423160"/>
+            <a:off x="731520" y="2468880"/>
             <a:ext cx="3429000" cy="2468880"/>
           </a:xfrm>
           <a:prstGeom prst="roundRect">
@@ -4937,7 +5195,7 @@
           <a:lstStyle/>
           <a:p>
             <a:pPr algn="ctr">
-              <a:defRPr b="1" sz="1200">
+              <a:defRPr b="1" sz="1150">
                 <a:solidFill>
                   <a:srgbClr val="1A73E8"/>
                 </a:solidFill>
@@ -4949,7 +5207,7 @@
           </a:p>
           <a:p>
             <a:pPr>
-              <a:defRPr b="1" sz="1000">
+              <a:defRPr b="1" sz="950">
                 <a:solidFill>
                   <a:srgbClr val="5F6368"/>
                 </a:solidFill>
@@ -4962,22 +5220,22 @@
           </a:p>
           <a:p>
             <a:pPr>
-              <a:defRPr sz="1000">
+              <a:defRPr sz="950">
                 <a:solidFill>
                   <a:srgbClr val="202124"/>
                 </a:solidFill>
               </a:defRPr>
             </a:pPr>
             <a:r>
-              <a:t>• Evaluates user intent &amp; domain.</a:t>
+              <a:t>• Classifies clinical intent &amp; domain.</a:t>
             </a:r>
             <a:br/>
             <a:r>
-              <a:t>• SafeRefusalEngine intercepts diagnosis &amp; prescription requests in &lt;5ms.</a:t>
+              <a:t>• SafeRefusalEngine rejects diagnosis/dosing in &lt;5ms.</a:t>
             </a:r>
             <a:br/>
             <a:r>
-              <a:t>• Enforces immutable max_iterations=2 loop ceiling to prevent runaway costs.</a:t>
+              <a:t>• Enforces strict max_iterations=2 loop ceiling.</a:t>
             </a:r>
           </a:p>
         </p:txBody>
@@ -4990,7 +5248,7 @@
         </p:nvSpPr>
         <p:spPr>
           <a:xfrm>
-            <a:off x="4370832" y="2423160"/>
+            <a:off x="4370832" y="2468880"/>
             <a:ext cx="3429000" cy="2468880"/>
           </a:xfrm>
           <a:prstGeom prst="roundRect">
@@ -5024,7 +5282,7 @@
           <a:lstStyle/>
           <a:p>
             <a:pPr algn="ctr">
-              <a:defRPr b="1" sz="1200">
+              <a:defRPr b="1" sz="1150">
                 <a:solidFill>
                   <a:srgbClr val="1A73E8"/>
                 </a:solidFill>
@@ -5036,7 +5294,7 @@
           </a:p>
           <a:p>
             <a:pPr>
-              <a:defRPr b="1" sz="1000">
+              <a:defRPr b="1" sz="950">
                 <a:solidFill>
                   <a:srgbClr val="5F6368"/>
                 </a:solidFill>
@@ -5049,22 +5307,22 @@
           </a:p>
           <a:p>
             <a:pPr>
-              <a:defRPr sz="1000">
+              <a:defRPr sz="950">
                 <a:solidFill>
                   <a:srgbClr val="202124"/>
                 </a:solidFill>
               </a:defRPr>
             </a:pPr>
             <a:r>
-              <a:t>• Executes semantic search across 16.4k NIH MedQuAD passages.</a:t>
+              <a:t>• Queries Vertex AI Search (16.4k NIH pairs).</a:t>
             </a:r>
             <a:br/>
             <a:r>
-              <a:t>• Queries lab reference ranges via ClinicalDBTool.</a:t>
+              <a:t>• Fetches lab test ranges via ClinicalDBTool.</a:t>
             </a:r>
             <a:br/>
             <a:r>
-              <a:t>• Synthesizes grounded evidence draft with explicit inline [1], [2] citations.</a:t>
+              <a:t>• Drafts evidence synthesis with inline [1], [2] citations.</a:t>
             </a:r>
           </a:p>
         </p:txBody>
@@ -5077,7 +5335,7 @@
         </p:nvSpPr>
         <p:spPr>
           <a:xfrm>
-            <a:off x="8001000" y="2423160"/>
+            <a:off x="8001000" y="2468880"/>
             <a:ext cx="3429000" cy="2468880"/>
           </a:xfrm>
           <a:prstGeom prst="roundRect">
@@ -5111,7 +5369,7 @@
           <a:lstStyle/>
           <a:p>
             <a:pPr algn="ctr">
-              <a:defRPr b="1" sz="1200">
+              <a:defRPr b="1" sz="1150">
                 <a:solidFill>
                   <a:srgbClr val="1A73E8"/>
                 </a:solidFill>
@@ -5123,7 +5381,7 @@
           </a:p>
           <a:p>
             <a:pPr>
-              <a:defRPr b="1" sz="1000">
+              <a:defRPr b="1" sz="950">
                 <a:solidFill>
                   <a:srgbClr val="5F6368"/>
                 </a:solidFill>
@@ -5136,22 +5394,22 @@
           </a:p>
           <a:p>
             <a:pPr>
-              <a:defRPr sz="1000">
+              <a:defRPr sz="950">
                 <a:solidFill>
                   <a:srgbClr val="202124"/>
                 </a:solidFill>
               </a:defRPr>
             </a:pPr>
             <a:r>
-              <a:t>• Operates with zero shared hidden state to avoid confirmation bias.</a:t>
+              <a:t>• Operates with zero shared hidden state.</a:t>
             </a:r>
             <a:br/>
             <a:r>
-              <a:t>• CitationVerifier: checks that every bracketed citation maps to a valid retrieved chunk ID.</a:t>
+              <a:t>• CitationVerifier checks every citation against chunk IDs.</a:t>
             </a:r>
             <a:br/>
             <a:r>
-              <a:t>• Blocks ungrounded claims before streaming.</a:t>
+              <a:t>• Strips ungrounded claims before streaming.</a:t>
             </a:r>
           </a:p>
         </p:txBody>
@@ -5165,13 +5423,13 @@
         <p:spPr>
           <a:xfrm>
             <a:off x="731520" y="5074920"/>
-            <a:ext cx="10698480" cy="594360"/>
+            <a:ext cx="10728655" cy="594360"/>
           </a:xfrm>
           <a:prstGeom prst="rect">
             <a:avLst/>
           </a:prstGeom>
           <a:solidFill>
-            <a:srgbClr val="F8F9FA"/>
+            <a:srgbClr val="FFFFFF"/>
           </a:solidFill>
           <a:ln>
             <a:solidFill>
@@ -5194,14 +5452,15 @@
           </a:fontRef>
         </p:style>
         <p:txBody>
-          <a:bodyPr rtlCol="0" anchor="ctr"/>
+          <a:bodyPr rtlCol="0" anchor="ctr" lIns="182880" rIns="182880" tIns="91440"/>
           <a:lstStyle/>
           <a:p>
             <a:pPr algn="ctr">
-              <a:defRPr b="1" sz="1100">
+              <a:defRPr sz="1050" b="1">
                 <a:solidFill>
                   <a:srgbClr val="1A73E8"/>
                 </a:solidFill>
+                <a:latin typeface="Arial"/>
               </a:defRPr>
             </a:pPr>
             <a:r>
@@ -5210,14 +5469,15 @@
           </a:p>
           <a:p>
             <a:pPr>
-              <a:defRPr sz="1000">
+              <a:defRPr sz="950">
                 <a:solidFill>
                   <a:srgbClr val="202124"/>
                 </a:solidFill>
-              </a:defRPr>
-            </a:pPr>
-            <a:r>
-              <a:t>Vertex AI Search (16,400+ NIH Records)  |  Local In-Memory Vector Fallback (Circuit Breaker)  |  GCS Corpus Bucket</a:t>
+                <a:latin typeface="Arial"/>
+              </a:defRPr>
+            </a:pPr>
+            <a:r>
+              <a:t>Vertex AI Search Datastore (16.4k NIH pairs)  |  In-Memory Vector Fallback (Circuit Breaker)  |  GCS Raw XML Staging</a:t>
             </a:r>
           </a:p>
         </p:txBody>
@@ -5231,13 +5491,13 @@
         <p:spPr>
           <a:xfrm>
             <a:off x="731520" y="5806440"/>
-            <a:ext cx="10698480" cy="594360"/>
+            <a:ext cx="10728655" cy="594360"/>
           </a:xfrm>
           <a:prstGeom prst="rect">
             <a:avLst/>
           </a:prstGeom>
           <a:solidFill>
-            <a:srgbClr val="F8F9FA"/>
+            <a:srgbClr val="FFFFFF"/>
           </a:solidFill>
           <a:ln>
             <a:solidFill>
@@ -5260,14 +5520,15 @@
           </a:fontRef>
         </p:style>
         <p:txBody>
-          <a:bodyPr rtlCol="0" anchor="ctr"/>
+          <a:bodyPr rtlCol="0" anchor="ctr" lIns="182880" rIns="182880" tIns="91440"/>
           <a:lstStyle/>
           <a:p>
             <a:pPr algn="ctr">
-              <a:defRPr b="1" sz="1100">
+              <a:defRPr sz="1050" b="1">
                 <a:solidFill>
                   <a:srgbClr val="1A73E8"/>
                 </a:solidFill>
+                <a:latin typeface="Arial"/>
               </a:defRPr>
             </a:pPr>
             <a:r>
@@ -5276,14 +5537,15 @@
           </a:p>
           <a:p>
             <a:pPr>
-              <a:defRPr sz="1000">
+              <a:defRPr sz="950">
                 <a:solidFill>
                   <a:srgbClr val="202124"/>
                 </a:solidFill>
-              </a:defRPr>
-            </a:pPr>
-            <a:r>
-              <a:t>OpenTelemetry Distributed Context  ──&gt;  Cloud Trace  ──&gt;  BigQuery Telemetry Sink  ──&gt;  Cloud Scheduler Nightly Audit Pipeline</a:t>
+                <a:latin typeface="Arial"/>
+              </a:defRPr>
+            </a:pPr>
+            <a:r>
+              <a:t>OpenTelemetry Distributed Tracing  ──&gt;  Google Cloud Trace  ──&gt;  BigQuery Telemetry Sink  ──&gt;  Automated Nightly Quality Audit</a:t>
             </a:r>
           </a:p>
         </p:txBody>
@@ -5296,13 +5558,13 @@
 </p:sld>
 </file>
 
-<file path=ppt/slides/slide4.xml><?xml version="1.0" encoding="utf-8"?>
+<file path=ppt/slides/slide5.xml><?xml version="1.0" encoding="utf-8"?>
 <p:sld xmlns:a="http://schemas.openxmlformats.org/drawingml/2006/main" xmlns:p="http://schemas.openxmlformats.org/presentationml/2006/main" xmlns:r="http://schemas.openxmlformats.org/officeDocument/2006/relationships">
   <p:cSld>
     <p:bg>
       <p:bgPr>
         <a:solidFill>
-          <a:srgbClr val="FFFFFF"/>
+          <a:srgbClr val="F8F9FA"/>
         </a:solidFill>
         <a:effectLst/>
       </p:bgPr>
@@ -5322,8 +5584,8 @@
         </p:nvSpPr>
         <p:spPr>
           <a:xfrm>
-            <a:off x="731520" y="457200"/>
-            <a:ext cx="10698480" cy="822960"/>
+            <a:off x="731520" y="502920"/>
+            <a:ext cx="10728655" cy="1005840"/>
           </a:xfrm>
           <a:prstGeom prst="rect">
             <a:avLst/>
@@ -5337,7 +5599,23 @@
           <a:lstStyle/>
           <a:p>
             <a:pPr>
-              <a:defRPr sz="2400" b="1">
+              <a:defRPr sz="1100" b="1">
+                <a:solidFill>
+                  <a:srgbClr val="1A73E8"/>
+                </a:solidFill>
+                <a:latin typeface="Arial"/>
+              </a:defRPr>
+            </a:pPr>
+            <a:r>
+              <a:t>FUTURE ROADMAP</a:t>
+            </a:r>
+          </a:p>
+          <a:p>
+            <a:pPr>
+              <a:spcBef>
+                <a:spcPts val="400"/>
+              </a:spcBef>
+              <a:defRPr sz="2200" b="1">
                 <a:solidFill>
                   <a:srgbClr val="202124"/>
                 </a:solidFill>
@@ -5345,20 +5623,7 @@
               </a:defRPr>
             </a:pPr>
             <a:r>
-              <a:t>Future Work: Roadmap &amp; Clinical System Integration</a:t>
-            </a:r>
-          </a:p>
-          <a:p>
-            <a:pPr>
-              <a:defRPr sz="1200">
-                <a:solidFill>
-                  <a:srgbClr val="5F6368"/>
-                </a:solidFill>
-                <a:latin typeface="Arial"/>
-              </a:defRPr>
-            </a:pPr>
-            <a:r>
-              <a:t>Technical Priorities for Production Maturation</a:t>
+              <a:t>Roadmap Focuses on Clinical Standards, State Persistence, and Multimodal RAG</a:t>
             </a:r>
           </a:p>
         </p:txBody>
@@ -5371,8 +5636,8 @@
         </p:nvSpPr>
         <p:spPr>
           <a:xfrm>
-            <a:off x="731520" y="1280160"/>
-            <a:ext cx="10728655" cy="18288"/>
+            <a:off x="731520" y="1554480"/>
+            <a:ext cx="10728655" cy="13716"/>
           </a:xfrm>
           <a:prstGeom prst="rect">
             <a:avLst/>
@@ -5416,14 +5681,14 @@
         </p:nvSpPr>
         <p:spPr>
           <a:xfrm>
-            <a:off x="731520" y="1554480"/>
-            <a:ext cx="5212080" cy="2148840"/>
+            <a:off x="731520" y="1737360"/>
+            <a:ext cx="5212080" cy="2103120"/>
           </a:xfrm>
           <a:prstGeom prst="roundRect">
             <a:avLst/>
           </a:prstGeom>
           <a:solidFill>
-            <a:srgbClr val="F8F9FA"/>
+            <a:srgbClr val="FFFFFF"/>
           </a:solidFill>
           <a:ln w="12700">
             <a:solidFill>
@@ -5458,7 +5723,7 @@
               </a:defRPr>
             </a:pPr>
             <a:r>
-              <a:t>1. EHR &amp; Standards Integration (Cloud Healthcare API)</a:t>
+              <a:t>1. EHR Standards (Google Cloud Healthcare API)</a:t>
             </a:r>
           </a:p>
           <a:p>
@@ -5466,7 +5731,7 @@
               <a:spcBef>
                 <a:spcPts val="600"/>
               </a:spcBef>
-              <a:defRPr sz="1100">
+              <a:defRPr sz="1050">
                 <a:solidFill>
                   <a:srgbClr val="202124"/>
                 </a:solidFill>
@@ -5474,7 +5739,7 @@
               </a:defRPr>
             </a:pPr>
             <a:r>
-              <a:t>•  Connect to Google Cloud Healthcare API to query de-identified patient data.</a:t>
+              <a:t>•  Integrate Google Cloud Healthcare API to query de-identified clinical records.</a:t>
             </a:r>
           </a:p>
           <a:p>
@@ -5482,7 +5747,7 @@
               <a:spcBef>
                 <a:spcPts val="600"/>
               </a:spcBef>
-              <a:defRPr sz="1100">
+              <a:defRPr sz="1050">
                 <a:solidFill>
                   <a:srgbClr val="202124"/>
                 </a:solidFill>
@@ -5490,7 +5755,7 @@
               </a:defRPr>
             </a:pPr>
             <a:r>
-              <a:t>•  Ingest and parse FHIR R4 resources (Patient, Condition, Observation, MedicationStatement).</a:t>
+              <a:t>•  Parse and ingest FHIR R4 resources (Patient, Condition, Observation, MedicationStatement).</a:t>
             </a:r>
           </a:p>
           <a:p>
@@ -5498,7 +5763,7 @@
               <a:spcBef>
                 <a:spcPts val="600"/>
               </a:spcBef>
-              <a:defRPr sz="1100">
+              <a:defRPr sz="1050">
                 <a:solidFill>
                   <a:srgbClr val="202124"/>
                 </a:solidFill>
@@ -5506,7 +5771,7 @@
               </a:defRPr>
             </a:pPr>
             <a:r>
-              <a:t>•  Enable clinical researchers to compare literature findings against patient cohort criteria.</a:t>
+              <a:t>•  Enable researchers to cross-reference literature evidence against clinical cohort criteria.</a:t>
             </a:r>
           </a:p>
         </p:txBody>
@@ -5519,14 +5784,14 @@
         </p:nvSpPr>
         <p:spPr>
           <a:xfrm>
-            <a:off x="6217920" y="1554480"/>
-            <a:ext cx="5212080" cy="2148840"/>
+            <a:off x="6217920" y="1737360"/>
+            <a:ext cx="5212080" cy="2103120"/>
           </a:xfrm>
           <a:prstGeom prst="roundRect">
             <a:avLst/>
           </a:prstGeom>
           <a:solidFill>
-            <a:srgbClr val="F8F9FA"/>
+            <a:srgbClr val="FFFFFF"/>
           </a:solidFill>
           <a:ln w="12700">
             <a:solidFill>
@@ -5569,7 +5834,7 @@
               <a:spcBef>
                 <a:spcPts val="600"/>
               </a:spcBef>
-              <a:defRPr sz="1100">
+              <a:defRPr sz="1050">
                 <a:solidFill>
                   <a:srgbClr val="202124"/>
                 </a:solidFill>
@@ -5577,7 +5842,7 @@
               </a:defRPr>
             </a:pPr>
             <a:r>
-              <a:t>•  Migrate from ephemeral in-memory session history to distributed Cloud Firestore.</a:t>
+              <a:t>•  Migrate from ephemeral in-memory conversation state to distributed Cloud Firestore.</a:t>
             </a:r>
           </a:p>
           <a:p>
@@ -5585,7 +5850,7 @@
               <a:spcBef>
                 <a:spcPts val="600"/>
               </a:spcBef>
-              <a:defRPr sz="1100">
+              <a:defRPr sz="1050">
                 <a:solidFill>
                   <a:srgbClr val="202124"/>
                 </a:solidFill>
@@ -5593,7 +5858,7 @@
               </a:defRPr>
             </a:pPr>
             <a:r>
-              <a:t>•  Support cross-session multi-turn research conversations with TTL-managed retention.</a:t>
+              <a:t>•  Support multi-turn research threads across container instances with TTL retention.</a:t>
             </a:r>
           </a:p>
           <a:p>
@@ -5601,7 +5866,7 @@
               <a:spcBef>
                 <a:spcPts val="600"/>
               </a:spcBef>
-              <a:defRPr sz="1100">
+              <a:defRPr sz="1050">
                 <a:solidFill>
                   <a:srgbClr val="202124"/>
                 </a:solidFill>
@@ -5609,7 +5874,7 @@
               </a:defRPr>
             </a:pPr>
             <a:r>
-              <a:t>•  Implement multi-region active-active redundancy for continuous availability.</a:t>
+              <a:t>•  Implement multi-region active-active replication for enterprise high availability.</a:t>
             </a:r>
           </a:p>
         </p:txBody>
@@ -5622,14 +5887,14 @@
         </p:nvSpPr>
         <p:spPr>
           <a:xfrm>
-            <a:off x="731520" y="3931920"/>
-            <a:ext cx="5212080" cy="2148840"/>
+            <a:off x="731520" y="4023360"/>
+            <a:ext cx="5212080" cy="2103120"/>
           </a:xfrm>
           <a:prstGeom prst="roundRect">
             <a:avLst/>
           </a:prstGeom>
           <a:solidFill>
-            <a:srgbClr val="F8F9FA"/>
+            <a:srgbClr val="FFFFFF"/>
           </a:solidFill>
           <a:ln w="12700">
             <a:solidFill>
@@ -5672,7 +5937,7 @@
               <a:spcBef>
                 <a:spcPts val="600"/>
               </a:spcBef>
-              <a:defRPr sz="1100">
+              <a:defRPr sz="1050">
                 <a:solidFill>
                   <a:srgbClr val="202124"/>
                 </a:solidFill>
@@ -5680,7 +5945,7 @@
               </a:defRPr>
             </a:pPr>
             <a:r>
-              <a:t>•  Expand retrieval from text-only NIH XML documents to medical imagery and scans.</a:t>
+              <a:t>•  Expand ingestion pipeline from text-only XML records to diagnostic imaging.</a:t>
             </a:r>
           </a:p>
           <a:p>
@@ -5688,7 +5953,7 @@
               <a:spcBef>
                 <a:spcPts val="600"/>
               </a:spcBef>
-              <a:defRPr sz="1100">
+              <a:defRPr sz="1050">
                 <a:solidFill>
                   <a:srgbClr val="202124"/>
                 </a:solidFill>
@@ -5696,7 +5961,7 @@
               </a:defRPr>
             </a:pPr>
             <a:r>
-              <a:t>•  Ingest DICOM radiology files and histology slides stored in Cloud Storage buckets.</a:t>
+              <a:t>•  Ingest DICOM radiology files and pathology slide scans stored in GCS buckets.</a:t>
             </a:r>
           </a:p>
           <a:p>
@@ -5704,7 +5969,7 @@
               <a:spcBef>
                 <a:spcPts val="600"/>
               </a:spcBef>
-              <a:defRPr sz="1100">
+              <a:defRPr sz="1050">
                 <a:solidFill>
                   <a:srgbClr val="202124"/>
                 </a:solidFill>
@@ -5712,7 +5977,7 @@
               </a:defRPr>
             </a:pPr>
             <a:r>
-              <a:t>•  Use Gemini multimodal reasoning to correlate diagnostic imaging with clinical guidelines.</a:t>
+              <a:t>•  Use Gemini multimodal reasoning to correlate medical imaging with clinical guidelines.</a:t>
             </a:r>
           </a:p>
         </p:txBody>
@@ -5725,14 +5990,14 @@
         </p:nvSpPr>
         <p:spPr>
           <a:xfrm>
-            <a:off x="6217920" y="3931920"/>
-            <a:ext cx="5212080" cy="2148840"/>
+            <a:off x="6217920" y="4023360"/>
+            <a:ext cx="5212080" cy="2103120"/>
           </a:xfrm>
           <a:prstGeom prst="roundRect">
             <a:avLst/>
           </a:prstGeom>
           <a:solidFill>
-            <a:srgbClr val="F8F9FA"/>
+            <a:srgbClr val="FFFFFF"/>
           </a:solidFill>
           <a:ln w="12700">
             <a:solidFill>
@@ -5775,7 +6040,7 @@
               <a:spcBef>
                 <a:spcPts val="600"/>
               </a:spcBef>
-              <a:defRPr sz="1100">
+              <a:defRPr sz="1050">
                 <a:solidFill>
                   <a:srgbClr val="202124"/>
                 </a:solidFill>
@@ -5791,7 +6056,7 @@
               <a:spcBef>
                 <a:spcPts val="600"/>
               </a:spcBef>
-              <a:defRPr sz="1100">
+              <a:defRPr sz="1050">
                 <a:solidFill>
                   <a:srgbClr val="202124"/>
                 </a:solidFill>
@@ -5799,7 +6064,7 @@
               </a:defRPr>
             </a:pPr>
             <a:r>
-              <a:t>•  Enforce role-based access control (RBAC) distinguishing researchers, oncologists, and auditors.</a:t>
+              <a:t>•  Enforce role-based access control (RBAC) separating researchers, oncologists, and auditors.</a:t>
             </a:r>
           </a:p>
           <a:p>
@@ -5807,7 +6072,7 @@
               <a:spcBef>
                 <a:spcPts val="600"/>
               </a:spcBef>
-              <a:defRPr sz="1100">
+              <a:defRPr sz="1050">
                 <a:solidFill>
                   <a:srgbClr val="202124"/>
                 </a:solidFill>

</xml_diff>

<commit_message>
feat(presentation): add visual architecture diagram with 39 native boxes, containers, and directional arrows
</commit_message>
<xml_diff>
--- a/docs/medquad_capstone_presentation.pptx
+++ b/docs/medquad_capstone_presentation.pptx
@@ -775,37 +775,43 @@
           <a:lstStyle/>
           <a:p>
             <a:r>
-              <a:t>Slide 4 walks through the technical architecture and request lifecycle:</a:t>
+              <a:t>Slide 4 displays the concrete architecture diagram showing the visual flow across components:</a:t>
             </a:r>
           </a:p>
           <a:p/>
           <a:p>
             <a:r>
-              <a:t>1. Ingress &amp; Security: Requests enter via Cloud Armor and FastAPI on Cloud Run. Before touching any model, Model Armor redacts 18 HIPAA Safe Harbor identifiers and filters jailbreak patterns.</a:t>
+              <a:t>1. Ingress &amp; Perimeter: Clinician queries enter via Cloud Armor and FastAPI on Cloud Run. Model Armor performs Layer 8 guardrails—scrubbing 18 HIPAA Safe Harbor identifiers and filtering jailbreak injections.</a:t>
             </a:r>
           </a:p>
           <a:p/>
           <a:p>
             <a:r>
-              <a:t>2. Orchestration: The Root Orchestrator (Gemini 2.5 Flash) assesses the query. If it asks for diagnosis or prescriptions, the Safe Refusal Engine catches it in under 5ms. If valid, it delegates to the Researcher.</a:t>
+              <a:t>2. Safe Refusal Branch: If the user asks for personal medical advice or dosing, the Safe Refusal Engine exits in under 5ms without invoking model tokens.</a:t>
             </a:r>
           </a:p>
           <a:p/>
           <a:p>
             <a:r>
-              <a:t>3. Research: The Clinical Researcher (Gemini 2.5 Pro) retrieves passages from Vertex AI Search and synthesizes a draft with explicit citations.</a:t>
+              <a:t>3. Multi-Agent Orchestration: If valid, the query passes to the Root Orchestrator (Gemini 2.5 Flash), which classifies intent and routes to the Clinical Researcher (Gemini 2.5 Pro).</a:t>
             </a:r>
           </a:p>
           <a:p/>
           <a:p>
             <a:r>
-              <a:t>4. Review: The draft is reviewed by an independent Reviewer subagent (Gemini 3.5 Flash) with zero shared state. The CitationVerifier validates every citation against retrieved chunk IDs before release.</a:t>
+              <a:t>4. Grounding: The Researcher retrieves 500-token chunks from Vertex AI Search (with fallback to an in-memory vector store) and fetches lab ranges via ClinicalDBTool, synthesizing an evidence draft with inline citation tags.</a:t>
             </a:r>
           </a:p>
           <a:p/>
           <a:p>
             <a:r>
-              <a:t>5. Telemetry: Traces are pushed to Cloud Trace, and telemetry data (latency, cost, tokens) is streamed to BigQuery.</a:t>
+              <a:t>5. Independent Verification: The Reviewer &amp; QC agent (Gemini 3.5 Flash) operates with zero shared state. Its CitationVerifier audits every single citation bracket against retrieved chunk IDs. Only 100% verified responses are streamed back to the client.</a:t>
+            </a:r>
+          </a:p>
+          <a:p/>
+          <a:p>
+            <a:r>
+              <a:t>6. Observability: Every span is traced to Cloud Trace, and telemetry is recorded in BigQuery for continuous auditing.</a:t>
             </a:r>
           </a:p>
         </p:txBody>
@@ -4152,7 +4158,7 @@
         </p:nvSpPr>
         <p:spPr>
           <a:xfrm>
-            <a:off x="731520" y="1554480"/>
+            <a:off x="731520" y="1508760"/>
             <a:ext cx="10728655" cy="13716"/>
           </a:xfrm>
           <a:prstGeom prst="rect">
@@ -4513,7 +4519,7 @@
         </p:nvSpPr>
         <p:spPr>
           <a:xfrm>
-            <a:off x="731520" y="1554480"/>
+            <a:off x="731520" y="1508760"/>
             <a:ext cx="10728655" cy="13716"/>
           </a:xfrm>
           <a:prstGeom prst="rect">
@@ -5048,7 +5054,7 @@
         </p:nvSpPr>
         <p:spPr>
           <a:xfrm>
-            <a:off x="731520" y="1554480"/>
+            <a:off x="731520" y="1508760"/>
             <a:ext cx="10728655" cy="13716"/>
           </a:xfrm>
           <a:prstGeom prst="rect">
@@ -5087,22 +5093,22 @@
       </p:sp>
       <p:sp>
         <p:nvSpPr>
-          <p:cNvPr id="4" name="Rectangle 3"/>
+          <p:cNvPr id="4" name="Rounded Rectangle 3"/>
           <p:cNvSpPr/>
           <p:nvPr/>
         </p:nvSpPr>
         <p:spPr>
           <a:xfrm>
-            <a:off x="731520" y="1691640"/>
-            <a:ext cx="10728655" cy="640080"/>
-          </a:xfrm>
-          <a:prstGeom prst="rect">
+            <a:off x="548640" y="1600200"/>
+            <a:ext cx="11094415" cy="1188720"/>
+          </a:xfrm>
+          <a:prstGeom prst="roundRect">
             <a:avLst/>
           </a:prstGeom>
           <a:solidFill>
             <a:srgbClr val="FFFFFF"/>
           </a:solidFill>
-          <a:ln>
+          <a:ln w="12700">
             <a:solidFill>
               <a:srgbClr val="DADCE0"/>
             </a:solidFill>
@@ -5123,32 +5129,19 @@
           </a:fontRef>
         </p:style>
         <p:txBody>
-          <a:bodyPr rtlCol="0" anchor="ctr" lIns="182880" rIns="182880" tIns="91440"/>
+          <a:bodyPr rtlCol="0" anchor="ctr" lIns="137160" tIns="54864"/>
           <a:lstStyle/>
           <a:p>
             <a:pPr algn="ctr">
-              <a:defRPr sz="1050" b="1">
-                <a:solidFill>
-                  <a:srgbClr val="1A73E8"/>
-                </a:solidFill>
-                <a:latin typeface="Arial"/>
-              </a:defRPr>
-            </a:pPr>
-            <a:r>
-              <a:t>1. INGRESS &amp; PERIMETER DEFENSE</a:t>
-            </a:r>
-          </a:p>
-          <a:p>
-            <a:pPr>
-              <a:defRPr sz="950">
-                <a:solidFill>
-                  <a:srgbClr val="202124"/>
-                </a:solidFill>
-                <a:latin typeface="Arial"/>
-              </a:defRPr>
-            </a:pPr>
-            <a:r>
-              <a:t>Client (HTTPS / SSE)  ──&gt;  Cloud Armor L7 WAF  ──&gt;  Cloud Run (FastAPI)  ──&gt;  Model Armor (HIPAA PHI Redaction &amp; Prompt Guard)</a:t>
+              <a:defRPr sz="900" b="1">
+                <a:solidFill>
+                  <a:srgbClr val="5F6368"/>
+                </a:solidFill>
+                <a:latin typeface="Arial"/>
+              </a:defRPr>
+            </a:pPr>
+            <a:r>
+              <a:t>1. INGRESS &amp; PERIMETER SECURITY GATEWAY</a:t>
             </a:r>
           </a:p>
         </p:txBody>
@@ -5161,8 +5154,938 @@
         </p:nvSpPr>
         <p:spPr>
           <a:xfrm>
-            <a:off x="731520" y="2468880"/>
-            <a:ext cx="3429000" cy="2468880"/>
+            <a:off x="731520" y="1847088"/>
+            <a:ext cx="1371600" cy="822960"/>
+          </a:xfrm>
+          <a:prstGeom prst="roundRect">
+            <a:avLst/>
+          </a:prstGeom>
+          <a:solidFill>
+            <a:srgbClr val="E8F0FE"/>
+          </a:solidFill>
+          <a:ln w="15240">
+            <a:solidFill>
+              <a:srgbClr val="1A73E8"/>
+            </a:solidFill>
+          </a:ln>
+        </p:spPr>
+        <p:style>
+          <a:lnRef idx="1">
+            <a:schemeClr val="accent1"/>
+          </a:lnRef>
+          <a:fillRef idx="3">
+            <a:schemeClr val="accent1"/>
+          </a:fillRef>
+          <a:effectRef idx="2">
+            <a:schemeClr val="accent1"/>
+          </a:effectRef>
+          <a:fontRef idx="minor">
+            <a:schemeClr val="lt1"/>
+          </a:fontRef>
+        </p:style>
+        <p:txBody>
+          <a:bodyPr rtlCol="0" anchor="ctr" wrap="square" lIns="109728" rIns="109728" tIns="73152" bIns="73152"/>
+          <a:lstStyle/>
+          <a:p>
+            <a:pPr algn="ctr">
+              <a:defRPr sz="1000" b="1">
+                <a:solidFill>
+                  <a:srgbClr val="1A73E8"/>
+                </a:solidFill>
+                <a:latin typeface="Arial"/>
+              </a:defRPr>
+            </a:pPr>
+            <a:r>
+              <a:t>Clinician / UI</a:t>
+            </a:r>
+          </a:p>
+          <a:p>
+            <a:pPr>
+              <a:defRPr sz="800" b="1">
+                <a:solidFill>
+                  <a:srgbClr val="5F6368"/>
+                </a:solidFill>
+                <a:latin typeface="Arial"/>
+              </a:defRPr>
+            </a:pPr>
+            <a:r>
+              <a:t>Web App &amp; REST</a:t>
+            </a:r>
+          </a:p>
+          <a:p>
+            <a:pPr>
+              <a:spcBef>
+                <a:spcPts val="150"/>
+              </a:spcBef>
+              <a:defRPr sz="800">
+                <a:solidFill>
+                  <a:srgbClr val="202124"/>
+                </a:solidFill>
+                <a:latin typeface="Arial"/>
+              </a:defRPr>
+            </a:pPr>
+            <a:r>
+              <a:t>• HTTPS / SSE</a:t>
+            </a:r>
+          </a:p>
+          <a:p>
+            <a:pPr>
+              <a:spcBef>
+                <a:spcPts val="150"/>
+              </a:spcBef>
+              <a:defRPr sz="800">
+                <a:solidFill>
+                  <a:srgbClr val="202124"/>
+                </a:solidFill>
+                <a:latin typeface="Arial"/>
+              </a:defRPr>
+            </a:pPr>
+            <a:r>
+              <a:t>• Inline Citations</a:t>
+            </a:r>
+          </a:p>
+        </p:txBody>
+      </p:sp>
+      <p:cxnSp>
+        <p:nvCxnSpPr>
+          <p:cNvPr id="6" name="Connector 5"/>
+          <p:cNvCxnSpPr/>
+          <p:nvPr/>
+        </p:nvCxnSpPr>
+        <p:spPr>
+          <a:xfrm>
+            <a:off x="2103120" y="2258568"/>
+            <a:ext cx="320040" cy="0"/>
+          </a:xfrm>
+          <a:prstGeom prst="line">
+            <a:avLst/>
+          </a:prstGeom>
+          <a:ln w="19050">
+            <a:solidFill>
+              <a:srgbClr val="1A73E8"/>
+            </a:solidFill>
+            <a:headEnd type="triangle" w="med" len="med"/>
+          </a:ln>
+        </p:spPr>
+        <p:style>
+          <a:lnRef idx="2">
+            <a:schemeClr val="accent1"/>
+          </a:lnRef>
+          <a:fillRef idx="0">
+            <a:schemeClr val="accent1"/>
+          </a:fillRef>
+          <a:effectRef idx="1">
+            <a:schemeClr val="accent1"/>
+          </a:effectRef>
+          <a:fontRef idx="minor">
+            <a:schemeClr val="tx1"/>
+          </a:fontRef>
+        </p:style>
+      </p:cxnSp>
+      <p:sp>
+        <p:nvSpPr>
+          <p:cNvPr id="7" name="TextBox 6"/>
+          <p:cNvSpPr txBox="1"/>
+          <p:nvPr/>
+        </p:nvSpPr>
+        <p:spPr>
+          <a:xfrm>
+            <a:off x="1485900" y="2112264"/>
+            <a:ext cx="1554480" cy="219456"/>
+          </a:xfrm>
+          <a:prstGeom prst="rect">
+            <a:avLst/>
+          </a:prstGeom>
+          <a:noFill/>
+        </p:spPr>
+        <p:txBody>
+          <a:bodyPr wrap="square" lIns="0" tIns="0" rIns="0" bIns="0">
+            <a:spAutoFit/>
+          </a:bodyPr>
+          <a:lstStyle/>
+          <a:p>
+            <a:pPr>
+              <a:defRPr sz="750" b="1">
+                <a:solidFill>
+                  <a:srgbClr val="1A73E8"/>
+                </a:solidFill>
+                <a:latin typeface="Arial"/>
+              </a:defRPr>
+            </a:pPr>
+            <a:r>
+              <a:t>1. Query</a:t>
+            </a:r>
+          </a:p>
+        </p:txBody>
+      </p:sp>
+      <p:sp>
+        <p:nvSpPr>
+          <p:cNvPr id="8" name="Rounded Rectangle 7"/>
+          <p:cNvSpPr/>
+          <p:nvPr/>
+        </p:nvSpPr>
+        <p:spPr>
+          <a:xfrm>
+            <a:off x="2423160" y="1847088"/>
+            <a:ext cx="1371600" cy="822960"/>
+          </a:xfrm>
+          <a:prstGeom prst="roundRect">
+            <a:avLst/>
+          </a:prstGeom>
+          <a:solidFill>
+            <a:srgbClr val="FFFFFF"/>
+          </a:solidFill>
+          <a:ln w="15240">
+            <a:solidFill>
+              <a:srgbClr val="DADCE0"/>
+            </a:solidFill>
+          </a:ln>
+        </p:spPr>
+        <p:style>
+          <a:lnRef idx="1">
+            <a:schemeClr val="accent1"/>
+          </a:lnRef>
+          <a:fillRef idx="3">
+            <a:schemeClr val="accent1"/>
+          </a:fillRef>
+          <a:effectRef idx="2">
+            <a:schemeClr val="accent1"/>
+          </a:effectRef>
+          <a:fontRef idx="minor">
+            <a:schemeClr val="lt1"/>
+          </a:fontRef>
+        </p:style>
+        <p:txBody>
+          <a:bodyPr rtlCol="0" anchor="ctr" wrap="square" lIns="109728" rIns="109728" tIns="73152" bIns="73152"/>
+          <a:lstStyle/>
+          <a:p>
+            <a:pPr algn="ctr">
+              <a:defRPr sz="1000" b="1">
+                <a:solidFill>
+                  <a:srgbClr val="1A73E8"/>
+                </a:solidFill>
+                <a:latin typeface="Arial"/>
+              </a:defRPr>
+            </a:pPr>
+            <a:r>
+              <a:t>Cloud Armor</a:t>
+            </a:r>
+          </a:p>
+          <a:p>
+            <a:pPr>
+              <a:defRPr sz="800" b="1">
+                <a:solidFill>
+                  <a:srgbClr val="5F6368"/>
+                </a:solidFill>
+                <a:latin typeface="Arial"/>
+              </a:defRPr>
+            </a:pPr>
+            <a:r>
+              <a:t>L7 WAF &amp; DDoS</a:t>
+            </a:r>
+          </a:p>
+          <a:p>
+            <a:pPr>
+              <a:spcBef>
+                <a:spcPts val="150"/>
+              </a:spcBef>
+              <a:defRPr sz="800">
+                <a:solidFill>
+                  <a:srgbClr val="202124"/>
+                </a:solidFill>
+                <a:latin typeface="Arial"/>
+              </a:defRPr>
+            </a:pPr>
+            <a:r>
+              <a:t>• IP Throttling</a:t>
+            </a:r>
+          </a:p>
+          <a:p>
+            <a:pPr>
+              <a:spcBef>
+                <a:spcPts val="150"/>
+              </a:spcBef>
+              <a:defRPr sz="800">
+                <a:solidFill>
+                  <a:srgbClr val="202124"/>
+                </a:solidFill>
+                <a:latin typeface="Arial"/>
+              </a:defRPr>
+            </a:pPr>
+            <a:r>
+              <a:t>• Bot Defense</a:t>
+            </a:r>
+          </a:p>
+        </p:txBody>
+      </p:sp>
+      <p:cxnSp>
+        <p:nvCxnSpPr>
+          <p:cNvPr id="9" name="Connector 8"/>
+          <p:cNvCxnSpPr/>
+          <p:nvPr/>
+        </p:nvCxnSpPr>
+        <p:spPr>
+          <a:xfrm>
+            <a:off x="3794760" y="2258568"/>
+            <a:ext cx="320040" cy="0"/>
+          </a:xfrm>
+          <a:prstGeom prst="line">
+            <a:avLst/>
+          </a:prstGeom>
+          <a:ln w="19050">
+            <a:solidFill>
+              <a:srgbClr val="1A73E8"/>
+            </a:solidFill>
+            <a:headEnd type="triangle" w="med" len="med"/>
+          </a:ln>
+        </p:spPr>
+        <p:style>
+          <a:lnRef idx="2">
+            <a:schemeClr val="accent1"/>
+          </a:lnRef>
+          <a:fillRef idx="0">
+            <a:schemeClr val="accent1"/>
+          </a:fillRef>
+          <a:effectRef idx="1">
+            <a:schemeClr val="accent1"/>
+          </a:effectRef>
+          <a:fontRef idx="minor">
+            <a:schemeClr val="tx1"/>
+          </a:fontRef>
+        </p:style>
+      </p:cxnSp>
+      <p:sp>
+        <p:nvSpPr>
+          <p:cNvPr id="10" name="TextBox 9"/>
+          <p:cNvSpPr txBox="1"/>
+          <p:nvPr/>
+        </p:nvSpPr>
+        <p:spPr>
+          <a:xfrm>
+            <a:off x="3177540" y="2112264"/>
+            <a:ext cx="1554480" cy="219456"/>
+          </a:xfrm>
+          <a:prstGeom prst="rect">
+            <a:avLst/>
+          </a:prstGeom>
+          <a:noFill/>
+        </p:spPr>
+        <p:txBody>
+          <a:bodyPr wrap="square" lIns="0" tIns="0" rIns="0" bIns="0">
+            <a:spAutoFit/>
+          </a:bodyPr>
+          <a:lstStyle/>
+          <a:p>
+            <a:pPr>
+              <a:defRPr sz="750" b="1">
+                <a:solidFill>
+                  <a:srgbClr val="1A73E8"/>
+                </a:solidFill>
+                <a:latin typeface="Arial"/>
+              </a:defRPr>
+            </a:pPr>
+            <a:r>
+              <a:t>2. Clean</a:t>
+            </a:r>
+          </a:p>
+        </p:txBody>
+      </p:sp>
+      <p:sp>
+        <p:nvSpPr>
+          <p:cNvPr id="11" name="Rounded Rectangle 10"/>
+          <p:cNvSpPr/>
+          <p:nvPr/>
+        </p:nvSpPr>
+        <p:spPr>
+          <a:xfrm>
+            <a:off x="4114800" y="1847088"/>
+            <a:ext cx="1554480" cy="822960"/>
+          </a:xfrm>
+          <a:prstGeom prst="roundRect">
+            <a:avLst/>
+          </a:prstGeom>
+          <a:solidFill>
+            <a:srgbClr val="FFFFFF"/>
+          </a:solidFill>
+          <a:ln w="15240">
+            <a:solidFill>
+              <a:srgbClr val="DADCE0"/>
+            </a:solidFill>
+          </a:ln>
+        </p:spPr>
+        <p:style>
+          <a:lnRef idx="1">
+            <a:schemeClr val="accent1"/>
+          </a:lnRef>
+          <a:fillRef idx="3">
+            <a:schemeClr val="accent1"/>
+          </a:fillRef>
+          <a:effectRef idx="2">
+            <a:schemeClr val="accent1"/>
+          </a:effectRef>
+          <a:fontRef idx="minor">
+            <a:schemeClr val="lt1"/>
+          </a:fontRef>
+        </p:style>
+        <p:txBody>
+          <a:bodyPr rtlCol="0" anchor="ctr" wrap="square" lIns="109728" rIns="109728" tIns="73152" bIns="73152"/>
+          <a:lstStyle/>
+          <a:p>
+            <a:pPr algn="ctr">
+              <a:defRPr sz="1000" b="1">
+                <a:solidFill>
+                  <a:srgbClr val="1A73E8"/>
+                </a:solidFill>
+                <a:latin typeface="Arial"/>
+              </a:defRPr>
+            </a:pPr>
+            <a:r>
+              <a:t>Cloud Run Gateway</a:t>
+            </a:r>
+          </a:p>
+          <a:p>
+            <a:pPr>
+              <a:defRPr sz="800" b="1">
+                <a:solidFill>
+                  <a:srgbClr val="5F6368"/>
+                </a:solidFill>
+                <a:latin typeface="Arial"/>
+              </a:defRPr>
+            </a:pPr>
+            <a:r>
+              <a:t>FastAPI Container</a:t>
+            </a:r>
+          </a:p>
+          <a:p>
+            <a:pPr>
+              <a:spcBef>
+                <a:spcPts val="150"/>
+              </a:spcBef>
+              <a:defRPr sz="800">
+                <a:solidFill>
+                  <a:srgbClr val="202124"/>
+                </a:solidFill>
+                <a:latin typeface="Arial"/>
+              </a:defRPr>
+            </a:pPr>
+            <a:r>
+              <a:t>• Auth Token Check</a:t>
+            </a:r>
+          </a:p>
+          <a:p>
+            <a:pPr>
+              <a:spcBef>
+                <a:spcPts val="150"/>
+              </a:spcBef>
+              <a:defRPr sz="800">
+                <a:solidFill>
+                  <a:srgbClr val="202124"/>
+                </a:solidFill>
+                <a:latin typeface="Arial"/>
+              </a:defRPr>
+            </a:pPr>
+            <a:r>
+              <a:t>• Streaming Engine</a:t>
+            </a:r>
+          </a:p>
+        </p:txBody>
+      </p:sp>
+      <p:cxnSp>
+        <p:nvCxnSpPr>
+          <p:cNvPr id="12" name="Connector 11"/>
+          <p:cNvCxnSpPr/>
+          <p:nvPr/>
+        </p:nvCxnSpPr>
+        <p:spPr>
+          <a:xfrm>
+            <a:off x="5669280" y="2258568"/>
+            <a:ext cx="320040" cy="0"/>
+          </a:xfrm>
+          <a:prstGeom prst="line">
+            <a:avLst/>
+          </a:prstGeom>
+          <a:ln w="19050">
+            <a:solidFill>
+              <a:srgbClr val="1A73E8"/>
+            </a:solidFill>
+            <a:headEnd type="triangle" w="med" len="med"/>
+          </a:ln>
+        </p:spPr>
+        <p:style>
+          <a:lnRef idx="2">
+            <a:schemeClr val="accent1"/>
+          </a:lnRef>
+          <a:fillRef idx="0">
+            <a:schemeClr val="accent1"/>
+          </a:fillRef>
+          <a:effectRef idx="1">
+            <a:schemeClr val="accent1"/>
+          </a:effectRef>
+          <a:fontRef idx="minor">
+            <a:schemeClr val="tx1"/>
+          </a:fontRef>
+        </p:style>
+      </p:cxnSp>
+      <p:sp>
+        <p:nvSpPr>
+          <p:cNvPr id="13" name="TextBox 12"/>
+          <p:cNvSpPr txBox="1"/>
+          <p:nvPr/>
+        </p:nvSpPr>
+        <p:spPr>
+          <a:xfrm>
+            <a:off x="5052060" y="2112264"/>
+            <a:ext cx="1554480" cy="219456"/>
+          </a:xfrm>
+          <a:prstGeom prst="rect">
+            <a:avLst/>
+          </a:prstGeom>
+          <a:noFill/>
+        </p:spPr>
+        <p:txBody>
+          <a:bodyPr wrap="square" lIns="0" tIns="0" rIns="0" bIns="0">
+            <a:spAutoFit/>
+          </a:bodyPr>
+          <a:lstStyle/>
+          <a:p>
+            <a:pPr>
+              <a:defRPr sz="750" b="1">
+                <a:solidFill>
+                  <a:srgbClr val="1A73E8"/>
+                </a:solidFill>
+                <a:latin typeface="Arial"/>
+              </a:defRPr>
+            </a:pPr>
+            <a:r>
+              <a:t>3. Ingest</a:t>
+            </a:r>
+          </a:p>
+        </p:txBody>
+      </p:sp>
+      <p:sp>
+        <p:nvSpPr>
+          <p:cNvPr id="14" name="Rounded Rectangle 13"/>
+          <p:cNvSpPr/>
+          <p:nvPr/>
+        </p:nvSpPr>
+        <p:spPr>
+          <a:xfrm>
+            <a:off x="5989320" y="1847088"/>
+            <a:ext cx="1920240" cy="822960"/>
+          </a:xfrm>
+          <a:prstGeom prst="roundRect">
+            <a:avLst/>
+          </a:prstGeom>
+          <a:solidFill>
+            <a:srgbClr val="FFFFFF"/>
+          </a:solidFill>
+          <a:ln w="15240">
+            <a:solidFill>
+              <a:srgbClr val="1A73E8"/>
+            </a:solidFill>
+          </a:ln>
+        </p:spPr>
+        <p:style>
+          <a:lnRef idx="1">
+            <a:schemeClr val="accent1"/>
+          </a:lnRef>
+          <a:fillRef idx="3">
+            <a:schemeClr val="accent1"/>
+          </a:fillRef>
+          <a:effectRef idx="2">
+            <a:schemeClr val="accent1"/>
+          </a:effectRef>
+          <a:fontRef idx="minor">
+            <a:schemeClr val="lt1"/>
+          </a:fontRef>
+        </p:style>
+        <p:txBody>
+          <a:bodyPr rtlCol="0" anchor="ctr" wrap="square" lIns="109728" rIns="109728" tIns="73152" bIns="73152"/>
+          <a:lstStyle/>
+          <a:p>
+            <a:pPr algn="ctr">
+              <a:defRPr sz="1000" b="1">
+                <a:solidFill>
+                  <a:srgbClr val="1A73E8"/>
+                </a:solidFill>
+                <a:latin typeface="Arial"/>
+              </a:defRPr>
+            </a:pPr>
+            <a:r>
+              <a:t>Model Armor</a:t>
+            </a:r>
+          </a:p>
+          <a:p>
+            <a:pPr>
+              <a:defRPr sz="800" b="1">
+                <a:solidFill>
+                  <a:srgbClr val="5F6368"/>
+                </a:solidFill>
+                <a:latin typeface="Arial"/>
+              </a:defRPr>
+            </a:pPr>
+            <a:r>
+              <a:t>Layer 8 Guardrail</a:t>
+            </a:r>
+          </a:p>
+          <a:p>
+            <a:pPr>
+              <a:spcBef>
+                <a:spcPts val="150"/>
+              </a:spcBef>
+              <a:defRPr sz="800">
+                <a:solidFill>
+                  <a:srgbClr val="202124"/>
+                </a:solidFill>
+                <a:latin typeface="Arial"/>
+              </a:defRPr>
+            </a:pPr>
+            <a:r>
+              <a:t>• 18 HIPAA PHI De-id</a:t>
+            </a:r>
+          </a:p>
+          <a:p>
+            <a:pPr>
+              <a:spcBef>
+                <a:spcPts val="150"/>
+              </a:spcBef>
+              <a:defRPr sz="800">
+                <a:solidFill>
+                  <a:srgbClr val="202124"/>
+                </a:solidFill>
+                <a:latin typeface="Arial"/>
+              </a:defRPr>
+            </a:pPr>
+            <a:r>
+              <a:t>• Injection Filter</a:t>
+            </a:r>
+          </a:p>
+        </p:txBody>
+      </p:sp>
+      <p:cxnSp>
+        <p:nvCxnSpPr>
+          <p:cNvPr id="15" name="Connector 14"/>
+          <p:cNvCxnSpPr/>
+          <p:nvPr/>
+        </p:nvCxnSpPr>
+        <p:spPr>
+          <a:xfrm>
+            <a:off x="7909560" y="2258568"/>
+            <a:ext cx="411480" cy="0"/>
+          </a:xfrm>
+          <a:prstGeom prst="line">
+            <a:avLst/>
+          </a:prstGeom>
+          <a:ln w="19050">
+            <a:solidFill>
+              <a:srgbClr val="EA4335"/>
+            </a:solidFill>
+            <a:headEnd type="triangle" w="med" len="med"/>
+          </a:ln>
+        </p:spPr>
+        <p:style>
+          <a:lnRef idx="2">
+            <a:schemeClr val="accent1"/>
+          </a:lnRef>
+          <a:fillRef idx="0">
+            <a:schemeClr val="accent1"/>
+          </a:fillRef>
+          <a:effectRef idx="1">
+            <a:schemeClr val="accent1"/>
+          </a:effectRef>
+          <a:fontRef idx="minor">
+            <a:schemeClr val="tx1"/>
+          </a:fontRef>
+        </p:style>
+      </p:cxnSp>
+      <p:sp>
+        <p:nvSpPr>
+          <p:cNvPr id="16" name="TextBox 15"/>
+          <p:cNvSpPr txBox="1"/>
+          <p:nvPr/>
+        </p:nvSpPr>
+        <p:spPr>
+          <a:xfrm>
+            <a:off x="7338060" y="2112264"/>
+            <a:ext cx="1554480" cy="219456"/>
+          </a:xfrm>
+          <a:prstGeom prst="rect">
+            <a:avLst/>
+          </a:prstGeom>
+          <a:noFill/>
+        </p:spPr>
+        <p:txBody>
+          <a:bodyPr wrap="square" lIns="0" tIns="0" rIns="0" bIns="0">
+            <a:spAutoFit/>
+          </a:bodyPr>
+          <a:lstStyle/>
+          <a:p>
+            <a:pPr>
+              <a:defRPr sz="750" b="1">
+                <a:solidFill>
+                  <a:srgbClr val="EA4335"/>
+                </a:solidFill>
+                <a:latin typeface="Arial"/>
+              </a:defRPr>
+            </a:pPr>
+            <a:r>
+              <a:t>Refusal (&lt;5ms)</a:t>
+            </a:r>
+          </a:p>
+        </p:txBody>
+      </p:sp>
+      <p:sp>
+        <p:nvSpPr>
+          <p:cNvPr id="17" name="Rounded Rectangle 16"/>
+          <p:cNvSpPr/>
+          <p:nvPr/>
+        </p:nvSpPr>
+        <p:spPr>
+          <a:xfrm>
+            <a:off x="8321040" y="1847088"/>
+            <a:ext cx="3108960" cy="822960"/>
+          </a:xfrm>
+          <a:prstGeom prst="roundRect">
+            <a:avLst/>
+          </a:prstGeom>
+          <a:solidFill>
+            <a:srgbClr val="FEF2F2"/>
+          </a:solidFill>
+          <a:ln w="15240">
+            <a:solidFill>
+              <a:srgbClr val="EA4335"/>
+            </a:solidFill>
+          </a:ln>
+        </p:spPr>
+        <p:style>
+          <a:lnRef idx="1">
+            <a:schemeClr val="accent1"/>
+          </a:lnRef>
+          <a:fillRef idx="3">
+            <a:schemeClr val="accent1"/>
+          </a:fillRef>
+          <a:effectRef idx="2">
+            <a:schemeClr val="accent1"/>
+          </a:effectRef>
+          <a:fontRef idx="minor">
+            <a:schemeClr val="lt1"/>
+          </a:fontRef>
+        </p:style>
+        <p:txBody>
+          <a:bodyPr rtlCol="0" anchor="ctr" wrap="square" lIns="109728" rIns="109728" tIns="73152" bIns="73152"/>
+          <a:lstStyle/>
+          <a:p>
+            <a:pPr algn="ctr">
+              <a:defRPr sz="1000" b="1">
+                <a:solidFill>
+                  <a:srgbClr val="EA4335"/>
+                </a:solidFill>
+                <a:latin typeface="Arial"/>
+              </a:defRPr>
+            </a:pPr>
+            <a:r>
+              <a:t>Safe Refusal Engine Exit</a:t>
+            </a:r>
+          </a:p>
+          <a:p>
+            <a:pPr>
+              <a:defRPr sz="800" b="1">
+                <a:solidFill>
+                  <a:srgbClr val="5F6368"/>
+                </a:solidFill>
+                <a:latin typeface="Arial"/>
+              </a:defRPr>
+            </a:pPr>
+            <a:r>
+              <a:t>Boundary Lock: Diagnosis &amp; Rx Dosing</a:t>
+            </a:r>
+          </a:p>
+          <a:p>
+            <a:pPr>
+              <a:spcBef>
+                <a:spcPts val="150"/>
+              </a:spcBef>
+              <a:defRPr sz="800">
+                <a:solidFill>
+                  <a:srgbClr val="202124"/>
+                </a:solidFill>
+                <a:latin typeface="Arial"/>
+              </a:defRPr>
+            </a:pPr>
+            <a:r>
+              <a:t>• Returns emergency disclaimer</a:t>
+            </a:r>
+          </a:p>
+          <a:p>
+            <a:pPr>
+              <a:spcBef>
+                <a:spcPts val="150"/>
+              </a:spcBef>
+              <a:defRPr sz="800">
+                <a:solidFill>
+                  <a:srgbClr val="202124"/>
+                </a:solidFill>
+                <a:latin typeface="Arial"/>
+              </a:defRPr>
+            </a:pPr>
+            <a:r>
+              <a:t>• Zero LLM tokens spent</a:t>
+            </a:r>
+          </a:p>
+        </p:txBody>
+      </p:sp>
+      <p:cxnSp>
+        <p:nvCxnSpPr>
+          <p:cNvPr id="18" name="Connector 17"/>
+          <p:cNvCxnSpPr/>
+          <p:nvPr/>
+        </p:nvCxnSpPr>
+        <p:spPr>
+          <a:xfrm>
+            <a:off x="6949440" y="2670048"/>
+            <a:ext cx="0" cy="242316.0"/>
+          </a:xfrm>
+          <a:prstGeom prst="line">
+            <a:avLst/>
+          </a:prstGeom>
+          <a:ln w="19050">
+            <a:solidFill>
+              <a:srgbClr val="34A853"/>
+            </a:solidFill>
+          </a:ln>
+        </p:spPr>
+        <p:style>
+          <a:lnRef idx="2">
+            <a:schemeClr val="accent1"/>
+          </a:lnRef>
+          <a:fillRef idx="0">
+            <a:schemeClr val="accent1"/>
+          </a:fillRef>
+          <a:effectRef idx="1">
+            <a:schemeClr val="accent1"/>
+          </a:effectRef>
+          <a:fontRef idx="minor">
+            <a:schemeClr val="tx1"/>
+          </a:fontRef>
+        </p:style>
+      </p:cxnSp>
+      <p:cxnSp>
+        <p:nvCxnSpPr>
+          <p:cNvPr id="19" name="Connector 18"/>
+          <p:cNvCxnSpPr/>
+          <p:nvPr/>
+        </p:nvCxnSpPr>
+        <p:spPr>
+          <a:xfrm flipH="1">
+            <a:off x="2148840" y="2912364.0"/>
+            <a:ext cx="4800600" cy="0.0"/>
+          </a:xfrm>
+          <a:prstGeom prst="line">
+            <a:avLst/>
+          </a:prstGeom>
+          <a:ln w="19050">
+            <a:solidFill>
+              <a:srgbClr val="34A853"/>
+            </a:solidFill>
+          </a:ln>
+        </p:spPr>
+        <p:style>
+          <a:lnRef idx="2">
+            <a:schemeClr val="accent1"/>
+          </a:lnRef>
+          <a:fillRef idx="0">
+            <a:schemeClr val="accent1"/>
+          </a:fillRef>
+          <a:effectRef idx="1">
+            <a:schemeClr val="accent1"/>
+          </a:effectRef>
+          <a:fontRef idx="minor">
+            <a:schemeClr val="tx1"/>
+          </a:fontRef>
+        </p:style>
+      </p:cxnSp>
+      <p:cxnSp>
+        <p:nvCxnSpPr>
+          <p:cNvPr id="20" name="Connector 19"/>
+          <p:cNvCxnSpPr/>
+          <p:nvPr/>
+        </p:nvCxnSpPr>
+        <p:spPr>
+          <a:xfrm>
+            <a:off x="2148840" y="2912364.0"/>
+            <a:ext cx="0" cy="242316.0"/>
+          </a:xfrm>
+          <a:prstGeom prst="line">
+            <a:avLst/>
+          </a:prstGeom>
+          <a:ln w="19050">
+            <a:solidFill>
+              <a:srgbClr val="34A853"/>
+            </a:solidFill>
+            <a:headEnd type="triangle" w="med" len="med"/>
+          </a:ln>
+        </p:spPr>
+        <p:style>
+          <a:lnRef idx="2">
+            <a:schemeClr val="accent1"/>
+          </a:lnRef>
+          <a:fillRef idx="0">
+            <a:schemeClr val="accent1"/>
+          </a:fillRef>
+          <a:effectRef idx="1">
+            <a:schemeClr val="accent1"/>
+          </a:effectRef>
+          <a:fontRef idx="minor">
+            <a:schemeClr val="tx1"/>
+          </a:fontRef>
+        </p:style>
+      </p:cxnSp>
+      <p:sp>
+        <p:nvSpPr>
+          <p:cNvPr id="21" name="TextBox 20"/>
+          <p:cNvSpPr txBox="1"/>
+          <p:nvPr/>
+        </p:nvSpPr>
+        <p:spPr>
+          <a:xfrm>
+            <a:off x="3954780" y="2711196"/>
+            <a:ext cx="1554480" cy="182880"/>
+          </a:xfrm>
+          <a:prstGeom prst="rect">
+            <a:avLst/>
+          </a:prstGeom>
+          <a:noFill/>
+        </p:spPr>
+        <p:txBody>
+          <a:bodyPr wrap="none">
+            <a:spAutoFit/>
+          </a:bodyPr>
+          <a:lstStyle/>
+          <a:p>
+            <a:pPr>
+              <a:defRPr sz="750" b="1">
+                <a:solidFill>
+                  <a:srgbClr val="34A853"/>
+                </a:solidFill>
+                <a:latin typeface="Arial"/>
+              </a:defRPr>
+            </a:pPr>
+            <a:r>
+              <a:t>4. Valid Inquiry (Sanitized Query)</a:t>
+            </a:r>
+          </a:p>
+        </p:txBody>
+      </p:sp>
+      <p:sp>
+        <p:nvSpPr>
+          <p:cNvPr id="22" name="Rounded Rectangle 21"/>
+          <p:cNvSpPr/>
+          <p:nvPr/>
+        </p:nvSpPr>
+        <p:spPr>
+          <a:xfrm>
+            <a:off x="548640" y="2907792"/>
+            <a:ext cx="11094415" cy="2121408"/>
           </a:xfrm>
           <a:prstGeom prst="roundRect">
             <a:avLst/>
@@ -5191,65 +6114,33 @@
           </a:fontRef>
         </p:style>
         <p:txBody>
-          <a:bodyPr rtlCol="0" anchor="ctr" lIns="182880" rIns="182880" tIns="137160"/>
+          <a:bodyPr rtlCol="0" anchor="ctr" lIns="137160" tIns="54864"/>
           <a:lstStyle/>
           <a:p>
             <a:pPr algn="ctr">
-              <a:defRPr b="1" sz="1150">
+              <a:defRPr sz="900" b="1">
                 <a:solidFill>
                   <a:srgbClr val="1A73E8"/>
                 </a:solidFill>
-              </a:defRPr>
-            </a:pPr>
-            <a:r>
-              <a:t>Root Orchestrator (Supervisor)</a:t>
-            </a:r>
-          </a:p>
-          <a:p>
-            <a:pPr>
-              <a:defRPr b="1" sz="950">
-                <a:solidFill>
-                  <a:srgbClr val="5F6368"/>
-                </a:solidFill>
-              </a:defRPr>
-            </a:pPr>
-            <a:r>
-              <a:t>Model: Gemini 2.5 Flash</a:t>
-            </a:r>
-            <a:br/>
-          </a:p>
-          <a:p>
-            <a:pPr>
-              <a:defRPr sz="950">
-                <a:solidFill>
-                  <a:srgbClr val="202124"/>
-                </a:solidFill>
-              </a:defRPr>
-            </a:pPr>
-            <a:r>
-              <a:t>• Classifies clinical intent &amp; domain.</a:t>
-            </a:r>
-            <a:br/>
-            <a:r>
-              <a:t>• SafeRefusalEngine rejects diagnosis/dosing in &lt;5ms.</a:t>
-            </a:r>
-            <a:br/>
-            <a:r>
-              <a:t>• Enforces strict max_iterations=2 loop ceiling.</a:t>
-            </a:r>
-          </a:p>
-        </p:txBody>
-      </p:sp>
-      <p:sp>
-        <p:nvSpPr>
-          <p:cNvPr id="6" name="Rounded Rectangle 5"/>
+                <a:latin typeface="Arial"/>
+              </a:defRPr>
+            </a:pPr>
+            <a:r>
+              <a:t>2. GOOGLE ADK MULTI-AGENT CORE (SUPERVISOR-WORKER DECOUPLED TOPOLOGY)</a:t>
+            </a:r>
+          </a:p>
+        </p:txBody>
+      </p:sp>
+      <p:sp>
+        <p:nvSpPr>
+          <p:cNvPr id="23" name="Rounded Rectangle 22"/>
           <p:cNvSpPr/>
           <p:nvPr/>
         </p:nvSpPr>
         <p:spPr>
           <a:xfrm>
-            <a:off x="4370832" y="2468880"/>
-            <a:ext cx="3429000" cy="2468880"/>
+            <a:off x="731520" y="3154680"/>
+            <a:ext cx="2834640" cy="1691640"/>
           </a:xfrm>
           <a:prstGeom prst="roundRect">
             <a:avLst/>
@@ -5257,7 +6148,7 @@
           <a:solidFill>
             <a:srgbClr val="FFFFFF"/>
           </a:solidFill>
-          <a:ln w="19050">
+          <a:ln w="15240">
             <a:solidFill>
               <a:srgbClr val="1A73E8"/>
             </a:solidFill>
@@ -5278,65 +6169,182 @@
           </a:fontRef>
         </p:style>
         <p:txBody>
-          <a:bodyPr rtlCol="0" anchor="ctr" lIns="182880" rIns="182880" tIns="137160"/>
+          <a:bodyPr rtlCol="0" anchor="ctr" wrap="square" lIns="109728" rIns="109728" tIns="73152" bIns="73152"/>
           <a:lstStyle/>
           <a:p>
             <a:pPr algn="ctr">
-              <a:defRPr b="1" sz="1150">
+              <a:defRPr sz="1000" b="1">
                 <a:solidFill>
                   <a:srgbClr val="1A73E8"/>
                 </a:solidFill>
-              </a:defRPr>
-            </a:pPr>
-            <a:r>
-              <a:t>Clinical Researcher (Worker)</a:t>
-            </a:r>
-          </a:p>
-          <a:p>
-            <a:pPr>
-              <a:defRPr b="1" sz="950">
+                <a:latin typeface="Arial"/>
+              </a:defRPr>
+            </a:pPr>
+            <a:r>
+              <a:t>Root Orchestrator</a:t>
+            </a:r>
+          </a:p>
+          <a:p>
+            <a:pPr>
+              <a:defRPr sz="800" b="1">
                 <a:solidFill>
                   <a:srgbClr val="5F6368"/>
                 </a:solidFill>
-              </a:defRPr>
-            </a:pPr>
-            <a:r>
-              <a:t>Model: Gemini 2.5 Pro</a:t>
-            </a:r>
-            <a:br/>
-          </a:p>
-          <a:p>
-            <a:pPr>
-              <a:defRPr sz="950">
+                <a:latin typeface="Arial"/>
+              </a:defRPr>
+            </a:pPr>
+            <a:r>
+              <a:t>Supervisor  |  Gemini 2.5 Flash</a:t>
+            </a:r>
+          </a:p>
+          <a:p>
+            <a:pPr>
+              <a:spcBef>
+                <a:spcPts val="150"/>
+              </a:spcBef>
+              <a:defRPr sz="800">
                 <a:solidFill>
                   <a:srgbClr val="202124"/>
                 </a:solidFill>
-              </a:defRPr>
-            </a:pPr>
-            <a:r>
-              <a:t>• Queries Vertex AI Search (16.4k NIH pairs).</a:t>
-            </a:r>
-            <a:br/>
-            <a:r>
-              <a:t>• Fetches lab test ranges via ClinicalDBTool.</a:t>
-            </a:r>
-            <a:br/>
-            <a:r>
-              <a:t>• Drafts evidence synthesis with inline [1], [2] citations.</a:t>
-            </a:r>
-          </a:p>
-        </p:txBody>
-      </p:sp>
-      <p:sp>
-        <p:nvSpPr>
-          <p:cNvPr id="7" name="Rounded Rectangle 6"/>
+                <a:latin typeface="Arial"/>
+              </a:defRPr>
+            </a:pPr>
+            <a:r>
+              <a:t>• Classifies clinical intent &amp; domain</a:t>
+            </a:r>
+          </a:p>
+          <a:p>
+            <a:pPr>
+              <a:spcBef>
+                <a:spcPts val="150"/>
+              </a:spcBef>
+              <a:defRPr sz="800">
+                <a:solidFill>
+                  <a:srgbClr val="202124"/>
+                </a:solidFill>
+                <a:latin typeface="Arial"/>
+              </a:defRPr>
+            </a:pPr>
+            <a:r>
+              <a:t>• SafeRefusalEngine policy routing</a:t>
+            </a:r>
+          </a:p>
+          <a:p>
+            <a:pPr>
+              <a:spcBef>
+                <a:spcPts val="150"/>
+              </a:spcBef>
+              <a:defRPr sz="800">
+                <a:solidFill>
+                  <a:srgbClr val="202124"/>
+                </a:solidFill>
+                <a:latin typeface="Arial"/>
+              </a:defRPr>
+            </a:pPr>
+            <a:r>
+              <a:t>• Enforces max_iterations=2 loop ceiling</a:t>
+            </a:r>
+          </a:p>
+          <a:p>
+            <a:pPr>
+              <a:spcBef>
+                <a:spcPts val="150"/>
+              </a:spcBef>
+              <a:defRPr sz="800">
+                <a:solidFill>
+                  <a:srgbClr val="202124"/>
+                </a:solidFill>
+                <a:latin typeface="Arial"/>
+              </a:defRPr>
+            </a:pPr>
+            <a:r>
+              <a:t>• Maintains top-level conversation state</a:t>
+            </a:r>
+          </a:p>
+        </p:txBody>
+      </p:sp>
+      <p:cxnSp>
+        <p:nvCxnSpPr>
+          <p:cNvPr id="24" name="Connector 23"/>
+          <p:cNvCxnSpPr/>
+          <p:nvPr/>
+        </p:nvCxnSpPr>
+        <p:spPr>
+          <a:xfrm>
+            <a:off x="3566160" y="3995928"/>
+            <a:ext cx="731520" cy="0"/>
+          </a:xfrm>
+          <a:prstGeom prst="line">
+            <a:avLst/>
+          </a:prstGeom>
+          <a:ln w="19050">
+            <a:solidFill>
+              <a:srgbClr val="1A73E8"/>
+            </a:solidFill>
+            <a:headEnd type="triangle" w="med" len="med"/>
+          </a:ln>
+        </p:spPr>
+        <p:style>
+          <a:lnRef idx="2">
+            <a:schemeClr val="accent1"/>
+          </a:lnRef>
+          <a:fillRef idx="0">
+            <a:schemeClr val="accent1"/>
+          </a:fillRef>
+          <a:effectRef idx="1">
+            <a:schemeClr val="accent1"/>
+          </a:effectRef>
+          <a:fontRef idx="minor">
+            <a:schemeClr val="tx1"/>
+          </a:fontRef>
+        </p:style>
+      </p:cxnSp>
+      <p:sp>
+        <p:nvSpPr>
+          <p:cNvPr id="25" name="TextBox 24"/>
+          <p:cNvSpPr txBox="1"/>
+          <p:nvPr/>
+        </p:nvSpPr>
+        <p:spPr>
+          <a:xfrm>
+            <a:off x="3154680" y="3849624"/>
+            <a:ext cx="1554480" cy="219456"/>
+          </a:xfrm>
+          <a:prstGeom prst="rect">
+            <a:avLst/>
+          </a:prstGeom>
+          <a:noFill/>
+        </p:spPr>
+        <p:txBody>
+          <a:bodyPr wrap="square" lIns="0" tIns="0" rIns="0" bIns="0">
+            <a:spAutoFit/>
+          </a:bodyPr>
+          <a:lstStyle/>
+          <a:p>
+            <a:pPr>
+              <a:defRPr sz="750" b="1">
+                <a:solidFill>
+                  <a:srgbClr val="1A73E8"/>
+                </a:solidFill>
+                <a:latin typeface="Arial"/>
+              </a:defRPr>
+            </a:pPr>
+            <a:r>
+              <a:t>5. Route</a:t>
+            </a:r>
+          </a:p>
+        </p:txBody>
+      </p:sp>
+      <p:sp>
+        <p:nvSpPr>
+          <p:cNvPr id="26" name="Rounded Rectangle 25"/>
           <p:cNvSpPr/>
           <p:nvPr/>
         </p:nvSpPr>
         <p:spPr>
           <a:xfrm>
-            <a:off x="8001000" y="2468880"/>
-            <a:ext cx="3429000" cy="2468880"/>
+            <a:off x="4297680" y="3154680"/>
+            <a:ext cx="3200400" cy="1691640"/>
           </a:xfrm>
           <a:prstGeom prst="roundRect">
             <a:avLst/>
@@ -5344,7 +6352,7 @@
           <a:solidFill>
             <a:srgbClr val="FFFFFF"/>
           </a:solidFill>
-          <a:ln w="19050">
+          <a:ln w="15240">
             <a:solidFill>
               <a:srgbClr val="1A73E8"/>
             </a:solidFill>
@@ -5365,75 +6373,192 @@
           </a:fontRef>
         </p:style>
         <p:txBody>
-          <a:bodyPr rtlCol="0" anchor="ctr" lIns="182880" rIns="182880" tIns="137160"/>
+          <a:bodyPr rtlCol="0" anchor="ctr" wrap="square" lIns="109728" rIns="109728" tIns="73152" bIns="73152"/>
           <a:lstStyle/>
           <a:p>
             <a:pPr algn="ctr">
-              <a:defRPr b="1" sz="1150">
+              <a:defRPr sz="1000" b="1">
                 <a:solidFill>
                   <a:srgbClr val="1A73E8"/>
                 </a:solidFill>
-              </a:defRPr>
-            </a:pPr>
-            <a:r>
-              <a:t>Reviewer &amp; QC (Quality Gate)</a:t>
-            </a:r>
-          </a:p>
-          <a:p>
-            <a:pPr>
-              <a:defRPr b="1" sz="950">
+                <a:latin typeface="Arial"/>
+              </a:defRPr>
+            </a:pPr>
+            <a:r>
+              <a:t>Clinical Researcher</a:t>
+            </a:r>
+          </a:p>
+          <a:p>
+            <a:pPr>
+              <a:defRPr sz="800" b="1">
                 <a:solidFill>
                   <a:srgbClr val="5F6368"/>
                 </a:solidFill>
-              </a:defRPr>
-            </a:pPr>
-            <a:r>
-              <a:t>Model: Gemini 3.5 Flash</a:t>
-            </a:r>
-            <a:br/>
-          </a:p>
-          <a:p>
-            <a:pPr>
-              <a:defRPr sz="950">
+                <a:latin typeface="Arial"/>
+              </a:defRPr>
+            </a:pPr>
+            <a:r>
+              <a:t>Worker  |  Gemini 2.5 Pro</a:t>
+            </a:r>
+          </a:p>
+          <a:p>
+            <a:pPr>
+              <a:spcBef>
+                <a:spcPts val="150"/>
+              </a:spcBef>
+              <a:defRPr sz="800">
                 <a:solidFill>
                   <a:srgbClr val="202124"/>
                 </a:solidFill>
-              </a:defRPr>
-            </a:pPr>
-            <a:r>
-              <a:t>• Operates with zero shared hidden state.</a:t>
-            </a:r>
-            <a:br/>
-            <a:r>
-              <a:t>• CitationVerifier checks every citation against chunk IDs.</a:t>
-            </a:r>
-            <a:br/>
-            <a:r>
-              <a:t>• Strips ungrounded claims before streaming.</a:t>
-            </a:r>
-          </a:p>
-        </p:txBody>
-      </p:sp>
-      <p:sp>
-        <p:nvSpPr>
-          <p:cNvPr id="8" name="Rectangle 7"/>
+                <a:latin typeface="Arial"/>
+              </a:defRPr>
+            </a:pPr>
+            <a:r>
+              <a:t>• Deep biomedical literature reasoning</a:t>
+            </a:r>
+          </a:p>
+          <a:p>
+            <a:pPr>
+              <a:spcBef>
+                <a:spcPts val="150"/>
+              </a:spcBef>
+              <a:defRPr sz="800">
+                <a:solidFill>
+                  <a:srgbClr val="202124"/>
+                </a:solidFill>
+                <a:latin typeface="Arial"/>
+              </a:defRPr>
+            </a:pPr>
+            <a:r>
+              <a:t>• Executes semantic search over NIH data</a:t>
+            </a:r>
+          </a:p>
+          <a:p>
+            <a:pPr>
+              <a:spcBef>
+                <a:spcPts val="150"/>
+              </a:spcBef>
+              <a:defRPr sz="800">
+                <a:solidFill>
+                  <a:srgbClr val="202124"/>
+                </a:solidFill>
+                <a:latin typeface="Arial"/>
+              </a:defRPr>
+            </a:pPr>
+            <a:r>
+              <a:t>• Queries lab test reference ranges</a:t>
+            </a:r>
+          </a:p>
+          <a:p>
+            <a:pPr>
+              <a:spcBef>
+                <a:spcPts val="150"/>
+              </a:spcBef>
+              <a:defRPr sz="800">
+                <a:solidFill>
+                  <a:srgbClr val="202124"/>
+                </a:solidFill>
+                <a:latin typeface="Arial"/>
+              </a:defRPr>
+            </a:pPr>
+            <a:r>
+              <a:t>• Drafts synthesis with inline [1],[2] tags</a:t>
+            </a:r>
+          </a:p>
+        </p:txBody>
+      </p:sp>
+      <p:cxnSp>
+        <p:nvCxnSpPr>
+          <p:cNvPr id="27" name="Connector 26"/>
+          <p:cNvCxnSpPr/>
+          <p:nvPr/>
+        </p:nvCxnSpPr>
+        <p:spPr>
+          <a:xfrm>
+            <a:off x="7498079" y="3995928"/>
+            <a:ext cx="640081" cy="0"/>
+          </a:xfrm>
+          <a:prstGeom prst="line">
+            <a:avLst/>
+          </a:prstGeom>
+          <a:ln w="19050">
+            <a:solidFill>
+              <a:srgbClr val="1A73E8"/>
+            </a:solidFill>
+            <a:headEnd type="triangle" w="med" len="med"/>
+          </a:ln>
+        </p:spPr>
+        <p:style>
+          <a:lnRef idx="2">
+            <a:schemeClr val="accent1"/>
+          </a:lnRef>
+          <a:fillRef idx="0">
+            <a:schemeClr val="accent1"/>
+          </a:fillRef>
+          <a:effectRef idx="1">
+            <a:schemeClr val="accent1"/>
+          </a:effectRef>
+          <a:fontRef idx="minor">
+            <a:schemeClr val="tx1"/>
+          </a:fontRef>
+        </p:style>
+      </p:cxnSp>
+      <p:sp>
+        <p:nvSpPr>
+          <p:cNvPr id="28" name="TextBox 27"/>
+          <p:cNvSpPr txBox="1"/>
+          <p:nvPr/>
+        </p:nvSpPr>
+        <p:spPr>
+          <a:xfrm>
+            <a:off x="7040879" y="3849624"/>
+            <a:ext cx="1554480" cy="219456"/>
+          </a:xfrm>
+          <a:prstGeom prst="rect">
+            <a:avLst/>
+          </a:prstGeom>
+          <a:noFill/>
+        </p:spPr>
+        <p:txBody>
+          <a:bodyPr wrap="square" lIns="0" tIns="0" rIns="0" bIns="0">
+            <a:spAutoFit/>
+          </a:bodyPr>
+          <a:lstStyle/>
+          <a:p>
+            <a:pPr>
+              <a:defRPr sz="750" b="1">
+                <a:solidFill>
+                  <a:srgbClr val="1A73E8"/>
+                </a:solidFill>
+                <a:latin typeface="Arial"/>
+              </a:defRPr>
+            </a:pPr>
+            <a:r>
+              <a:t>8. Draft</a:t>
+            </a:r>
+          </a:p>
+        </p:txBody>
+      </p:sp>
+      <p:sp>
+        <p:nvSpPr>
+          <p:cNvPr id="29" name="Rounded Rectangle 28"/>
           <p:cNvSpPr/>
           <p:nvPr/>
         </p:nvSpPr>
         <p:spPr>
           <a:xfrm>
-            <a:off x="731520" y="5074920"/>
-            <a:ext cx="10728655" cy="594360"/>
-          </a:xfrm>
-          <a:prstGeom prst="rect">
+            <a:off x="8138160" y="3154680"/>
+            <a:ext cx="3291840" cy="1691640"/>
+          </a:xfrm>
+          <a:prstGeom prst="roundRect">
             <a:avLst/>
           </a:prstGeom>
           <a:solidFill>
             <a:srgbClr val="FFFFFF"/>
           </a:solidFill>
-          <a:ln>
+          <a:ln w="15240">
             <a:solidFill>
-              <a:srgbClr val="DADCE0"/>
+              <a:srgbClr val="34A853"/>
             </a:solidFill>
           </a:ln>
         </p:spPr>
@@ -5452,24 +6577,40 @@
           </a:fontRef>
         </p:style>
         <p:txBody>
-          <a:bodyPr rtlCol="0" anchor="ctr" lIns="182880" rIns="182880" tIns="91440"/>
+          <a:bodyPr rtlCol="0" anchor="ctr" wrap="square" lIns="109728" rIns="109728" tIns="73152" bIns="73152"/>
           <a:lstStyle/>
           <a:p>
             <a:pPr algn="ctr">
-              <a:defRPr sz="1050" b="1">
-                <a:solidFill>
-                  <a:srgbClr val="1A73E8"/>
-                </a:solidFill>
-                <a:latin typeface="Arial"/>
-              </a:defRPr>
-            </a:pPr>
-            <a:r>
-              <a:t>3. GROUNDING &amp; DATA LAYER</a:t>
-            </a:r>
-          </a:p>
-          <a:p>
-            <a:pPr>
-              <a:defRPr sz="950">
+              <a:defRPr sz="1000" b="1">
+                <a:solidFill>
+                  <a:srgbClr val="34A853"/>
+                </a:solidFill>
+                <a:latin typeface="Arial"/>
+              </a:defRPr>
+            </a:pPr>
+            <a:r>
+              <a:t>Reviewer &amp; QC Gate</a:t>
+            </a:r>
+          </a:p>
+          <a:p>
+            <a:pPr>
+              <a:defRPr sz="800" b="1">
+                <a:solidFill>
+                  <a:srgbClr val="5F6368"/>
+                </a:solidFill>
+                <a:latin typeface="Arial"/>
+              </a:defRPr>
+            </a:pPr>
+            <a:r>
+              <a:t>Auditor  |  Gemini 3.5 Flash</a:t>
+            </a:r>
+          </a:p>
+          <a:p>
+            <a:pPr>
+              <a:spcBef>
+                <a:spcPts val="150"/>
+              </a:spcBef>
+              <a:defRPr sz="800">
                 <a:solidFill>
                   <a:srgbClr val="202124"/>
                 </a:solidFill>
@@ -5477,29 +6618,77 @@
               </a:defRPr>
             </a:pPr>
             <a:r>
-              <a:t>Vertex AI Search Datastore (16.4k NIH pairs)  |  In-Memory Vector Fallback (Circuit Breaker)  |  GCS Raw XML Staging</a:t>
-            </a:r>
-          </a:p>
-        </p:txBody>
-      </p:sp>
-      <p:sp>
-        <p:nvSpPr>
-          <p:cNvPr id="9" name="Rectangle 8"/>
+              <a:t>• Zero shared hidden state (no bias)</a:t>
+            </a:r>
+          </a:p>
+          <a:p>
+            <a:pPr>
+              <a:spcBef>
+                <a:spcPts val="150"/>
+              </a:spcBef>
+              <a:defRPr sz="800">
+                <a:solidFill>
+                  <a:srgbClr val="202124"/>
+                </a:solidFill>
+                <a:latin typeface="Arial"/>
+              </a:defRPr>
+            </a:pPr>
+            <a:r>
+              <a:t>• CitationVerifier: 100% chunk ID match</a:t>
+            </a:r>
+          </a:p>
+          <a:p>
+            <a:pPr>
+              <a:spcBef>
+                <a:spcPts val="150"/>
+              </a:spcBef>
+              <a:defRPr sz="800">
+                <a:solidFill>
+                  <a:srgbClr val="202124"/>
+                </a:solidFill>
+                <a:latin typeface="Arial"/>
+              </a:defRPr>
+            </a:pPr>
+            <a:r>
+              <a:t>• Strips ungrounded/hallucinated statements</a:t>
+            </a:r>
+          </a:p>
+          <a:p>
+            <a:pPr>
+              <a:spcBef>
+                <a:spcPts val="150"/>
+              </a:spcBef>
+              <a:defRPr sz="800">
+                <a:solidFill>
+                  <a:srgbClr val="202124"/>
+                </a:solidFill>
+                <a:latin typeface="Arial"/>
+              </a:defRPr>
+            </a:pPr>
+            <a:r>
+              <a:t>• Approves streaming release to client</a:t>
+            </a:r>
+          </a:p>
+        </p:txBody>
+      </p:sp>
+      <p:sp>
+        <p:nvSpPr>
+          <p:cNvPr id="30" name="Rounded Rectangle 29"/>
           <p:cNvSpPr/>
           <p:nvPr/>
         </p:nvSpPr>
         <p:spPr>
           <a:xfrm>
-            <a:off x="731520" y="5806440"/>
-            <a:ext cx="10728655" cy="594360"/>
-          </a:xfrm>
-          <a:prstGeom prst="rect">
+            <a:off x="548640" y="5138928"/>
+            <a:ext cx="11094415" cy="1353312"/>
+          </a:xfrm>
+          <a:prstGeom prst="roundRect">
             <a:avLst/>
           </a:prstGeom>
           <a:solidFill>
             <a:srgbClr val="FFFFFF"/>
           </a:solidFill>
-          <a:ln>
+          <a:ln w="12700">
             <a:solidFill>
               <a:srgbClr val="DADCE0"/>
             </a:solidFill>
@@ -5520,11 +6709,66 @@
           </a:fontRef>
         </p:style>
         <p:txBody>
-          <a:bodyPr rtlCol="0" anchor="ctr" lIns="182880" rIns="182880" tIns="91440"/>
+          <a:bodyPr rtlCol="0" anchor="ctr" lIns="137160" tIns="54864"/>
           <a:lstStyle/>
           <a:p>
             <a:pPr algn="ctr">
-              <a:defRPr sz="1050" b="1">
+              <a:defRPr sz="900" b="1">
+                <a:solidFill>
+                  <a:srgbClr val="5F6368"/>
+                </a:solidFill>
+                <a:latin typeface="Arial"/>
+              </a:defRPr>
+            </a:pPr>
+            <a:r>
+              <a:t>3. GROUNDING DATA STORES &amp; OBSERVABILITY SINK</a:t>
+            </a:r>
+          </a:p>
+        </p:txBody>
+      </p:sp>
+      <p:sp>
+        <p:nvSpPr>
+          <p:cNvPr id="31" name="Rounded Rectangle 30"/>
+          <p:cNvSpPr/>
+          <p:nvPr/>
+        </p:nvSpPr>
+        <p:spPr>
+          <a:xfrm>
+            <a:off x="731520" y="5413248"/>
+            <a:ext cx="2560320" cy="960120"/>
+          </a:xfrm>
+          <a:prstGeom prst="roundRect">
+            <a:avLst/>
+          </a:prstGeom>
+          <a:solidFill>
+            <a:srgbClr val="FFFFFF"/>
+          </a:solidFill>
+          <a:ln w="15240">
+            <a:solidFill>
+              <a:srgbClr val="DADCE0"/>
+            </a:solidFill>
+          </a:ln>
+        </p:spPr>
+        <p:style>
+          <a:lnRef idx="1">
+            <a:schemeClr val="accent1"/>
+          </a:lnRef>
+          <a:fillRef idx="3">
+            <a:schemeClr val="accent1"/>
+          </a:fillRef>
+          <a:effectRef idx="2">
+            <a:schemeClr val="accent1"/>
+          </a:effectRef>
+          <a:fontRef idx="minor">
+            <a:schemeClr val="lt1"/>
+          </a:fontRef>
+        </p:style>
+        <p:txBody>
+          <a:bodyPr rtlCol="0" anchor="ctr" wrap="square" lIns="109728" rIns="109728" tIns="73152" bIns="73152"/>
+          <a:lstStyle/>
+          <a:p>
+            <a:pPr algn="ctr">
+              <a:defRPr sz="1000" b="1">
                 <a:solidFill>
                   <a:srgbClr val="1A73E8"/>
                 </a:solidFill>
@@ -5532,12 +6776,28 @@
               </a:defRPr>
             </a:pPr>
             <a:r>
-              <a:t>4. OBSERVABILITY &amp; CONTINUOUS EVALUATION</a:t>
-            </a:r>
-          </a:p>
-          <a:p>
-            <a:pPr>
-              <a:defRPr sz="950">
+              <a:t>Vertex AI Search</a:t>
+            </a:r>
+          </a:p>
+          <a:p>
+            <a:pPr>
+              <a:defRPr sz="800" b="1">
+                <a:solidFill>
+                  <a:srgbClr val="5F6368"/>
+                </a:solidFill>
+                <a:latin typeface="Arial"/>
+              </a:defRPr>
+            </a:pPr>
+            <a:r>
+              <a:t>Authoritative Literature Datastore</a:t>
+            </a:r>
+          </a:p>
+          <a:p>
+            <a:pPr>
+              <a:spcBef>
+                <a:spcPts val="150"/>
+              </a:spcBef>
+              <a:defRPr sz="800">
                 <a:solidFill>
                   <a:srgbClr val="202124"/>
                 </a:solidFill>
@@ -5545,7 +6805,540 @@
               </a:defRPr>
             </a:pPr>
             <a:r>
-              <a:t>OpenTelemetry Distributed Tracing  ──&gt;  Google Cloud Trace  ──&gt;  BigQuery Telemetry Sink  ──&gt;  Automated Nightly Quality Audit</a:t>
+              <a:t>• 16,400+ NIH Q&amp;A pairs indexed</a:t>
+            </a:r>
+          </a:p>
+          <a:p>
+            <a:pPr>
+              <a:spcBef>
+                <a:spcPts val="150"/>
+              </a:spcBef>
+              <a:defRPr sz="800">
+                <a:solidFill>
+                  <a:srgbClr val="202124"/>
+                </a:solidFill>
+                <a:latin typeface="Arial"/>
+              </a:defRPr>
+            </a:pPr>
+            <a:r>
+              <a:t>• 500-token semantic chunks (10% ovlp)</a:t>
+            </a:r>
+          </a:p>
+        </p:txBody>
+      </p:sp>
+      <p:sp>
+        <p:nvSpPr>
+          <p:cNvPr id="32" name="Rounded Rectangle 31"/>
+          <p:cNvSpPr/>
+          <p:nvPr/>
+        </p:nvSpPr>
+        <p:spPr>
+          <a:xfrm>
+            <a:off x="3474720" y="5413248"/>
+            <a:ext cx="2468880" cy="960120"/>
+          </a:xfrm>
+          <a:prstGeom prst="roundRect">
+            <a:avLst/>
+          </a:prstGeom>
+          <a:solidFill>
+            <a:srgbClr val="FFFFFF"/>
+          </a:solidFill>
+          <a:ln w="15240">
+            <a:solidFill>
+              <a:srgbClr val="DADCE0"/>
+            </a:solidFill>
+          </a:ln>
+        </p:spPr>
+        <p:style>
+          <a:lnRef idx="1">
+            <a:schemeClr val="accent1"/>
+          </a:lnRef>
+          <a:fillRef idx="3">
+            <a:schemeClr val="accent1"/>
+          </a:fillRef>
+          <a:effectRef idx="2">
+            <a:schemeClr val="accent1"/>
+          </a:effectRef>
+          <a:fontRef idx="minor">
+            <a:schemeClr val="lt1"/>
+          </a:fontRef>
+        </p:style>
+        <p:txBody>
+          <a:bodyPr rtlCol="0" anchor="ctr" wrap="square" lIns="109728" rIns="109728" tIns="73152" bIns="73152"/>
+          <a:lstStyle/>
+          <a:p>
+            <a:pPr algn="ctr">
+              <a:defRPr sz="1000" b="1">
+                <a:solidFill>
+                  <a:srgbClr val="1A73E8"/>
+                </a:solidFill>
+                <a:latin typeface="Arial"/>
+              </a:defRPr>
+            </a:pPr>
+            <a:r>
+              <a:t>ClinicalDBTool</a:t>
+            </a:r>
+          </a:p>
+          <a:p>
+            <a:pPr>
+              <a:defRPr sz="800" b="1">
+                <a:solidFill>
+                  <a:srgbClr val="5F6368"/>
+                </a:solidFill>
+                <a:latin typeface="Arial"/>
+              </a:defRPr>
+            </a:pPr>
+            <a:r>
+              <a:t>Structured Reference Database</a:t>
+            </a:r>
+          </a:p>
+          <a:p>
+            <a:pPr>
+              <a:spcBef>
+                <a:spcPts val="150"/>
+              </a:spcBef>
+              <a:defRPr sz="800">
+                <a:solidFill>
+                  <a:srgbClr val="202124"/>
+                </a:solidFill>
+                <a:latin typeface="Arial"/>
+              </a:defRPr>
+            </a:pPr>
+            <a:r>
+              <a:t>• Lab test reference ranges</a:t>
+            </a:r>
+          </a:p>
+          <a:p>
+            <a:pPr>
+              <a:spcBef>
+                <a:spcPts val="150"/>
+              </a:spcBef>
+              <a:defRPr sz="800">
+                <a:solidFill>
+                  <a:srgbClr val="202124"/>
+                </a:solidFill>
+                <a:latin typeface="Arial"/>
+              </a:defRPr>
+            </a:pPr>
+            <a:r>
+              <a:t>• Diagnostic biomarker thresholds</a:t>
+            </a:r>
+          </a:p>
+        </p:txBody>
+      </p:sp>
+      <p:sp>
+        <p:nvSpPr>
+          <p:cNvPr id="33" name="Rounded Rectangle 32"/>
+          <p:cNvSpPr/>
+          <p:nvPr/>
+        </p:nvSpPr>
+        <p:spPr>
+          <a:xfrm>
+            <a:off x="6126480" y="5413248"/>
+            <a:ext cx="2560320" cy="960120"/>
+          </a:xfrm>
+          <a:prstGeom prst="roundRect">
+            <a:avLst/>
+          </a:prstGeom>
+          <a:solidFill>
+            <a:srgbClr val="FFFFFF"/>
+          </a:solidFill>
+          <a:ln w="15240">
+            <a:solidFill>
+              <a:srgbClr val="DADCE0"/>
+            </a:solidFill>
+          </a:ln>
+        </p:spPr>
+        <p:style>
+          <a:lnRef idx="1">
+            <a:schemeClr val="accent1"/>
+          </a:lnRef>
+          <a:fillRef idx="3">
+            <a:schemeClr val="accent1"/>
+          </a:fillRef>
+          <a:effectRef idx="2">
+            <a:schemeClr val="accent1"/>
+          </a:effectRef>
+          <a:fontRef idx="minor">
+            <a:schemeClr val="lt1"/>
+          </a:fontRef>
+        </p:style>
+        <p:txBody>
+          <a:bodyPr rtlCol="0" anchor="ctr" wrap="square" lIns="109728" rIns="109728" tIns="73152" bIns="73152"/>
+          <a:lstStyle/>
+          <a:p>
+            <a:pPr algn="ctr">
+              <a:defRPr sz="1000" b="1">
+                <a:solidFill>
+                  <a:srgbClr val="1A73E8"/>
+                </a:solidFill>
+                <a:latin typeface="Arial"/>
+              </a:defRPr>
+            </a:pPr>
+            <a:r>
+              <a:t>Vector DB Fallback</a:t>
+            </a:r>
+          </a:p>
+          <a:p>
+            <a:pPr>
+              <a:defRPr sz="800" b="1">
+                <a:solidFill>
+                  <a:srgbClr val="5F6368"/>
+                </a:solidFill>
+                <a:latin typeface="Arial"/>
+              </a:defRPr>
+            </a:pPr>
+            <a:r>
+              <a:t>Circuit Breaker Redundancy</a:t>
+            </a:r>
+          </a:p>
+          <a:p>
+            <a:pPr>
+              <a:spcBef>
+                <a:spcPts val="150"/>
+              </a:spcBef>
+              <a:defRPr sz="800">
+                <a:solidFill>
+                  <a:srgbClr val="202124"/>
+                </a:solidFill>
+                <a:latin typeface="Arial"/>
+              </a:defRPr>
+            </a:pPr>
+            <a:r>
+              <a:t>• Local FAISS in-memory store</a:t>
+            </a:r>
+          </a:p>
+          <a:p>
+            <a:pPr>
+              <a:spcBef>
+                <a:spcPts val="150"/>
+              </a:spcBef>
+              <a:defRPr sz="800">
+                <a:solidFill>
+                  <a:srgbClr val="202124"/>
+                </a:solidFill>
+                <a:latin typeface="Arial"/>
+              </a:defRPr>
+            </a:pPr>
+            <a:r>
+              <a:t>• Sub-50ms fallback on 504 timeouts</a:t>
+            </a:r>
+          </a:p>
+        </p:txBody>
+      </p:sp>
+      <p:sp>
+        <p:nvSpPr>
+          <p:cNvPr id="34" name="Rounded Rectangle 33"/>
+          <p:cNvSpPr/>
+          <p:nvPr/>
+        </p:nvSpPr>
+        <p:spPr>
+          <a:xfrm>
+            <a:off x="8869680" y="5413248"/>
+            <a:ext cx="2560320" cy="960120"/>
+          </a:xfrm>
+          <a:prstGeom prst="roundRect">
+            <a:avLst/>
+          </a:prstGeom>
+          <a:solidFill>
+            <a:srgbClr val="FFFFFF"/>
+          </a:solidFill>
+          <a:ln w="15240">
+            <a:solidFill>
+              <a:srgbClr val="DADCE0"/>
+            </a:solidFill>
+          </a:ln>
+        </p:spPr>
+        <p:style>
+          <a:lnRef idx="1">
+            <a:schemeClr val="accent1"/>
+          </a:lnRef>
+          <a:fillRef idx="3">
+            <a:schemeClr val="accent1"/>
+          </a:fillRef>
+          <a:effectRef idx="2">
+            <a:schemeClr val="accent1"/>
+          </a:effectRef>
+          <a:fontRef idx="minor">
+            <a:schemeClr val="lt1"/>
+          </a:fontRef>
+        </p:style>
+        <p:txBody>
+          <a:bodyPr rtlCol="0" anchor="ctr" wrap="square" lIns="109728" rIns="109728" tIns="73152" bIns="73152"/>
+          <a:lstStyle/>
+          <a:p>
+            <a:pPr algn="ctr">
+              <a:defRPr sz="1000" b="1">
+                <a:solidFill>
+                  <a:srgbClr val="1A73E8"/>
+                </a:solidFill>
+                <a:latin typeface="Arial"/>
+              </a:defRPr>
+            </a:pPr>
+            <a:r>
+              <a:t>Cloud Trace &amp; BigQuery</a:t>
+            </a:r>
+          </a:p>
+          <a:p>
+            <a:pPr>
+              <a:defRPr sz="800" b="1">
+                <a:solidFill>
+                  <a:srgbClr val="5F6368"/>
+                </a:solidFill>
+                <a:latin typeface="Arial"/>
+              </a:defRPr>
+            </a:pPr>
+            <a:r>
+              <a:t>Observability &amp; Quality Sink</a:t>
+            </a:r>
+          </a:p>
+          <a:p>
+            <a:pPr>
+              <a:spcBef>
+                <a:spcPts val="150"/>
+              </a:spcBef>
+              <a:defRPr sz="800">
+                <a:solidFill>
+                  <a:srgbClr val="202124"/>
+                </a:solidFill>
+                <a:latin typeface="Arial"/>
+              </a:defRPr>
+            </a:pPr>
+            <a:r>
+              <a:t>• OpenTelemetry distributed spans</a:t>
+            </a:r>
+          </a:p>
+          <a:p>
+            <a:pPr>
+              <a:spcBef>
+                <a:spcPts val="150"/>
+              </a:spcBef>
+              <a:defRPr sz="800">
+                <a:solidFill>
+                  <a:srgbClr val="202124"/>
+                </a:solidFill>
+                <a:latin typeface="Arial"/>
+              </a:defRPr>
+            </a:pPr>
+            <a:r>
+              <a:t>• Nightly automated evaluation audits</a:t>
+            </a:r>
+          </a:p>
+        </p:txBody>
+      </p:sp>
+      <p:cxnSp>
+        <p:nvCxnSpPr>
+          <p:cNvPr id="35" name="Connector 34"/>
+          <p:cNvCxnSpPr/>
+          <p:nvPr/>
+        </p:nvCxnSpPr>
+        <p:spPr>
+          <a:xfrm>
+            <a:off x="5212080" y="4846320"/>
+            <a:ext cx="0" cy="566928"/>
+          </a:xfrm>
+          <a:prstGeom prst="line">
+            <a:avLst/>
+          </a:prstGeom>
+          <a:ln w="19050">
+            <a:solidFill>
+              <a:srgbClr val="1A73E8"/>
+            </a:solidFill>
+            <a:headEnd type="triangle" w="med" len="med"/>
+          </a:ln>
+        </p:spPr>
+        <p:style>
+          <a:lnRef idx="2">
+            <a:schemeClr val="accent1"/>
+          </a:lnRef>
+          <a:fillRef idx="0">
+            <a:schemeClr val="accent1"/>
+          </a:fillRef>
+          <a:effectRef idx="1">
+            <a:schemeClr val="accent1"/>
+          </a:effectRef>
+          <a:fontRef idx="minor">
+            <a:schemeClr val="tx1"/>
+          </a:fontRef>
+        </p:style>
+      </p:cxnSp>
+      <p:sp>
+        <p:nvSpPr>
+          <p:cNvPr id="36" name="TextBox 35"/>
+          <p:cNvSpPr txBox="1"/>
+          <p:nvPr/>
+        </p:nvSpPr>
+        <p:spPr>
+          <a:xfrm>
+            <a:off x="4663440" y="5038344"/>
+            <a:ext cx="1554480" cy="219456"/>
+          </a:xfrm>
+          <a:prstGeom prst="rect">
+            <a:avLst/>
+          </a:prstGeom>
+          <a:noFill/>
+        </p:spPr>
+        <p:txBody>
+          <a:bodyPr wrap="square" lIns="0" tIns="0" rIns="0" bIns="0">
+            <a:spAutoFit/>
+          </a:bodyPr>
+          <a:lstStyle/>
+          <a:p>
+            <a:pPr>
+              <a:defRPr sz="750" b="1">
+                <a:solidFill>
+                  <a:srgbClr val="1A73E8"/>
+                </a:solidFill>
+                <a:latin typeface="Arial"/>
+              </a:defRPr>
+            </a:pPr>
+            <a:r>
+              <a:t>6. Query</a:t>
+            </a:r>
+          </a:p>
+        </p:txBody>
+      </p:sp>
+      <p:cxnSp>
+        <p:nvCxnSpPr>
+          <p:cNvPr id="37" name="Connector 36"/>
+          <p:cNvCxnSpPr/>
+          <p:nvPr/>
+        </p:nvCxnSpPr>
+        <p:spPr>
+          <a:xfrm flipV="1">
+            <a:off x="5943600" y="4846320"/>
+            <a:ext cx="0" cy="566928"/>
+          </a:xfrm>
+          <a:prstGeom prst="line">
+            <a:avLst/>
+          </a:prstGeom>
+          <a:ln w="19050">
+            <a:solidFill>
+              <a:srgbClr val="1A73E8"/>
+            </a:solidFill>
+            <a:headEnd type="triangle" w="med" len="med"/>
+          </a:ln>
+        </p:spPr>
+        <p:style>
+          <a:lnRef idx="2">
+            <a:schemeClr val="accent1"/>
+          </a:lnRef>
+          <a:fillRef idx="0">
+            <a:schemeClr val="accent1"/>
+          </a:fillRef>
+          <a:effectRef idx="1">
+            <a:schemeClr val="accent1"/>
+          </a:effectRef>
+          <a:fontRef idx="minor">
+            <a:schemeClr val="tx1"/>
+          </a:fontRef>
+        </p:style>
+      </p:cxnSp>
+      <p:sp>
+        <p:nvSpPr>
+          <p:cNvPr id="38" name="TextBox 37"/>
+          <p:cNvSpPr txBox="1"/>
+          <p:nvPr/>
+        </p:nvSpPr>
+        <p:spPr>
+          <a:xfrm>
+            <a:off x="5440680" y="5202936"/>
+            <a:ext cx="1554480" cy="219456"/>
+          </a:xfrm>
+          <a:prstGeom prst="rect">
+            <a:avLst/>
+          </a:prstGeom>
+          <a:noFill/>
+        </p:spPr>
+        <p:txBody>
+          <a:bodyPr wrap="square" lIns="0" tIns="0" rIns="0" bIns="0">
+            <a:spAutoFit/>
+          </a:bodyPr>
+          <a:lstStyle/>
+          <a:p>
+            <a:pPr>
+              <a:defRPr sz="750" b="1">
+                <a:solidFill>
+                  <a:srgbClr val="1A73E8"/>
+                </a:solidFill>
+                <a:latin typeface="Arial"/>
+              </a:defRPr>
+            </a:pPr>
+            <a:r>
+              <a:t>7. Chunks</a:t>
+            </a:r>
+          </a:p>
+        </p:txBody>
+      </p:sp>
+      <p:cxnSp>
+        <p:nvCxnSpPr>
+          <p:cNvPr id="39" name="Connector 38"/>
+          <p:cNvCxnSpPr/>
+          <p:nvPr/>
+        </p:nvCxnSpPr>
+        <p:spPr>
+          <a:xfrm>
+            <a:off x="10149840" y="4846320"/>
+            <a:ext cx="0" cy="566928"/>
+          </a:xfrm>
+          <a:prstGeom prst="line">
+            <a:avLst/>
+          </a:prstGeom>
+          <a:ln w="19050">
+            <a:solidFill>
+              <a:srgbClr val="5F6368"/>
+            </a:solidFill>
+            <a:headEnd type="triangle" w="med" len="med"/>
+            <a:prstDash val="dash"/>
+          </a:ln>
+        </p:spPr>
+        <p:style>
+          <a:lnRef idx="2">
+            <a:schemeClr val="accent1"/>
+          </a:lnRef>
+          <a:fillRef idx="0">
+            <a:schemeClr val="accent1"/>
+          </a:fillRef>
+          <a:effectRef idx="1">
+            <a:schemeClr val="accent1"/>
+          </a:effectRef>
+          <a:fontRef idx="minor">
+            <a:schemeClr val="tx1"/>
+          </a:fontRef>
+        </p:style>
+      </p:cxnSp>
+      <p:sp>
+        <p:nvSpPr>
+          <p:cNvPr id="40" name="TextBox 39"/>
+          <p:cNvSpPr txBox="1"/>
+          <p:nvPr/>
+        </p:nvSpPr>
+        <p:spPr>
+          <a:xfrm>
+            <a:off x="9692640" y="5129784"/>
+            <a:ext cx="1554480" cy="219456"/>
+          </a:xfrm>
+          <a:prstGeom prst="rect">
+            <a:avLst/>
+          </a:prstGeom>
+          <a:noFill/>
+        </p:spPr>
+        <p:txBody>
+          <a:bodyPr wrap="square" lIns="0" tIns="0" rIns="0" bIns="0">
+            <a:spAutoFit/>
+          </a:bodyPr>
+          <a:lstStyle/>
+          <a:p>
+            <a:pPr>
+              <a:defRPr sz="750" b="1">
+                <a:solidFill>
+                  <a:srgbClr val="5F6368"/>
+                </a:solidFill>
+                <a:latin typeface="Arial"/>
+              </a:defRPr>
+            </a:pPr>
+            <a:r>
+              <a:t>Telemetry</a:t>
             </a:r>
           </a:p>
         </p:txBody>
@@ -5636,7 +7429,7 @@
         </p:nvSpPr>
         <p:spPr>
           <a:xfrm>
-            <a:off x="731520" y="1554480"/>
+            <a:off x="731520" y="1508760"/>
             <a:ext cx="10728655" cy="13716"/>
           </a:xfrm>
           <a:prstGeom prst="rect">

</xml_diff>

<commit_message>
feat(slides): streamline element boxes to minimal descriptors and add detailed protocol data-flow arrows
</commit_message>
<xml_diff>
--- a/docs/medquad_capstone_presentation.pptx
+++ b/docs/medquad_capstone_presentation.pptx
@@ -781,37 +781,37 @@
           <a:p/>
           <a:p>
             <a:r>
-              <a:t>1. Ingress &amp; Perimeter: Clinician queries enter via Cloud Armor and FastAPI on Cloud Run. Model Armor performs Layer 8 guardrails—scrubbing 18 HIPAA Safe Harbor identifiers and filtering jailbreak injections.</a:t>
+              <a:t>1. Ingress &amp; Perimeter: Clinician queries enter via Cloud Armor and FastAPI on Cloud Run. Model Armor scrubs 18 HIPAA PHI identifiers.</a:t>
             </a:r>
           </a:p>
           <a:p/>
           <a:p>
             <a:r>
-              <a:t>2. Safe Refusal Branch: If the user asks for personal medical advice or dosing, the Safe Refusal Engine exits in under 5ms without invoking model tokens.</a:t>
+              <a:t>2. Safe Refusal Branch: If personal medical advice or dosing is detected, it exits in &lt;5ms without model token consumption.</a:t>
             </a:r>
           </a:p>
           <a:p/>
           <a:p>
             <a:r>
-              <a:t>3. Multi-Agent Orchestration: If valid, the query passes to the Root Orchestrator (Gemini 2.5 Flash), which classifies intent and routes to the Clinical Researcher (Gemini 2.5 Pro).</a:t>
+              <a:t>3. Multi-Agent Orchestration: Root Orchestrator (Gemini 2.5 Flash) routes to Clinical Researcher (Gemini 2.5 Pro).</a:t>
             </a:r>
           </a:p>
           <a:p/>
           <a:p>
             <a:r>
-              <a:t>4. Grounding: The Researcher retrieves 500-token chunks from Vertex AI Search (with fallback to an in-memory vector store) and fetches lab ranges via ClinicalDBTool, synthesizing an evidence draft with inline citation tags.</a:t>
+              <a:t>4. Grounding: Researcher retrieves 500-token chunks from Vertex AI Search and queries ClinicalDBTool.</a:t>
             </a:r>
           </a:p>
           <a:p/>
           <a:p>
             <a:r>
-              <a:t>5. Independent Verification: The Reviewer &amp; QC agent (Gemini 3.5 Flash) operates with zero shared state. Its CitationVerifier audits every single citation bracket against retrieved chunk IDs. Only 100% verified responses are streamed back to the client.</a:t>
+              <a:t>5. Independent Verification: Reviewer &amp; QC gate (Gemini 3.5 Flash) audits 100% citation ID matching before streaming release.</a:t>
             </a:r>
           </a:p>
           <a:p/>
           <a:p>
             <a:r>
-              <a:t>6. Observability: Every span is traced to Cloud Trace, and telemetry is recorded in BigQuery for continuous auditing.</a:t>
+              <a:t>6. Observability: Spans are sent to Cloud Trace, and telemetry is logged to BigQuery.</a:t>
             </a:r>
           </a:p>
         </p:txBody>
@@ -5100,7 +5100,7 @@
         <p:spPr>
           <a:xfrm>
             <a:off x="548640" y="1600200"/>
-            <a:ext cx="11094415" cy="1188720"/>
+            <a:ext cx="11094415" cy="1115568"/>
           </a:xfrm>
           <a:prstGeom prst="roundRect">
             <a:avLst/>
@@ -5133,7 +5133,7 @@
           <a:lstStyle/>
           <a:p>
             <a:pPr algn="ctr">
-              <a:defRPr sz="900" b="1">
+              <a:defRPr sz="850" b="1">
                 <a:solidFill>
                   <a:srgbClr val="5F6368"/>
                 </a:solidFill>
@@ -5141,7 +5141,7 @@
               </a:defRPr>
             </a:pPr>
             <a:r>
-              <a:t>1. INGRESS &amp; PERIMETER SECURITY GATEWAY</a:t>
+              <a:t>1. INGRESS &amp; PERIMETER DEFENSE</a:t>
             </a:r>
           </a:p>
         </p:txBody>
@@ -5155,7 +5155,7 @@
         <p:spPr>
           <a:xfrm>
             <a:off x="731520" y="1847088"/>
-            <a:ext cx="1371600" cy="822960"/>
+            <a:ext cx="1280160" cy="731520"/>
           </a:xfrm>
           <a:prstGeom prst="roundRect">
             <a:avLst/>
@@ -5163,7 +5163,7 @@
           <a:solidFill>
             <a:srgbClr val="E8F0FE"/>
           </a:solidFill>
-          <a:ln w="15240">
+          <a:ln w="19050">
             <a:solidFill>
               <a:srgbClr val="1A73E8"/>
             </a:solidFill>
@@ -5184,11 +5184,11 @@
           </a:fontRef>
         </p:style>
         <p:txBody>
-          <a:bodyPr rtlCol="0" anchor="ctr" wrap="square" lIns="109728" rIns="109728" tIns="73152" bIns="73152"/>
+          <a:bodyPr rtlCol="0" anchor="ctr" wrap="square" lIns="109728" rIns="109728" tIns="91440" bIns="91440"/>
           <a:lstStyle/>
           <a:p>
             <a:pPr algn="ctr">
-              <a:defRPr sz="1000" b="1">
+              <a:defRPr sz="1050" b="1">
                 <a:solidFill>
                   <a:srgbClr val="1A73E8"/>
                 </a:solidFill>
@@ -5196,44 +5196,31 @@
               </a:defRPr>
             </a:pPr>
             <a:r>
-              <a:t>Clinician / UI</a:t>
-            </a:r>
-          </a:p>
-          <a:p>
-            <a:pPr>
-              <a:defRPr sz="800" b="1">
-                <a:solidFill>
-                  <a:srgbClr val="5F6368"/>
-                </a:solidFill>
-                <a:latin typeface="Arial"/>
-              </a:defRPr>
-            </a:pPr>
-            <a:r>
-              <a:t>Web App &amp; REST</a:t>
+              <a:t>Clinician UI</a:t>
             </a:r>
           </a:p>
           <a:p>
             <a:pPr>
               <a:spcBef>
-                <a:spcPts val="150"/>
+                <a:spcPts val="200"/>
               </a:spcBef>
-              <a:defRPr sz="800">
-                <a:solidFill>
-                  <a:srgbClr val="202124"/>
-                </a:solidFill>
-                <a:latin typeface="Arial"/>
-              </a:defRPr>
-            </a:pPr>
-            <a:r>
-              <a:t>• HTTPS / SSE</a:t>
+              <a:defRPr sz="850" b="1">
+                <a:solidFill>
+                  <a:srgbClr val="5F6368"/>
+                </a:solidFill>
+                <a:latin typeface="Arial"/>
+              </a:defRPr>
+            </a:pPr>
+            <a:r>
+              <a:t>Web &amp; REST API</a:t>
             </a:r>
           </a:p>
           <a:p>
             <a:pPr>
               <a:spcBef>
-                <a:spcPts val="150"/>
+                <a:spcPts val="300"/>
               </a:spcBef>
-              <a:defRPr sz="800">
+              <a:defRPr sz="850">
                 <a:solidFill>
                   <a:srgbClr val="202124"/>
                 </a:solidFill>
@@ -5241,7 +5228,7 @@
               </a:defRPr>
             </a:pPr>
             <a:r>
-              <a:t>• Inline Citations</a:t>
+              <a:t>HTTPS / SSE streaming</a:t>
             </a:r>
           </a:p>
         </p:txBody>
@@ -5254,8 +5241,8 @@
         </p:nvCxnSpPr>
         <p:spPr>
           <a:xfrm>
-            <a:off x="2103120" y="2258568"/>
-            <a:ext cx="320040" cy="0"/>
+            <a:off x="2011680" y="2212848"/>
+            <a:ext cx="548640" cy="0"/>
           </a:xfrm>
           <a:prstGeom prst="line">
             <a:avLst/>
@@ -5290,8 +5277,8 @@
         </p:nvSpPr>
         <p:spPr>
           <a:xfrm>
-            <a:off x="1485900" y="2112264"/>
-            <a:ext cx="1554480" cy="219456"/>
+            <a:off x="1280160" y="2048256"/>
+            <a:ext cx="2011680" cy="219456"/>
           </a:xfrm>
           <a:prstGeom prst="rect">
             <a:avLst/>
@@ -5313,7 +5300,7 @@
               </a:defRPr>
             </a:pPr>
             <a:r>
-              <a:t>1. Query</a:t>
+              <a:t>1. HTTPS Inquiry</a:t>
             </a:r>
           </a:p>
         </p:txBody>
@@ -5326,8 +5313,8 @@
         </p:nvSpPr>
         <p:spPr>
           <a:xfrm>
-            <a:off x="2423160" y="1847088"/>
-            <a:ext cx="1371600" cy="822960"/>
+            <a:off x="2560320" y="1847088"/>
+            <a:ext cx="1280160" cy="731520"/>
           </a:xfrm>
           <a:prstGeom prst="roundRect">
             <a:avLst/>
@@ -5335,7 +5322,7 @@
           <a:solidFill>
             <a:srgbClr val="FFFFFF"/>
           </a:solidFill>
-          <a:ln w="15240">
+          <a:ln w="12700">
             <a:solidFill>
               <a:srgbClr val="DADCE0"/>
             </a:solidFill>
@@ -5356,11 +5343,11 @@
           </a:fontRef>
         </p:style>
         <p:txBody>
-          <a:bodyPr rtlCol="0" anchor="ctr" wrap="square" lIns="109728" rIns="109728" tIns="73152" bIns="73152"/>
+          <a:bodyPr rtlCol="0" anchor="ctr" wrap="square" lIns="109728" rIns="109728" tIns="91440" bIns="91440"/>
           <a:lstStyle/>
           <a:p>
             <a:pPr algn="ctr">
-              <a:defRPr sz="1000" b="1">
+              <a:defRPr sz="1050" b="1">
                 <a:solidFill>
                   <a:srgbClr val="1A73E8"/>
                 </a:solidFill>
@@ -5369,43 +5356,30 @@
             </a:pPr>
             <a:r>
               <a:t>Cloud Armor</a:t>
-            </a:r>
-          </a:p>
-          <a:p>
-            <a:pPr>
-              <a:defRPr sz="800" b="1">
-                <a:solidFill>
-                  <a:srgbClr val="5F6368"/>
-                </a:solidFill>
-                <a:latin typeface="Arial"/>
-              </a:defRPr>
-            </a:pPr>
-            <a:r>
-              <a:t>L7 WAF &amp; DDoS</a:t>
             </a:r>
           </a:p>
           <a:p>
             <a:pPr>
               <a:spcBef>
-                <a:spcPts val="150"/>
+                <a:spcPts val="200"/>
               </a:spcBef>
-              <a:defRPr sz="800">
-                <a:solidFill>
-                  <a:srgbClr val="202124"/>
-                </a:solidFill>
-                <a:latin typeface="Arial"/>
-              </a:defRPr>
-            </a:pPr>
-            <a:r>
-              <a:t>• IP Throttling</a:t>
+              <a:defRPr sz="850" b="1">
+                <a:solidFill>
+                  <a:srgbClr val="5F6368"/>
+                </a:solidFill>
+                <a:latin typeface="Arial"/>
+              </a:defRPr>
+            </a:pPr>
+            <a:r>
+              <a:t>L7 WAF &amp; DDoS</a:t>
             </a:r>
           </a:p>
           <a:p>
             <a:pPr>
               <a:spcBef>
-                <a:spcPts val="150"/>
+                <a:spcPts val="300"/>
               </a:spcBef>
-              <a:defRPr sz="800">
+              <a:defRPr sz="850">
                 <a:solidFill>
                   <a:srgbClr val="202124"/>
                 </a:solidFill>
@@ -5413,7 +5387,7 @@
               </a:defRPr>
             </a:pPr>
             <a:r>
-              <a:t>• Bot Defense</a:t>
+              <a:t>Rate &amp; bot filtering</a:t>
             </a:r>
           </a:p>
         </p:txBody>
@@ -5426,8 +5400,8 @@
         </p:nvCxnSpPr>
         <p:spPr>
           <a:xfrm>
-            <a:off x="3794760" y="2258568"/>
-            <a:ext cx="320040" cy="0"/>
+            <a:off x="3840480" y="2212848"/>
+            <a:ext cx="548640" cy="0"/>
           </a:xfrm>
           <a:prstGeom prst="line">
             <a:avLst/>
@@ -5462,8 +5436,8 @@
         </p:nvSpPr>
         <p:spPr>
           <a:xfrm>
-            <a:off x="3177540" y="2112264"/>
-            <a:ext cx="1554480" cy="219456"/>
+            <a:off x="3108960" y="2048256"/>
+            <a:ext cx="2011680" cy="219456"/>
           </a:xfrm>
           <a:prstGeom prst="rect">
             <a:avLst/>
@@ -5485,7 +5459,7 @@
               </a:defRPr>
             </a:pPr>
             <a:r>
-              <a:t>2. Clean</a:t>
+              <a:t>2. Clean Traffic</a:t>
             </a:r>
           </a:p>
         </p:txBody>
@@ -5498,8 +5472,8 @@
         </p:nvSpPr>
         <p:spPr>
           <a:xfrm>
-            <a:off x="4114800" y="1847088"/>
-            <a:ext cx="1554480" cy="822960"/>
+            <a:off x="4389120" y="1847088"/>
+            <a:ext cx="1371600" cy="731520"/>
           </a:xfrm>
           <a:prstGeom prst="roundRect">
             <a:avLst/>
@@ -5507,7 +5481,7 @@
           <a:solidFill>
             <a:srgbClr val="FFFFFF"/>
           </a:solidFill>
-          <a:ln w="15240">
+          <a:ln w="12700">
             <a:solidFill>
               <a:srgbClr val="DADCE0"/>
             </a:solidFill>
@@ -5528,11 +5502,11 @@
           </a:fontRef>
         </p:style>
         <p:txBody>
-          <a:bodyPr rtlCol="0" anchor="ctr" wrap="square" lIns="109728" rIns="109728" tIns="73152" bIns="73152"/>
+          <a:bodyPr rtlCol="0" anchor="ctr" wrap="square" lIns="109728" rIns="109728" tIns="91440" bIns="91440"/>
           <a:lstStyle/>
           <a:p>
             <a:pPr algn="ctr">
-              <a:defRPr sz="1000" b="1">
+              <a:defRPr sz="1050" b="1">
                 <a:solidFill>
                   <a:srgbClr val="1A73E8"/>
                 </a:solidFill>
@@ -5541,43 +5515,30 @@
             </a:pPr>
             <a:r>
               <a:t>Cloud Run Gateway</a:t>
-            </a:r>
-          </a:p>
-          <a:p>
-            <a:pPr>
-              <a:defRPr sz="800" b="1">
-                <a:solidFill>
-                  <a:srgbClr val="5F6368"/>
-                </a:solidFill>
-                <a:latin typeface="Arial"/>
-              </a:defRPr>
-            </a:pPr>
-            <a:r>
-              <a:t>FastAPI Container</a:t>
             </a:r>
           </a:p>
           <a:p>
             <a:pPr>
               <a:spcBef>
-                <a:spcPts val="150"/>
+                <a:spcPts val="200"/>
               </a:spcBef>
-              <a:defRPr sz="800">
-                <a:solidFill>
-                  <a:srgbClr val="202124"/>
-                </a:solidFill>
-                <a:latin typeface="Arial"/>
-              </a:defRPr>
-            </a:pPr>
-            <a:r>
-              <a:t>• Auth Token Check</a:t>
+              <a:defRPr sz="850" b="1">
+                <a:solidFill>
+                  <a:srgbClr val="5F6368"/>
+                </a:solidFill>
+                <a:latin typeface="Arial"/>
+              </a:defRPr>
+            </a:pPr>
+            <a:r>
+              <a:t>FastAPI Microservice</a:t>
             </a:r>
           </a:p>
           <a:p>
             <a:pPr>
               <a:spcBef>
-                <a:spcPts val="150"/>
+                <a:spcPts val="300"/>
               </a:spcBef>
-              <a:defRPr sz="800">
+              <a:defRPr sz="850">
                 <a:solidFill>
                   <a:srgbClr val="202124"/>
                 </a:solidFill>
@@ -5585,7 +5546,7 @@
               </a:defRPr>
             </a:pPr>
             <a:r>
-              <a:t>• Streaming Engine</a:t>
+              <a:t>Auth &amp; session state</a:t>
             </a:r>
           </a:p>
         </p:txBody>
@@ -5598,8 +5559,8 @@
         </p:nvCxnSpPr>
         <p:spPr>
           <a:xfrm>
-            <a:off x="5669280" y="2258568"/>
-            <a:ext cx="320040" cy="0"/>
+            <a:off x="5760720" y="2212848"/>
+            <a:ext cx="548640" cy="0"/>
           </a:xfrm>
           <a:prstGeom prst="line">
             <a:avLst/>
@@ -5634,8 +5595,8 @@
         </p:nvSpPr>
         <p:spPr>
           <a:xfrm>
-            <a:off x="5052060" y="2112264"/>
-            <a:ext cx="1554480" cy="219456"/>
+            <a:off x="5029200" y="2048256"/>
+            <a:ext cx="2011680" cy="219456"/>
           </a:xfrm>
           <a:prstGeom prst="rect">
             <a:avLst/>
@@ -5657,7 +5618,7 @@
               </a:defRPr>
             </a:pPr>
             <a:r>
-              <a:t>3. Ingest</a:t>
+              <a:t>3. Auth Payload</a:t>
             </a:r>
           </a:p>
         </p:txBody>
@@ -5670,8 +5631,8 @@
         </p:nvSpPr>
         <p:spPr>
           <a:xfrm>
-            <a:off x="5989320" y="1847088"/>
-            <a:ext cx="1920240" cy="822960"/>
+            <a:off x="6309360" y="1847088"/>
+            <a:ext cx="1463040" cy="731520"/>
           </a:xfrm>
           <a:prstGeom prst="roundRect">
             <a:avLst/>
@@ -5679,7 +5640,7 @@
           <a:solidFill>
             <a:srgbClr val="FFFFFF"/>
           </a:solidFill>
-          <a:ln w="15240">
+          <a:ln w="19050">
             <a:solidFill>
               <a:srgbClr val="1A73E8"/>
             </a:solidFill>
@@ -5700,11 +5661,11 @@
           </a:fontRef>
         </p:style>
         <p:txBody>
-          <a:bodyPr rtlCol="0" anchor="ctr" wrap="square" lIns="109728" rIns="109728" tIns="73152" bIns="73152"/>
+          <a:bodyPr rtlCol="0" anchor="ctr" wrap="square" lIns="109728" rIns="109728" tIns="91440" bIns="91440"/>
           <a:lstStyle/>
           <a:p>
             <a:pPr algn="ctr">
-              <a:defRPr sz="1000" b="1">
+              <a:defRPr sz="1050" b="1">
                 <a:solidFill>
                   <a:srgbClr val="1A73E8"/>
                 </a:solidFill>
@@ -5713,43 +5674,30 @@
             </a:pPr>
             <a:r>
               <a:t>Model Armor</a:t>
-            </a:r>
-          </a:p>
-          <a:p>
-            <a:pPr>
-              <a:defRPr sz="800" b="1">
-                <a:solidFill>
-                  <a:srgbClr val="5F6368"/>
-                </a:solidFill>
-                <a:latin typeface="Arial"/>
-              </a:defRPr>
-            </a:pPr>
-            <a:r>
-              <a:t>Layer 8 Guardrail</a:t>
             </a:r>
           </a:p>
           <a:p>
             <a:pPr>
               <a:spcBef>
-                <a:spcPts val="150"/>
+                <a:spcPts val="200"/>
               </a:spcBef>
-              <a:defRPr sz="800">
-                <a:solidFill>
-                  <a:srgbClr val="202124"/>
-                </a:solidFill>
-                <a:latin typeface="Arial"/>
-              </a:defRPr>
-            </a:pPr>
-            <a:r>
-              <a:t>• 18 HIPAA PHI De-id</a:t>
+              <a:defRPr sz="850" b="1">
+                <a:solidFill>
+                  <a:srgbClr val="5F6368"/>
+                </a:solidFill>
+                <a:latin typeface="Arial"/>
+              </a:defRPr>
+            </a:pPr>
+            <a:r>
+              <a:t>Layer 8 Guardrail</a:t>
             </a:r>
           </a:p>
           <a:p>
             <a:pPr>
               <a:spcBef>
-                <a:spcPts val="150"/>
+                <a:spcPts val="300"/>
               </a:spcBef>
-              <a:defRPr sz="800">
+              <a:defRPr sz="850">
                 <a:solidFill>
                   <a:srgbClr val="202124"/>
                 </a:solidFill>
@@ -5757,7 +5705,7 @@
               </a:defRPr>
             </a:pPr>
             <a:r>
-              <a:t>• Injection Filter</a:t>
+              <a:t>HIPAA PHI &amp; Jailbreak</a:t>
             </a:r>
           </a:p>
         </p:txBody>
@@ -5770,8 +5718,8 @@
         </p:nvCxnSpPr>
         <p:spPr>
           <a:xfrm>
-            <a:off x="7909560" y="2258568"/>
-            <a:ext cx="411480" cy="0"/>
+            <a:off x="7772400" y="2212848"/>
+            <a:ext cx="548640" cy="0"/>
           </a:xfrm>
           <a:prstGeom prst="line">
             <a:avLst/>
@@ -5806,8 +5754,8 @@
         </p:nvSpPr>
         <p:spPr>
           <a:xfrm>
-            <a:off x="7338060" y="2112264"/>
-            <a:ext cx="1554480" cy="219456"/>
+            <a:off x="7040880" y="2048256"/>
+            <a:ext cx="2011680" cy="219456"/>
           </a:xfrm>
           <a:prstGeom prst="rect">
             <a:avLst/>
@@ -5829,7 +5777,7 @@
               </a:defRPr>
             </a:pPr>
             <a:r>
-              <a:t>Refusal (&lt;5ms)</a:t>
+              <a:t>4a. Safe Refusal (&lt;5ms)</a:t>
             </a:r>
           </a:p>
         </p:txBody>
@@ -5843,7 +5791,7 @@
         <p:spPr>
           <a:xfrm>
             <a:off x="8321040" y="1847088"/>
-            <a:ext cx="3108960" cy="822960"/>
+            <a:ext cx="3108960" cy="731520"/>
           </a:xfrm>
           <a:prstGeom prst="roundRect">
             <a:avLst/>
@@ -5851,7 +5799,7 @@
           <a:solidFill>
             <a:srgbClr val="FEF2F2"/>
           </a:solidFill>
-          <a:ln w="15240">
+          <a:ln w="19050">
             <a:solidFill>
               <a:srgbClr val="EA4335"/>
             </a:solidFill>
@@ -5872,11 +5820,11 @@
           </a:fontRef>
         </p:style>
         <p:txBody>
-          <a:bodyPr rtlCol="0" anchor="ctr" wrap="square" lIns="109728" rIns="109728" tIns="73152" bIns="73152"/>
+          <a:bodyPr rtlCol="0" anchor="ctr" wrap="square" lIns="109728" rIns="109728" tIns="91440" bIns="91440"/>
           <a:lstStyle/>
           <a:p>
             <a:pPr algn="ctr">
-              <a:defRPr sz="1000" b="1">
+              <a:defRPr sz="1050" b="1">
                 <a:solidFill>
                   <a:srgbClr val="EA4335"/>
                 </a:solidFill>
@@ -5885,43 +5833,30 @@
             </a:pPr>
             <a:r>
               <a:t>Safe Refusal Engine Exit</a:t>
-            </a:r>
-          </a:p>
-          <a:p>
-            <a:pPr>
-              <a:defRPr sz="800" b="1">
-                <a:solidFill>
-                  <a:srgbClr val="5F6368"/>
-                </a:solidFill>
-                <a:latin typeface="Arial"/>
-              </a:defRPr>
-            </a:pPr>
-            <a:r>
-              <a:t>Boundary Lock: Diagnosis &amp; Rx Dosing</a:t>
             </a:r>
           </a:p>
           <a:p>
             <a:pPr>
               <a:spcBef>
-                <a:spcPts val="150"/>
+                <a:spcPts val="200"/>
               </a:spcBef>
-              <a:defRPr sz="800">
-                <a:solidFill>
-                  <a:srgbClr val="202124"/>
-                </a:solidFill>
-                <a:latin typeface="Arial"/>
-              </a:defRPr>
-            </a:pPr>
-            <a:r>
-              <a:t>• Returns emergency disclaimer</a:t>
+              <a:defRPr sz="850" b="1">
+                <a:solidFill>
+                  <a:srgbClr val="5F6368"/>
+                </a:solidFill>
+                <a:latin typeface="Arial"/>
+              </a:defRPr>
+            </a:pPr>
+            <a:r>
+              <a:t>Personal Advice &amp; Dosing Block</a:t>
             </a:r>
           </a:p>
           <a:p>
             <a:pPr>
               <a:spcBef>
-                <a:spcPts val="150"/>
+                <a:spcPts val="300"/>
               </a:spcBef>
-              <a:defRPr sz="800">
+              <a:defRPr sz="850">
                 <a:solidFill>
                   <a:srgbClr val="202124"/>
                 </a:solidFill>
@@ -5929,7 +5864,7 @@
               </a:defRPr>
             </a:pPr>
             <a:r>
-              <a:t>• Zero LLM tokens spent</a:t>
+              <a:t>Returns ER disclaimer | Zero tokens</a:t>
             </a:r>
           </a:p>
         </p:txBody>
@@ -5942,8 +5877,8 @@
         </p:nvCxnSpPr>
         <p:spPr>
           <a:xfrm>
-            <a:off x="6949440" y="2670048"/>
-            <a:ext cx="0" cy="242316.0"/>
+            <a:off x="7040880" y="2578608"/>
+            <a:ext cx="0" cy="256032.0"/>
           </a:xfrm>
           <a:prstGeom prst="line">
             <a:avLst/>
@@ -5977,8 +5912,8 @@
         </p:nvCxnSpPr>
         <p:spPr>
           <a:xfrm flipH="1">
-            <a:off x="2148840" y="2912364.0"/>
-            <a:ext cx="4800600" cy="0.0"/>
+            <a:off x="2148840" y="2834640.0"/>
+            <a:ext cx="4892040" cy="0.0"/>
           </a:xfrm>
           <a:prstGeom prst="line">
             <a:avLst/>
@@ -6012,8 +5947,8 @@
         </p:nvCxnSpPr>
         <p:spPr>
           <a:xfrm>
-            <a:off x="2148840" y="2912364.0"/>
-            <a:ext cx="0" cy="242316.0"/>
+            <a:off x="2148840" y="2834640.0"/>
+            <a:ext cx="0" cy="256032.0"/>
           </a:xfrm>
           <a:prstGeom prst="line">
             <a:avLst/>
@@ -6048,8 +5983,8 @@
         </p:nvSpPr>
         <p:spPr>
           <a:xfrm>
-            <a:off x="3954780" y="2711196"/>
-            <a:ext cx="1554480" cy="182880"/>
+            <a:off x="3131820" y="2633472"/>
+            <a:ext cx="3291840" cy="201168"/>
           </a:xfrm>
           <a:prstGeom prst="rect">
             <a:avLst/>
@@ -6071,7 +6006,7 @@
               </a:defRPr>
             </a:pPr>
             <a:r>
-              <a:t>4. Valid Inquiry (Sanitized Query)</a:t>
+              <a:t>4b. Sanitized Query (18 HIPAA PHI Identifiers Scrubbed)</a:t>
             </a:r>
           </a:p>
         </p:txBody>
@@ -6084,8 +6019,8 @@
         </p:nvSpPr>
         <p:spPr>
           <a:xfrm>
-            <a:off x="548640" y="2907792"/>
-            <a:ext cx="11094415" cy="2121408"/>
+            <a:off x="548640" y="2852928"/>
+            <a:ext cx="11094415" cy="2084831"/>
           </a:xfrm>
           <a:prstGeom prst="roundRect">
             <a:avLst/>
@@ -6118,7 +6053,7 @@
           <a:lstStyle/>
           <a:p>
             <a:pPr algn="ctr">
-              <a:defRPr sz="900" b="1">
+              <a:defRPr sz="850" b="1">
                 <a:solidFill>
                   <a:srgbClr val="1A73E8"/>
                 </a:solidFill>
@@ -6126,7 +6061,7 @@
               </a:defRPr>
             </a:pPr>
             <a:r>
-              <a:t>2. GOOGLE ADK MULTI-AGENT CORE (SUPERVISOR-WORKER DECOUPLED TOPOLOGY)</a:t>
+              <a:t>2. GOOGLE ADK MULTI-AGENT CORE (DECOUPLED SUPERVISOR-WORKER PATTERN)</a:t>
             </a:r>
           </a:p>
         </p:txBody>
@@ -6139,8 +6074,8 @@
         </p:nvSpPr>
         <p:spPr>
           <a:xfrm>
-            <a:off x="731520" y="3154680"/>
-            <a:ext cx="2834640" cy="1691640"/>
+            <a:off x="731520" y="3090672"/>
+            <a:ext cx="2743200" cy="1691640"/>
           </a:xfrm>
           <a:prstGeom prst="roundRect">
             <a:avLst/>
@@ -6148,7 +6083,7 @@
           <a:solidFill>
             <a:srgbClr val="FFFFFF"/>
           </a:solidFill>
-          <a:ln w="15240">
+          <a:ln w="19050">
             <a:solidFill>
               <a:srgbClr val="1A73E8"/>
             </a:solidFill>
@@ -6169,11 +6104,11 @@
           </a:fontRef>
         </p:style>
         <p:txBody>
-          <a:bodyPr rtlCol="0" anchor="ctr" wrap="square" lIns="109728" rIns="109728" tIns="73152" bIns="73152"/>
+          <a:bodyPr rtlCol="0" anchor="ctr" wrap="square" lIns="109728" rIns="109728" tIns="91440" bIns="91440"/>
           <a:lstStyle/>
           <a:p>
             <a:pPr algn="ctr">
-              <a:defRPr sz="1000" b="1">
+              <a:defRPr sz="1050" b="1">
                 <a:solidFill>
                   <a:srgbClr val="1A73E8"/>
                 </a:solidFill>
@@ -6182,43 +6117,30 @@
             </a:pPr>
             <a:r>
               <a:t>Root Orchestrator</a:t>
-            </a:r>
-          </a:p>
-          <a:p>
-            <a:pPr>
-              <a:defRPr sz="800" b="1">
-                <a:solidFill>
-                  <a:srgbClr val="5F6368"/>
-                </a:solidFill>
-                <a:latin typeface="Arial"/>
-              </a:defRPr>
-            </a:pPr>
-            <a:r>
-              <a:t>Supervisor  |  Gemini 2.5 Flash</a:t>
             </a:r>
           </a:p>
           <a:p>
             <a:pPr>
               <a:spcBef>
-                <a:spcPts val="150"/>
+                <a:spcPts val="200"/>
               </a:spcBef>
-              <a:defRPr sz="800">
-                <a:solidFill>
-                  <a:srgbClr val="202124"/>
-                </a:solidFill>
-                <a:latin typeface="Arial"/>
-              </a:defRPr>
-            </a:pPr>
-            <a:r>
-              <a:t>• Classifies clinical intent &amp; domain</a:t>
+              <a:defRPr sz="850" b="1">
+                <a:solidFill>
+                  <a:srgbClr val="5F6368"/>
+                </a:solidFill>
+                <a:latin typeface="Arial"/>
+              </a:defRPr>
+            </a:pPr>
+            <a:r>
+              <a:t>Supervisor  |  Gemini 2.5 Flash</a:t>
             </a:r>
           </a:p>
           <a:p>
             <a:pPr>
               <a:spcBef>
-                <a:spcPts val="150"/>
+                <a:spcPts val="300"/>
               </a:spcBef>
-              <a:defRPr sz="800">
+              <a:defRPr sz="850">
                 <a:solidFill>
                   <a:srgbClr val="202124"/>
                 </a:solidFill>
@@ -6226,39 +6148,15 @@
               </a:defRPr>
             </a:pPr>
             <a:r>
-              <a:t>• SafeRefusalEngine policy routing</a:t>
-            </a:r>
-          </a:p>
-          <a:p>
-            <a:pPr>
-              <a:spcBef>
-                <a:spcPts val="150"/>
-              </a:spcBef>
-              <a:defRPr sz="800">
-                <a:solidFill>
-                  <a:srgbClr val="202124"/>
-                </a:solidFill>
-                <a:latin typeface="Arial"/>
-              </a:defRPr>
-            </a:pPr>
-            <a:r>
-              <a:t>• Enforces max_iterations=2 loop ceiling</a:t>
-            </a:r>
-          </a:p>
-          <a:p>
-            <a:pPr>
-              <a:spcBef>
-                <a:spcPts val="150"/>
-              </a:spcBef>
-              <a:defRPr sz="800">
-                <a:solidFill>
-                  <a:srgbClr val="202124"/>
-                </a:solidFill>
-                <a:latin typeface="Arial"/>
-              </a:defRPr>
-            </a:pPr>
-            <a:r>
-              <a:t>• Maintains top-level conversation state</a:t>
+              <a:t>• Intent classification &amp; policy routing</a:t>
+            </a:r>
+            <a:br/>
+            <a:r>
+              <a:t>• max_iterations=2 safety loop ceiling</a:t>
+            </a:r>
+            <a:br/>
+            <a:r>
+              <a:t>• Top-level conversation session state</a:t>
             </a:r>
           </a:p>
         </p:txBody>
@@ -6271,8 +6169,8 @@
         </p:nvCxnSpPr>
         <p:spPr>
           <a:xfrm>
-            <a:off x="3566160" y="3995928"/>
-            <a:ext cx="731520" cy="0"/>
+            <a:off x="3474720" y="3931920"/>
+            <a:ext cx="914400" cy="0"/>
           </a:xfrm>
           <a:prstGeom prst="line">
             <a:avLst/>
@@ -6307,8 +6205,8 @@
         </p:nvSpPr>
         <p:spPr>
           <a:xfrm>
-            <a:off x="3154680" y="3849624"/>
-            <a:ext cx="1554480" cy="219456"/>
+            <a:off x="2926080" y="3767328"/>
+            <a:ext cx="2011680" cy="219456"/>
           </a:xfrm>
           <a:prstGeom prst="rect">
             <a:avLst/>
@@ -6330,7 +6228,7 @@
               </a:defRPr>
             </a:pPr>
             <a:r>
-              <a:t>5. Route</a:t>
+              <a:t>5. Research Intent + Loop Guard (max_iter=2)</a:t>
             </a:r>
           </a:p>
         </p:txBody>
@@ -6343,8 +6241,8 @@
         </p:nvSpPr>
         <p:spPr>
           <a:xfrm>
-            <a:off x="4297680" y="3154680"/>
-            <a:ext cx="3200400" cy="1691640"/>
+            <a:off x="4389120" y="3090672"/>
+            <a:ext cx="3017520" cy="1691640"/>
           </a:xfrm>
           <a:prstGeom prst="roundRect">
             <a:avLst/>
@@ -6352,7 +6250,7 @@
           <a:solidFill>
             <a:srgbClr val="FFFFFF"/>
           </a:solidFill>
-          <a:ln w="15240">
+          <a:ln w="19050">
             <a:solidFill>
               <a:srgbClr val="1A73E8"/>
             </a:solidFill>
@@ -6373,11 +6271,11 @@
           </a:fontRef>
         </p:style>
         <p:txBody>
-          <a:bodyPr rtlCol="0" anchor="ctr" wrap="square" lIns="109728" rIns="109728" tIns="73152" bIns="73152"/>
+          <a:bodyPr rtlCol="0" anchor="ctr" wrap="square" lIns="109728" rIns="109728" tIns="91440" bIns="91440"/>
           <a:lstStyle/>
           <a:p>
             <a:pPr algn="ctr">
-              <a:defRPr sz="1000" b="1">
+              <a:defRPr sz="1050" b="1">
                 <a:solidFill>
                   <a:srgbClr val="1A73E8"/>
                 </a:solidFill>
@@ -6386,43 +6284,30 @@
             </a:pPr>
             <a:r>
               <a:t>Clinical Researcher</a:t>
-            </a:r>
-          </a:p>
-          <a:p>
-            <a:pPr>
-              <a:defRPr sz="800" b="1">
-                <a:solidFill>
-                  <a:srgbClr val="5F6368"/>
-                </a:solidFill>
-                <a:latin typeface="Arial"/>
-              </a:defRPr>
-            </a:pPr>
-            <a:r>
-              <a:t>Worker  |  Gemini 2.5 Pro</a:t>
             </a:r>
           </a:p>
           <a:p>
             <a:pPr>
               <a:spcBef>
-                <a:spcPts val="150"/>
+                <a:spcPts val="200"/>
               </a:spcBef>
-              <a:defRPr sz="800">
-                <a:solidFill>
-                  <a:srgbClr val="202124"/>
-                </a:solidFill>
-                <a:latin typeface="Arial"/>
-              </a:defRPr>
-            </a:pPr>
-            <a:r>
-              <a:t>• Deep biomedical literature reasoning</a:t>
+              <a:defRPr sz="850" b="1">
+                <a:solidFill>
+                  <a:srgbClr val="5F6368"/>
+                </a:solidFill>
+                <a:latin typeface="Arial"/>
+              </a:defRPr>
+            </a:pPr>
+            <a:r>
+              <a:t>Worker  |  Gemini 2.5 Pro</a:t>
             </a:r>
           </a:p>
           <a:p>
             <a:pPr>
               <a:spcBef>
-                <a:spcPts val="150"/>
+                <a:spcPts val="300"/>
               </a:spcBef>
-              <a:defRPr sz="800">
+              <a:defRPr sz="850">
                 <a:solidFill>
                   <a:srgbClr val="202124"/>
                 </a:solidFill>
@@ -6430,39 +6315,15 @@
               </a:defRPr>
             </a:pPr>
             <a:r>
-              <a:t>• Executes semantic search over NIH data</a:t>
-            </a:r>
-          </a:p>
-          <a:p>
-            <a:pPr>
-              <a:spcBef>
-                <a:spcPts val="150"/>
-              </a:spcBef>
-              <a:defRPr sz="800">
-                <a:solidFill>
-                  <a:srgbClr val="202124"/>
-                </a:solidFill>
-                <a:latin typeface="Arial"/>
-              </a:defRPr>
-            </a:pPr>
-            <a:r>
-              <a:t>• Queries lab test reference ranges</a:t>
-            </a:r>
-          </a:p>
-          <a:p>
-            <a:pPr>
-              <a:spcBef>
-                <a:spcPts val="150"/>
-              </a:spcBef>
-              <a:defRPr sz="800">
-                <a:solidFill>
-                  <a:srgbClr val="202124"/>
-                </a:solidFill>
-                <a:latin typeface="Arial"/>
-              </a:defRPr>
-            </a:pPr>
-            <a:r>
-              <a:t>• Drafts synthesis with inline [1],[2] tags</a:t>
+              <a:t>• Deep biomedical literature reasoning</a:t>
+            </a:r>
+            <a:br/>
+            <a:r>
+              <a:t>• Multi-source synthesis across NIH</a:t>
+            </a:r>
+            <a:br/>
+            <a:r>
+              <a:t>• Drafts response with [1], [2] citations</a:t>
             </a:r>
           </a:p>
         </p:txBody>
@@ -6475,8 +6336,8 @@
         </p:nvCxnSpPr>
         <p:spPr>
           <a:xfrm>
-            <a:off x="7498079" y="3995928"/>
-            <a:ext cx="640081" cy="0"/>
+            <a:off x="7406640" y="3931920"/>
+            <a:ext cx="822960" cy="0"/>
           </a:xfrm>
           <a:prstGeom prst="line">
             <a:avLst/>
@@ -6511,8 +6372,8 @@
         </p:nvSpPr>
         <p:spPr>
           <a:xfrm>
-            <a:off x="7040879" y="3849624"/>
-            <a:ext cx="1554480" cy="219456"/>
+            <a:off x="6812280" y="3767328"/>
+            <a:ext cx="2011680" cy="219456"/>
           </a:xfrm>
           <a:prstGeom prst="rect">
             <a:avLst/>
@@ -6534,7 +6395,7 @@
               </a:defRPr>
             </a:pPr>
             <a:r>
-              <a:t>8. Draft</a:t>
+              <a:t>8. Draft Response with [1],[2] Anchors</a:t>
             </a:r>
           </a:p>
         </p:txBody>
@@ -6547,8 +6408,8 @@
         </p:nvSpPr>
         <p:spPr>
           <a:xfrm>
-            <a:off x="8138160" y="3154680"/>
-            <a:ext cx="3291840" cy="1691640"/>
+            <a:off x="8229600" y="3090672"/>
+            <a:ext cx="3200400" cy="1691640"/>
           </a:xfrm>
           <a:prstGeom prst="roundRect">
             <a:avLst/>
@@ -6556,7 +6417,7 @@
           <a:solidFill>
             <a:srgbClr val="FFFFFF"/>
           </a:solidFill>
-          <a:ln w="15240">
+          <a:ln w="19050">
             <a:solidFill>
               <a:srgbClr val="34A853"/>
             </a:solidFill>
@@ -6577,11 +6438,11 @@
           </a:fontRef>
         </p:style>
         <p:txBody>
-          <a:bodyPr rtlCol="0" anchor="ctr" wrap="square" lIns="109728" rIns="109728" tIns="73152" bIns="73152"/>
+          <a:bodyPr rtlCol="0" anchor="ctr" wrap="square" lIns="109728" rIns="109728" tIns="91440" bIns="91440"/>
           <a:lstStyle/>
           <a:p>
             <a:pPr algn="ctr">
-              <a:defRPr sz="1000" b="1">
+              <a:defRPr sz="1050" b="1">
                 <a:solidFill>
                   <a:srgbClr val="34A853"/>
                 </a:solidFill>
@@ -6590,43 +6451,30 @@
             </a:pPr>
             <a:r>
               <a:t>Reviewer &amp; QC Gate</a:t>
-            </a:r>
-          </a:p>
-          <a:p>
-            <a:pPr>
-              <a:defRPr sz="800" b="1">
-                <a:solidFill>
-                  <a:srgbClr val="5F6368"/>
-                </a:solidFill>
-                <a:latin typeface="Arial"/>
-              </a:defRPr>
-            </a:pPr>
-            <a:r>
-              <a:t>Auditor  |  Gemini 3.5 Flash</a:t>
             </a:r>
           </a:p>
           <a:p>
             <a:pPr>
               <a:spcBef>
-                <a:spcPts val="150"/>
+                <a:spcPts val="200"/>
               </a:spcBef>
-              <a:defRPr sz="800">
-                <a:solidFill>
-                  <a:srgbClr val="202124"/>
-                </a:solidFill>
-                <a:latin typeface="Arial"/>
-              </a:defRPr>
-            </a:pPr>
-            <a:r>
-              <a:t>• Zero shared hidden state (no bias)</a:t>
+              <a:defRPr sz="850" b="1">
+                <a:solidFill>
+                  <a:srgbClr val="5F6368"/>
+                </a:solidFill>
+                <a:latin typeface="Arial"/>
+              </a:defRPr>
+            </a:pPr>
+            <a:r>
+              <a:t>Auditor  |  Gemini 3.5 Flash</a:t>
             </a:r>
           </a:p>
           <a:p>
             <a:pPr>
               <a:spcBef>
-                <a:spcPts val="150"/>
+                <a:spcPts val="300"/>
               </a:spcBef>
-              <a:defRPr sz="800">
+              <a:defRPr sz="850">
                 <a:solidFill>
                   <a:srgbClr val="202124"/>
                 </a:solidFill>
@@ -6634,39 +6482,15 @@
               </a:defRPr>
             </a:pPr>
             <a:r>
-              <a:t>• CitationVerifier: 100% chunk ID match</a:t>
-            </a:r>
-          </a:p>
-          <a:p>
-            <a:pPr>
-              <a:spcBef>
-                <a:spcPts val="150"/>
-              </a:spcBef>
-              <a:defRPr sz="800">
-                <a:solidFill>
-                  <a:srgbClr val="202124"/>
-                </a:solidFill>
-                <a:latin typeface="Arial"/>
-              </a:defRPr>
-            </a:pPr>
-            <a:r>
-              <a:t>• Strips ungrounded/hallucinated statements</a:t>
-            </a:r>
-          </a:p>
-          <a:p>
-            <a:pPr>
-              <a:spcBef>
-                <a:spcPts val="150"/>
-              </a:spcBef>
-              <a:defRPr sz="800">
-                <a:solidFill>
-                  <a:srgbClr val="202124"/>
-                </a:solidFill>
-                <a:latin typeface="Arial"/>
-              </a:defRPr>
-            </a:pPr>
-            <a:r>
-              <a:t>• Approves streaming release to client</a:t>
+              <a:t>• Zero shared state (eliminates bias)</a:t>
+            </a:r>
+            <a:br/>
+            <a:r>
+              <a:t>• CitationVerifier: 100% chunk match</a:t>
+            </a:r>
+            <a:br/>
+            <a:r>
+              <a:t>• Approves verified streaming release</a:t>
             </a:r>
           </a:p>
         </p:txBody>
@@ -6679,8 +6503,8 @@
         </p:nvSpPr>
         <p:spPr>
           <a:xfrm>
-            <a:off x="548640" y="5138928"/>
-            <a:ext cx="11094415" cy="1353312"/>
+            <a:off x="548640" y="5074920"/>
+            <a:ext cx="11094415" cy="1389888"/>
           </a:xfrm>
           <a:prstGeom prst="roundRect">
             <a:avLst/>
@@ -6713,7 +6537,7 @@
           <a:lstStyle/>
           <a:p>
             <a:pPr algn="ctr">
-              <a:defRPr sz="900" b="1">
+              <a:defRPr sz="850" b="1">
                 <a:solidFill>
                   <a:srgbClr val="5F6368"/>
                 </a:solidFill>
@@ -6734,8 +6558,8 @@
         </p:nvSpPr>
         <p:spPr>
           <a:xfrm>
-            <a:off x="731520" y="5413248"/>
-            <a:ext cx="2560320" cy="960120"/>
+            <a:off x="731520" y="5321808"/>
+            <a:ext cx="2560320" cy="1005840"/>
           </a:xfrm>
           <a:prstGeom prst="roundRect">
             <a:avLst/>
@@ -6743,7 +6567,7 @@
           <a:solidFill>
             <a:srgbClr val="FFFFFF"/>
           </a:solidFill>
-          <a:ln w="15240">
+          <a:ln w="12700">
             <a:solidFill>
               <a:srgbClr val="DADCE0"/>
             </a:solidFill>
@@ -6764,11 +6588,11 @@
           </a:fontRef>
         </p:style>
         <p:txBody>
-          <a:bodyPr rtlCol="0" anchor="ctr" wrap="square" lIns="109728" rIns="109728" tIns="73152" bIns="73152"/>
+          <a:bodyPr rtlCol="0" anchor="ctr" wrap="square" lIns="109728" rIns="109728" tIns="91440" bIns="91440"/>
           <a:lstStyle/>
           <a:p>
             <a:pPr algn="ctr">
-              <a:defRPr sz="1000" b="1">
+              <a:defRPr sz="1050" b="1">
                 <a:solidFill>
                   <a:srgbClr val="1A73E8"/>
                 </a:solidFill>
@@ -6777,43 +6601,30 @@
             </a:pPr>
             <a:r>
               <a:t>Vertex AI Search</a:t>
-            </a:r>
-          </a:p>
-          <a:p>
-            <a:pPr>
-              <a:defRPr sz="800" b="1">
-                <a:solidFill>
-                  <a:srgbClr val="5F6368"/>
-                </a:solidFill>
-                <a:latin typeface="Arial"/>
-              </a:defRPr>
-            </a:pPr>
-            <a:r>
-              <a:t>Authoritative Literature Datastore</a:t>
             </a:r>
           </a:p>
           <a:p>
             <a:pPr>
               <a:spcBef>
-                <a:spcPts val="150"/>
+                <a:spcPts val="200"/>
               </a:spcBef>
-              <a:defRPr sz="800">
-                <a:solidFill>
-                  <a:srgbClr val="202124"/>
-                </a:solidFill>
-                <a:latin typeface="Arial"/>
-              </a:defRPr>
-            </a:pPr>
-            <a:r>
-              <a:t>• 16,400+ NIH Q&amp;A pairs indexed</a:t>
+              <a:defRPr sz="850" b="1">
+                <a:solidFill>
+                  <a:srgbClr val="5F6368"/>
+                </a:solidFill>
+                <a:latin typeface="Arial"/>
+              </a:defRPr>
+            </a:pPr>
+            <a:r>
+              <a:t>NIH Literature Datastore</a:t>
             </a:r>
           </a:p>
           <a:p>
             <a:pPr>
               <a:spcBef>
-                <a:spcPts val="150"/>
+                <a:spcPts val="300"/>
               </a:spcBef>
-              <a:defRPr sz="800">
+              <a:defRPr sz="850">
                 <a:solidFill>
                   <a:srgbClr val="202124"/>
                 </a:solidFill>
@@ -6821,7 +6632,11 @@
               </a:defRPr>
             </a:pPr>
             <a:r>
-              <a:t>• 500-token semantic chunks (10% ovlp)</a:t>
+              <a:t>16,400+ verified medical Q&amp;A pairs</a:t>
+            </a:r>
+            <a:br/>
+            <a:r>
+              <a:t>500-token chunks with 10% overlap</a:t>
             </a:r>
           </a:p>
         </p:txBody>
@@ -6834,8 +6649,8 @@
         </p:nvSpPr>
         <p:spPr>
           <a:xfrm>
-            <a:off x="3474720" y="5413248"/>
-            <a:ext cx="2468880" cy="960120"/>
+            <a:off x="3474720" y="5321808"/>
+            <a:ext cx="2468880" cy="1005840"/>
           </a:xfrm>
           <a:prstGeom prst="roundRect">
             <a:avLst/>
@@ -6843,7 +6658,7 @@
           <a:solidFill>
             <a:srgbClr val="FFFFFF"/>
           </a:solidFill>
-          <a:ln w="15240">
+          <a:ln w="12700">
             <a:solidFill>
               <a:srgbClr val="DADCE0"/>
             </a:solidFill>
@@ -6864,11 +6679,11 @@
           </a:fontRef>
         </p:style>
         <p:txBody>
-          <a:bodyPr rtlCol="0" anchor="ctr" wrap="square" lIns="109728" rIns="109728" tIns="73152" bIns="73152"/>
+          <a:bodyPr rtlCol="0" anchor="ctr" wrap="square" lIns="109728" rIns="109728" tIns="91440" bIns="91440"/>
           <a:lstStyle/>
           <a:p>
             <a:pPr algn="ctr">
-              <a:defRPr sz="1000" b="1">
+              <a:defRPr sz="1050" b="1">
                 <a:solidFill>
                   <a:srgbClr val="1A73E8"/>
                 </a:solidFill>
@@ -6877,43 +6692,30 @@
             </a:pPr>
             <a:r>
               <a:t>ClinicalDBTool</a:t>
-            </a:r>
-          </a:p>
-          <a:p>
-            <a:pPr>
-              <a:defRPr sz="800" b="1">
-                <a:solidFill>
-                  <a:srgbClr val="5F6368"/>
-                </a:solidFill>
-                <a:latin typeface="Arial"/>
-              </a:defRPr>
-            </a:pPr>
-            <a:r>
-              <a:t>Structured Reference Database</a:t>
             </a:r>
           </a:p>
           <a:p>
             <a:pPr>
               <a:spcBef>
-                <a:spcPts val="150"/>
+                <a:spcPts val="200"/>
               </a:spcBef>
-              <a:defRPr sz="800">
-                <a:solidFill>
-                  <a:srgbClr val="202124"/>
-                </a:solidFill>
-                <a:latin typeface="Arial"/>
-              </a:defRPr>
-            </a:pPr>
-            <a:r>
-              <a:t>• Lab test reference ranges</a:t>
+              <a:defRPr sz="850" b="1">
+                <a:solidFill>
+                  <a:srgbClr val="5F6368"/>
+                </a:solidFill>
+                <a:latin typeface="Arial"/>
+              </a:defRPr>
+            </a:pPr>
+            <a:r>
+              <a:t>Biomarker Reference DB</a:t>
             </a:r>
           </a:p>
           <a:p>
             <a:pPr>
               <a:spcBef>
-                <a:spcPts val="150"/>
+                <a:spcPts val="300"/>
               </a:spcBef>
-              <a:defRPr sz="800">
+              <a:defRPr sz="850">
                 <a:solidFill>
                   <a:srgbClr val="202124"/>
                 </a:solidFill>
@@ -6921,7 +6723,11 @@
               </a:defRPr>
             </a:pPr>
             <a:r>
-              <a:t>• Diagnostic biomarker thresholds</a:t>
+              <a:t>Diagnostic reference ranges &amp;</a:t>
+            </a:r>
+            <a:br/>
+            <a:r>
+              <a:t>clinical lab test thresholds</a:t>
             </a:r>
           </a:p>
         </p:txBody>
@@ -6934,8 +6740,8 @@
         </p:nvSpPr>
         <p:spPr>
           <a:xfrm>
-            <a:off x="6126480" y="5413248"/>
-            <a:ext cx="2560320" cy="960120"/>
+            <a:off x="6126480" y="5321808"/>
+            <a:ext cx="2560320" cy="1005840"/>
           </a:xfrm>
           <a:prstGeom prst="roundRect">
             <a:avLst/>
@@ -6943,7 +6749,7 @@
           <a:solidFill>
             <a:srgbClr val="FFFFFF"/>
           </a:solidFill>
-          <a:ln w="15240">
+          <a:ln w="12700">
             <a:solidFill>
               <a:srgbClr val="DADCE0"/>
             </a:solidFill>
@@ -6964,11 +6770,11 @@
           </a:fontRef>
         </p:style>
         <p:txBody>
-          <a:bodyPr rtlCol="0" anchor="ctr" wrap="square" lIns="109728" rIns="109728" tIns="73152" bIns="73152"/>
+          <a:bodyPr rtlCol="0" anchor="ctr" wrap="square" lIns="109728" rIns="109728" tIns="91440" bIns="91440"/>
           <a:lstStyle/>
           <a:p>
             <a:pPr algn="ctr">
-              <a:defRPr sz="1000" b="1">
+              <a:defRPr sz="1050" b="1">
                 <a:solidFill>
                   <a:srgbClr val="1A73E8"/>
                 </a:solidFill>
@@ -6977,43 +6783,30 @@
             </a:pPr>
             <a:r>
               <a:t>Vector DB Fallback</a:t>
-            </a:r>
-          </a:p>
-          <a:p>
-            <a:pPr>
-              <a:defRPr sz="800" b="1">
-                <a:solidFill>
-                  <a:srgbClr val="5F6368"/>
-                </a:solidFill>
-                <a:latin typeface="Arial"/>
-              </a:defRPr>
-            </a:pPr>
-            <a:r>
-              <a:t>Circuit Breaker Redundancy</a:t>
             </a:r>
           </a:p>
           <a:p>
             <a:pPr>
               <a:spcBef>
-                <a:spcPts val="150"/>
+                <a:spcPts val="200"/>
               </a:spcBef>
-              <a:defRPr sz="800">
-                <a:solidFill>
-                  <a:srgbClr val="202124"/>
-                </a:solidFill>
-                <a:latin typeface="Arial"/>
-              </a:defRPr>
-            </a:pPr>
-            <a:r>
-              <a:t>• Local FAISS in-memory store</a:t>
+              <a:defRPr sz="850" b="1">
+                <a:solidFill>
+                  <a:srgbClr val="5F6368"/>
+                </a:solidFill>
+                <a:latin typeface="Arial"/>
+              </a:defRPr>
+            </a:pPr>
+            <a:r>
+              <a:t>Circuit Breaker Store</a:t>
             </a:r>
           </a:p>
           <a:p>
             <a:pPr>
               <a:spcBef>
-                <a:spcPts val="150"/>
+                <a:spcPts val="300"/>
               </a:spcBef>
-              <a:defRPr sz="800">
+              <a:defRPr sz="850">
                 <a:solidFill>
                   <a:srgbClr val="202124"/>
                 </a:solidFill>
@@ -7021,7 +6814,11 @@
               </a:defRPr>
             </a:pPr>
             <a:r>
-              <a:t>• Sub-50ms fallback on 504 timeouts</a:t>
+              <a:t>Local FAISS in-memory index</a:t>
+            </a:r>
+            <a:br/>
+            <a:r>
+              <a:t>Sub-50ms fallback on 504 timeouts</a:t>
             </a:r>
           </a:p>
         </p:txBody>
@@ -7034,8 +6831,8 @@
         </p:nvSpPr>
         <p:spPr>
           <a:xfrm>
-            <a:off x="8869680" y="5413248"/>
-            <a:ext cx="2560320" cy="960120"/>
+            <a:off x="8869680" y="5321808"/>
+            <a:ext cx="2560320" cy="1005840"/>
           </a:xfrm>
           <a:prstGeom prst="roundRect">
             <a:avLst/>
@@ -7043,7 +6840,7 @@
           <a:solidFill>
             <a:srgbClr val="FFFFFF"/>
           </a:solidFill>
-          <a:ln w="15240">
+          <a:ln w="12700">
             <a:solidFill>
               <a:srgbClr val="DADCE0"/>
             </a:solidFill>
@@ -7064,11 +6861,11 @@
           </a:fontRef>
         </p:style>
         <p:txBody>
-          <a:bodyPr rtlCol="0" anchor="ctr" wrap="square" lIns="109728" rIns="109728" tIns="73152" bIns="73152"/>
+          <a:bodyPr rtlCol="0" anchor="ctr" wrap="square" lIns="109728" rIns="109728" tIns="91440" bIns="91440"/>
           <a:lstStyle/>
           <a:p>
             <a:pPr algn="ctr">
-              <a:defRPr sz="1000" b="1">
+              <a:defRPr sz="1050" b="1">
                 <a:solidFill>
                   <a:srgbClr val="1A73E8"/>
                 </a:solidFill>
@@ -7077,43 +6874,30 @@
             </a:pPr>
             <a:r>
               <a:t>Cloud Trace &amp; BigQuery</a:t>
-            </a:r>
-          </a:p>
-          <a:p>
-            <a:pPr>
-              <a:defRPr sz="800" b="1">
-                <a:solidFill>
-                  <a:srgbClr val="5F6368"/>
-                </a:solidFill>
-                <a:latin typeface="Arial"/>
-              </a:defRPr>
-            </a:pPr>
-            <a:r>
-              <a:t>Observability &amp; Quality Sink</a:t>
             </a:r>
           </a:p>
           <a:p>
             <a:pPr>
               <a:spcBef>
-                <a:spcPts val="150"/>
+                <a:spcPts val="200"/>
               </a:spcBef>
-              <a:defRPr sz="800">
-                <a:solidFill>
-                  <a:srgbClr val="202124"/>
-                </a:solidFill>
-                <a:latin typeface="Arial"/>
-              </a:defRPr>
-            </a:pPr>
-            <a:r>
-              <a:t>• OpenTelemetry distributed spans</a:t>
+              <a:defRPr sz="850" b="1">
+                <a:solidFill>
+                  <a:srgbClr val="5F6368"/>
+                </a:solidFill>
+                <a:latin typeface="Arial"/>
+              </a:defRPr>
+            </a:pPr>
+            <a:r>
+              <a:t>Observability &amp; Audit Sink</a:t>
             </a:r>
           </a:p>
           <a:p>
             <a:pPr>
               <a:spcBef>
-                <a:spcPts val="150"/>
+                <a:spcPts val="300"/>
               </a:spcBef>
-              <a:defRPr sz="800">
+              <a:defRPr sz="850">
                 <a:solidFill>
                   <a:srgbClr val="202124"/>
                 </a:solidFill>
@@ -7121,7 +6905,11 @@
               </a:defRPr>
             </a:pPr>
             <a:r>
-              <a:t>• Nightly automated evaluation audits</a:t>
+              <a:t>OpenTelemetry distributed spans &amp;</a:t>
+            </a:r>
+            <a:br/>
+            <a:r>
+              <a:t>nightly continuous evaluation logs</a:t>
             </a:r>
           </a:p>
         </p:txBody>
@@ -7134,8 +6922,8 @@
         </p:nvCxnSpPr>
         <p:spPr>
           <a:xfrm>
-            <a:off x="5212080" y="4846320"/>
-            <a:ext cx="0" cy="566928"/>
+            <a:off x="5303520" y="4782312"/>
+            <a:ext cx="0" cy="539496"/>
           </a:xfrm>
           <a:prstGeom prst="line">
             <a:avLst/>
@@ -7170,8 +6958,8 @@
         </p:nvSpPr>
         <p:spPr>
           <a:xfrm>
-            <a:off x="4663440" y="5038344"/>
-            <a:ext cx="1554480" cy="219456"/>
+            <a:off x="5029200" y="4978908"/>
+            <a:ext cx="2011680" cy="219456"/>
           </a:xfrm>
           <a:prstGeom prst="rect">
             <a:avLst/>
@@ -7193,7 +6981,7 @@
               </a:defRPr>
             </a:pPr>
             <a:r>
-              <a:t>6. Query</a:t>
+              <a:t>6. Hybrid Dense+Lexical Query</a:t>
             </a:r>
           </a:p>
         </p:txBody>
@@ -7206,8 +6994,8 @@
         </p:nvCxnSpPr>
         <p:spPr>
           <a:xfrm flipV="1">
-            <a:off x="5943600" y="4846320"/>
-            <a:ext cx="0" cy="566928"/>
+            <a:off x="6126480" y="4782312"/>
+            <a:ext cx="0" cy="539496"/>
           </a:xfrm>
           <a:prstGeom prst="line">
             <a:avLst/>
@@ -7242,8 +7030,8 @@
         </p:nvSpPr>
         <p:spPr>
           <a:xfrm>
-            <a:off x="5440680" y="5202936"/>
-            <a:ext cx="1554480" cy="219456"/>
+            <a:off x="5852160" y="5125212"/>
+            <a:ext cx="2011680" cy="219456"/>
           </a:xfrm>
           <a:prstGeom prst="rect">
             <a:avLst/>
@@ -7265,7 +7053,7 @@
               </a:defRPr>
             </a:pPr>
             <a:r>
-              <a:t>7. Chunks</a:t>
+              <a:t>7. Top-K NIH Evidence Chunks</a:t>
             </a:r>
           </a:p>
         </p:txBody>
@@ -7278,8 +7066,8 @@
         </p:nvCxnSpPr>
         <p:spPr>
           <a:xfrm>
-            <a:off x="10149840" y="4846320"/>
-            <a:ext cx="0" cy="566928"/>
+            <a:off x="9875520" y="4782312"/>
+            <a:ext cx="0" cy="539496"/>
           </a:xfrm>
           <a:prstGeom prst="line">
             <a:avLst/>
@@ -7315,8 +7103,8 @@
         </p:nvSpPr>
         <p:spPr>
           <a:xfrm>
-            <a:off x="9692640" y="5129784"/>
-            <a:ext cx="1554480" cy="219456"/>
+            <a:off x="9646920" y="5052060"/>
+            <a:ext cx="2011680" cy="219456"/>
           </a:xfrm>
           <a:prstGeom prst="rect">
             <a:avLst/>
@@ -7338,7 +7126,7 @@
               </a:defRPr>
             </a:pPr>
             <a:r>
-              <a:t>Telemetry</a:t>
+              <a:t>Async OTel Traces &amp; Cost Logs</a:t>
             </a:r>
           </a:p>
         </p:txBody>

</xml_diff>